<commit_message>
Harden release audit findings
</commit_message>
<xml_diff>
--- a/deliverables/DEPO_Functional_Architecture_and_Deployment.pptx
+++ b/deliverables/DEPO_Functional_Architecture_and_Deployment.pptx
@@ -2,32 +2,32 @@
 <file path=ppt/presentation.xml><?xml version="1.0" encoding="utf-8"?>
 <p:presentation xmlns:p="http://schemas.openxmlformats.org/presentationml/2006/main">
   <p:sldMasterIdLst>
-    <p:sldMasterId xmlns:r="http://schemas.openxmlformats.org/officeDocument/2006/relationships" id="2147483648" r:id="R64fc490b1f6844ca"/>
+    <p:sldMasterId xmlns:r="http://schemas.openxmlformats.org/officeDocument/2006/relationships" id="2147483648" r:id="R02225e7a155b4e44"/>
   </p:sldMasterIdLst>
   <p:notesMasterIdLst>
-    <p:notesMasterId xmlns:r="http://schemas.openxmlformats.org/officeDocument/2006/relationships" r:id="R95df761aba3d4500"/>
+    <p:notesMasterId xmlns:r="http://schemas.openxmlformats.org/officeDocument/2006/relationships" r:id="R5129beb429f845e1"/>
   </p:notesMasterIdLst>
   <p:sldIdLst>
-    <p:sldId xmlns:r="http://schemas.openxmlformats.org/officeDocument/2006/relationships" id="256" r:id="R608f71fb96674ba2"/>
-    <p:sldId xmlns:r="http://schemas.openxmlformats.org/officeDocument/2006/relationships" id="257" r:id="R674b8bf57ba745fd"/>
-    <p:sldId xmlns:r="http://schemas.openxmlformats.org/officeDocument/2006/relationships" id="258" r:id="R4a353bed14e84b7e"/>
-    <p:sldId xmlns:r="http://schemas.openxmlformats.org/officeDocument/2006/relationships" id="259" r:id="Rd89c027ebd8f4721"/>
-    <p:sldId xmlns:r="http://schemas.openxmlformats.org/officeDocument/2006/relationships" id="260" r:id="Re4fded437e5b4729"/>
-    <p:sldId xmlns:r="http://schemas.openxmlformats.org/officeDocument/2006/relationships" id="261" r:id="R2c156982abce4485"/>
-    <p:sldId xmlns:r="http://schemas.openxmlformats.org/officeDocument/2006/relationships" id="262" r:id="Rc2a08428246e4c84"/>
-    <p:sldId xmlns:r="http://schemas.openxmlformats.org/officeDocument/2006/relationships" id="263" r:id="Rf24727264bf84e87"/>
-    <p:sldId xmlns:r="http://schemas.openxmlformats.org/officeDocument/2006/relationships" id="264" r:id="R09d716183d8c4865"/>
-    <p:sldId xmlns:r="http://schemas.openxmlformats.org/officeDocument/2006/relationships" id="265" r:id="Rb68c66fd03584fa0"/>
-    <p:sldId xmlns:r="http://schemas.openxmlformats.org/officeDocument/2006/relationships" id="266" r:id="Rdc19a50f76c74947"/>
-    <p:sldId xmlns:r="http://schemas.openxmlformats.org/officeDocument/2006/relationships" id="267" r:id="Rda3bc57860c54a7a"/>
-    <p:sldId xmlns:r="http://schemas.openxmlformats.org/officeDocument/2006/relationships" id="268" r:id="R21787f3f80d64caa"/>
-    <p:sldId xmlns:r="http://schemas.openxmlformats.org/officeDocument/2006/relationships" id="269" r:id="R4721f5b7d3d04f46"/>
-    <p:sldId xmlns:r="http://schemas.openxmlformats.org/officeDocument/2006/relationships" id="270" r:id="Rffd9d821e3824c08"/>
-    <p:sldId xmlns:r="http://schemas.openxmlformats.org/officeDocument/2006/relationships" id="271" r:id="R66160b80b3464718"/>
-    <p:sldId xmlns:r="http://schemas.openxmlformats.org/officeDocument/2006/relationships" id="272" r:id="R18142af478484164"/>
-    <p:sldId xmlns:r="http://schemas.openxmlformats.org/officeDocument/2006/relationships" id="273" r:id="R938b0821f343422f"/>
-    <p:sldId xmlns:r="http://schemas.openxmlformats.org/officeDocument/2006/relationships" id="274" r:id="Ra137640229604631"/>
-    <p:sldId xmlns:r="http://schemas.openxmlformats.org/officeDocument/2006/relationships" id="275" r:id="R456dcb5a143642e4"/>
+    <p:sldId xmlns:r="http://schemas.openxmlformats.org/officeDocument/2006/relationships" id="256" r:id="R3e930c3663224073"/>
+    <p:sldId xmlns:r="http://schemas.openxmlformats.org/officeDocument/2006/relationships" id="257" r:id="R3b5228f796de476d"/>
+    <p:sldId xmlns:r="http://schemas.openxmlformats.org/officeDocument/2006/relationships" id="258" r:id="Rc92c9c2688fb4a50"/>
+    <p:sldId xmlns:r="http://schemas.openxmlformats.org/officeDocument/2006/relationships" id="259" r:id="Rc9ab709b4d2643a1"/>
+    <p:sldId xmlns:r="http://schemas.openxmlformats.org/officeDocument/2006/relationships" id="260" r:id="R73e140c2bbfc4a68"/>
+    <p:sldId xmlns:r="http://schemas.openxmlformats.org/officeDocument/2006/relationships" id="261" r:id="R8c01aae6a808497f"/>
+    <p:sldId xmlns:r="http://schemas.openxmlformats.org/officeDocument/2006/relationships" id="262" r:id="R013136a215f64908"/>
+    <p:sldId xmlns:r="http://schemas.openxmlformats.org/officeDocument/2006/relationships" id="263" r:id="R7d7bb1410a5048d0"/>
+    <p:sldId xmlns:r="http://schemas.openxmlformats.org/officeDocument/2006/relationships" id="264" r:id="Rd817fcf0c6f44ab6"/>
+    <p:sldId xmlns:r="http://schemas.openxmlformats.org/officeDocument/2006/relationships" id="265" r:id="R9f1b4e3dfc4d4195"/>
+    <p:sldId xmlns:r="http://schemas.openxmlformats.org/officeDocument/2006/relationships" id="266" r:id="R7ae997a9a8bd40a0"/>
+    <p:sldId xmlns:r="http://schemas.openxmlformats.org/officeDocument/2006/relationships" id="267" r:id="R3a344b0edd984dd4"/>
+    <p:sldId xmlns:r="http://schemas.openxmlformats.org/officeDocument/2006/relationships" id="268" r:id="Ra50f21c243ec42b0"/>
+    <p:sldId xmlns:r="http://schemas.openxmlformats.org/officeDocument/2006/relationships" id="269" r:id="Rfd87d4c5a4484444"/>
+    <p:sldId xmlns:r="http://schemas.openxmlformats.org/officeDocument/2006/relationships" id="270" r:id="Rf2d41ab471dd44d3"/>
+    <p:sldId xmlns:r="http://schemas.openxmlformats.org/officeDocument/2006/relationships" id="271" r:id="Radb913f1fb824e51"/>
+    <p:sldId xmlns:r="http://schemas.openxmlformats.org/officeDocument/2006/relationships" id="272" r:id="Rae7a18b513504db3"/>
+    <p:sldId xmlns:r="http://schemas.openxmlformats.org/officeDocument/2006/relationships" id="273" r:id="Rff6a630f03564345"/>
+    <p:sldId xmlns:r="http://schemas.openxmlformats.org/officeDocument/2006/relationships" id="274" r:id="R7ee1d91e2561441e"/>
+    <p:sldId xmlns:r="http://schemas.openxmlformats.org/officeDocument/2006/relationships" id="275" r:id="Rb144d6af710248f5"/>
   </p:sldIdLst>
   <p:sldSz cx="12192000" cy="6858000"/>
   <p:notesSz cx="6858000" cy="9144000"/>
@@ -461,17 +461,17 @@
           <a:lstStyle xmlns:a="http://schemas.openxmlformats.org/drawingml/2006/main"/>
           <a:p xmlns:a="http://schemas.openxmlformats.org/drawingml/2006/main">
             <a:r>
-              <a:t>Implementation baseline: commit 545d43a, 22 September 2026.</a:t>
-            </a:r>
-          </a:p>
-          <a:p xmlns:a="http://schemas.openxmlformats.org/drawingml/2006/main">
-            <a:r>
-              <a:t>https://github.com/dparitosh/PMem/blob/545d43a/infra/deployment/README.md</a:t>
-            </a:r>
-          </a:p>
-          <a:p xmlns:a="http://schemas.openxmlformats.org/drawingml/2006/main">
-            <a:r>
-              <a:t>https://github.com/dparitosh/PMem/blob/545d43a/docs/architecture/SERVICE_CATALOG.md</a:t>
+              <a:t>Implementation baseline: current release branch, 23 September 2026.</a:t>
+            </a:r>
+          </a:p>
+          <a:p xmlns:a="http://schemas.openxmlformats.org/drawingml/2006/main">
+            <a:r>
+              <a:t>https://github.com/dparitosh/PMem/blob/codex/semantic-bridge-release/INSTALLATION.md</a:t>
+            </a:r>
+          </a:p>
+          <a:p xmlns:a="http://schemas.openxmlformats.org/drawingml/2006/main">
+            <a:r>
+              <a:t>https://github.com/dparitosh/PMem/blob/codex/semantic-bridge-release/docs/architecture/SERVICE_CATALOG.md</a:t>
             </a:r>
           </a:p>
         </p:txBody>
@@ -541,17 +541,17 @@
           <a:lstStyle xmlns:a="http://schemas.openxmlformats.org/drawingml/2006/main"/>
           <a:p xmlns:a="http://schemas.openxmlformats.org/drawingml/2006/main">
             <a:r>
-              <a:t>Implementation baseline: commit 545d43a, 22 September 2026.</a:t>
-            </a:r>
-          </a:p>
-          <a:p xmlns:a="http://schemas.openxmlformats.org/drawingml/2006/main">
-            <a:r>
-              <a:t>https://github.com/dparitosh/PMem/blob/545d43a/backend/data_pipeline_service/router.py</a:t>
-            </a:r>
-          </a:p>
-          <a:p xmlns:a="http://schemas.openxmlformats.org/drawingml/2006/main">
-            <a:r>
-              <a:t>https://github.com/dparitosh/PMem/blob/545d43a/backend/data_pipeline_service/runner.py</a:t>
+              <a:t>Implementation baseline: current release branch, 23 September 2026.</a:t>
+            </a:r>
+          </a:p>
+          <a:p xmlns:a="http://schemas.openxmlformats.org/drawingml/2006/main">
+            <a:r>
+              <a:t>https://github.com/dparitosh/PMem/blob/codex/semantic-bridge-release/backend/data_pipeline_service/router.py</a:t>
+            </a:r>
+          </a:p>
+          <a:p xmlns:a="http://schemas.openxmlformats.org/drawingml/2006/main">
+            <a:r>
+              <a:t>https://github.com/dparitosh/PMem/blob/codex/semantic-bridge-release/backend/data_pipeline_service/runner.py</a:t>
             </a:r>
           </a:p>
         </p:txBody>
@@ -621,22 +621,22 @@
           <a:lstStyle xmlns:a="http://schemas.openxmlformats.org/drawingml/2006/main"/>
           <a:p xmlns:a="http://schemas.openxmlformats.org/drawingml/2006/main">
             <a:r>
-              <a:t>Implementation baseline: commit 545d43a, 22 September 2026.</a:t>
-            </a:r>
-          </a:p>
-          <a:p xmlns:a="http://schemas.openxmlformats.org/drawingml/2006/main">
-            <a:r>
-              <a:t>https://github.com/dparitosh/PMem/blob/545d43a/backend/data_product_service/router.py</a:t>
-            </a:r>
-          </a:p>
-          <a:p xmlns:a="http://schemas.openxmlformats.org/drawingml/2006/main">
-            <a:r>
-              <a:t>https://github.com/dparitosh/PMem/blob/545d43a/backend/data_product_service/worker.py</a:t>
-            </a:r>
-          </a:p>
-          <a:p xmlns:a="http://schemas.openxmlformats.org/drawingml/2006/main">
-            <a:r>
-              <a:t>https://github.com/dparitosh/PMem/blob/545d43a/backend/data_catalog_service/router.py</a:t>
+              <a:t>Implementation baseline: current release branch, 23 September 2026.</a:t>
+            </a:r>
+          </a:p>
+          <a:p xmlns:a="http://schemas.openxmlformats.org/drawingml/2006/main">
+            <a:r>
+              <a:t>https://github.com/dparitosh/PMem/blob/codex/semantic-bridge-release/backend/data_product_service/router.py</a:t>
+            </a:r>
+          </a:p>
+          <a:p xmlns:a="http://schemas.openxmlformats.org/drawingml/2006/main">
+            <a:r>
+              <a:t>https://github.com/dparitosh/PMem/blob/codex/semantic-bridge-release/backend/data_product_service/worker.py</a:t>
+            </a:r>
+          </a:p>
+          <a:p xmlns:a="http://schemas.openxmlformats.org/drawingml/2006/main">
+            <a:r>
+              <a:t>https://github.com/dparitosh/PMem/blob/codex/semantic-bridge-release/backend/data_catalog_service/router.py</a:t>
             </a:r>
           </a:p>
         </p:txBody>
@@ -706,32 +706,32 @@
           <a:lstStyle xmlns:a="http://schemas.openxmlformats.org/drawingml/2006/main"/>
           <a:p xmlns:a="http://schemas.openxmlformats.org/drawingml/2006/main">
             <a:r>
-              <a:t>Implementation baseline: commit 545d43a, 22 September 2026.</a:t>
-            </a:r>
-          </a:p>
-          <a:p xmlns:a="http://schemas.openxmlformats.org/drawingml/2006/main">
-            <a:r>
-              <a:t>https://github.com/dparitosh/PMem/blob/545d43a/backend/agentic_service/companion.py</a:t>
-            </a:r>
-          </a:p>
-          <a:p xmlns:a="http://schemas.openxmlformats.org/drawingml/2006/main">
-            <a:r>
-              <a:t>https://github.com/dparitosh/PMem/blob/545d43a/backend/agentic_service/router.py</a:t>
-            </a:r>
-          </a:p>
-          <a:p xmlns:a="http://schemas.openxmlformats.org/drawingml/2006/main">
-            <a:r>
-              <a:t>https://github.com/dparitosh/PMem/blob/545d43a/backend/agentic_service/configuration.py</a:t>
-            </a:r>
-          </a:p>
-          <a:p xmlns:a="http://schemas.openxmlformats.org/drawingml/2006/main">
-            <a:r>
-              <a:t>https://github.com/dparitosh/PMem/blob/545d43a/backend/graph_service/sparql_router.py</a:t>
-            </a:r>
-          </a:p>
-          <a:p xmlns:a="http://schemas.openxmlformats.org/drawingml/2006/main">
-            <a:r>
-              <a:t>https://github.com/dparitosh/PMem/blob/545d43a/backend/graph_service/federation_router.py</a:t>
+              <a:t>Implementation baseline: current release branch, 23 September 2026.</a:t>
+            </a:r>
+          </a:p>
+          <a:p xmlns:a="http://schemas.openxmlformats.org/drawingml/2006/main">
+            <a:r>
+              <a:t>https://github.com/dparitosh/PMem/blob/codex/semantic-bridge-release/backend/agentic_service/companion.py</a:t>
+            </a:r>
+          </a:p>
+          <a:p xmlns:a="http://schemas.openxmlformats.org/drawingml/2006/main">
+            <a:r>
+              <a:t>https://github.com/dparitosh/PMem/blob/codex/semantic-bridge-release/backend/agentic_service/router.py</a:t>
+            </a:r>
+          </a:p>
+          <a:p xmlns:a="http://schemas.openxmlformats.org/drawingml/2006/main">
+            <a:r>
+              <a:t>https://github.com/dparitosh/PMem/blob/codex/semantic-bridge-release/backend/agentic_service/configuration.py</a:t>
+            </a:r>
+          </a:p>
+          <a:p xmlns:a="http://schemas.openxmlformats.org/drawingml/2006/main">
+            <a:r>
+              <a:t>https://github.com/dparitosh/PMem/blob/codex/semantic-bridge-release/backend/graph_service/sparql_router.py</a:t>
+            </a:r>
+          </a:p>
+          <a:p xmlns:a="http://schemas.openxmlformats.org/drawingml/2006/main">
+            <a:r>
+              <a:t>https://github.com/dparitosh/PMem/blob/codex/semantic-bridge-release/backend/graph_service/federation_router.py</a:t>
             </a:r>
           </a:p>
         </p:txBody>
@@ -801,27 +801,27 @@
           <a:lstStyle xmlns:a="http://schemas.openxmlformats.org/drawingml/2006/main"/>
           <a:p xmlns:a="http://schemas.openxmlformats.org/drawingml/2006/main">
             <a:r>
-              <a:t>Implementation baseline: commit 545d43a, 22 September 2026.</a:t>
-            </a:r>
-          </a:p>
-          <a:p xmlns:a="http://schemas.openxmlformats.org/drawingml/2006/main">
-            <a:r>
-              <a:t>https://github.com/dparitosh/PMem/blob/545d43a/frontend/src/Components/ontology/SemanticBridgeJobs.js</a:t>
-            </a:r>
-          </a:p>
-          <a:p xmlns:a="http://schemas.openxmlformats.org/drawingml/2006/main">
-            <a:r>
-              <a:t>https://github.com/dparitosh/PMem/blob/545d43a/frontend/src/pages/DataFlowPage.js</a:t>
-            </a:r>
-          </a:p>
-          <a:p xmlns:a="http://schemas.openxmlformats.org/drawingml/2006/main">
-            <a:r>
-              <a:t>https://github.com/dparitosh/PMem/blob/545d43a/frontend/src/pages/GraphExplorerPage.js</a:t>
-            </a:r>
-          </a:p>
-          <a:p xmlns:a="http://schemas.openxmlformats.org/drawingml/2006/main">
-            <a:r>
-              <a:t>https://github.com/dparitosh/PMem/blob/545d43a/frontend/src/Components/Chatbot.js</a:t>
+              <a:t>Implementation baseline: current release branch, 23 September 2026.</a:t>
+            </a:r>
+          </a:p>
+          <a:p xmlns:a="http://schemas.openxmlformats.org/drawingml/2006/main">
+            <a:r>
+              <a:t>https://github.com/dparitosh/PMem/blob/codex/semantic-bridge-release/frontend/src/Components/ontology/SemanticBridgeJobs.js</a:t>
+            </a:r>
+          </a:p>
+          <a:p xmlns:a="http://schemas.openxmlformats.org/drawingml/2006/main">
+            <a:r>
+              <a:t>https://github.com/dparitosh/PMem/blob/codex/semantic-bridge-release/frontend/src/pages/DataFlowPage.js</a:t>
+            </a:r>
+          </a:p>
+          <a:p xmlns:a="http://schemas.openxmlformats.org/drawingml/2006/main">
+            <a:r>
+              <a:t>https://github.com/dparitosh/PMem/blob/codex/semantic-bridge-release/frontend/src/pages/GraphExplorerPage.js</a:t>
+            </a:r>
+          </a:p>
+          <a:p xmlns:a="http://schemas.openxmlformats.org/drawingml/2006/main">
+            <a:r>
+              <a:t>https://github.com/dparitosh/PMem/blob/codex/semantic-bridge-release/frontend/src/Components/Chatbot.js</a:t>
             </a:r>
           </a:p>
         </p:txBody>
@@ -891,27 +891,27 @@
           <a:lstStyle xmlns:a="http://schemas.openxmlformats.org/drawingml/2006/main"/>
           <a:p xmlns:a="http://schemas.openxmlformats.org/drawingml/2006/main">
             <a:r>
-              <a:t>Implementation baseline: commit 545d43a, 22 September 2026.</a:t>
-            </a:r>
-          </a:p>
-          <a:p xmlns:a="http://schemas.openxmlformats.org/drawingml/2006/main">
-            <a:r>
-              <a:t>https://github.com/dparitosh/PMem/blob/545d43a/infra/deployment/README.md</a:t>
-            </a:r>
-          </a:p>
-          <a:p xmlns:a="http://schemas.openxmlformats.org/drawingml/2006/main">
-            <a:r>
-              <a:t>https://github.com/dparitosh/PMem/blob/545d43a/infra/neo4j/README.md</a:t>
-            </a:r>
-          </a:p>
-          <a:p xmlns:a="http://schemas.openxmlformats.org/drawingml/2006/main">
-            <a:r>
-              <a:t>https://github.com/dparitosh/PMem/blob/545d43a/infra/postgres/README.md</a:t>
-            </a:r>
-          </a:p>
-          <a:p xmlns:a="http://schemas.openxmlformats.org/drawingml/2006/main">
-            <a:r>
-              <a:t>https://github.com/dparitosh/PMem/blob/545d43a/infra/spark/README.md</a:t>
+              <a:t>Implementation baseline: current release branch, 23 September 2026.</a:t>
+            </a:r>
+          </a:p>
+          <a:p xmlns:a="http://schemas.openxmlformats.org/drawingml/2006/main">
+            <a:r>
+              <a:t>https://github.com/dparitosh/PMem/blob/codex/semantic-bridge-release/INSTALLATION.md</a:t>
+            </a:r>
+          </a:p>
+          <a:p xmlns:a="http://schemas.openxmlformats.org/drawingml/2006/main">
+            <a:r>
+              <a:t>https://github.com/dparitosh/PMem/blob/codex/semantic-bridge-release/INSTALLATION.md</a:t>
+            </a:r>
+          </a:p>
+          <a:p xmlns:a="http://schemas.openxmlformats.org/drawingml/2006/main">
+            <a:r>
+              <a:t>https://github.com/dparitosh/PMem/blob/codex/semantic-bridge-release/INSTALLATION.md</a:t>
+            </a:r>
+          </a:p>
+          <a:p xmlns:a="http://schemas.openxmlformats.org/drawingml/2006/main">
+            <a:r>
+              <a:t>https://github.com/dparitosh/PMem/blob/codex/semantic-bridge-release/INSTALLATION.md</a:t>
             </a:r>
           </a:p>
         </p:txBody>
@@ -981,22 +981,22 @@
           <a:lstStyle xmlns:a="http://schemas.openxmlformats.org/drawingml/2006/main"/>
           <a:p xmlns:a="http://schemas.openxmlformats.org/drawingml/2006/main">
             <a:r>
-              <a:t>Implementation baseline: commit 545d43a, 22 September 2026.</a:t>
-            </a:r>
-          </a:p>
-          <a:p xmlns:a="http://schemas.openxmlformats.org/drawingml/2006/main">
-            <a:r>
-              <a:t>https://github.com/dparitosh/PMem/blob/545d43a/infra/deployment/README.md</a:t>
-            </a:r>
-          </a:p>
-          <a:p xmlns:a="http://schemas.openxmlformats.org/drawingml/2006/main">
-            <a:r>
-              <a:t>https://github.com/dparitosh/PMem/blob/545d43a/infra/windows/install-depo.ps1</a:t>
-            </a:r>
-          </a:p>
-          <a:p xmlns:a="http://schemas.openxmlformats.org/drawingml/2006/main">
-            <a:r>
-              <a:t>https://github.com/dparitosh/PMem/blob/545d43a/infra/windows/initialize-depo-schema.ps1</a:t>
+              <a:t>Implementation baseline: current release branch, 23 September 2026.</a:t>
+            </a:r>
+          </a:p>
+          <a:p xmlns:a="http://schemas.openxmlformats.org/drawingml/2006/main">
+            <a:r>
+              <a:t>https://github.com/dparitosh/PMem/blob/codex/semantic-bridge-release/INSTALLATION.md</a:t>
+            </a:r>
+          </a:p>
+          <a:p xmlns:a="http://schemas.openxmlformats.org/drawingml/2006/main">
+            <a:r>
+              <a:t>https://github.com/dparitosh/PMem/blob/codex/semantic-bridge-release/infra/windows/install-depo-windows.ps1</a:t>
+            </a:r>
+          </a:p>
+          <a:p xmlns:a="http://schemas.openxmlformats.org/drawingml/2006/main">
+            <a:r>
+              <a:t>https://github.com/dparitosh/PMem/blob/codex/semantic-bridge-release/infra/windows/initialize-depo-schema.ps1</a:t>
             </a:r>
           </a:p>
         </p:txBody>
@@ -1066,22 +1066,22 @@
           <a:lstStyle xmlns:a="http://schemas.openxmlformats.org/drawingml/2006/main"/>
           <a:p xmlns:a="http://schemas.openxmlformats.org/drawingml/2006/main">
             <a:r>
-              <a:t>Implementation baseline: commit 545d43a, 22 September 2026.</a:t>
-            </a:r>
-          </a:p>
-          <a:p xmlns:a="http://schemas.openxmlformats.org/drawingml/2006/main">
-            <a:r>
-              <a:t>https://github.com/dparitosh/PMem/blob/545d43a/backend/postgres_migrations.py</a:t>
-            </a:r>
-          </a:p>
-          <a:p xmlns:a="http://schemas.openxmlformats.org/drawingml/2006/main">
-            <a:r>
-              <a:t>https://github.com/dparitosh/PMem/blob/545d43a/backend/depo_platform/database_setup.py</a:t>
-            </a:r>
-          </a:p>
-          <a:p xmlns:a="http://schemas.openxmlformats.org/drawingml/2006/main">
-            <a:r>
-              <a:t>https://github.com/dparitosh/PMem/blob/545d43a/infra/postgres/SCHEMA.md</a:t>
+              <a:t>Implementation baseline: current release branch, 23 September 2026.</a:t>
+            </a:r>
+          </a:p>
+          <a:p xmlns:a="http://schemas.openxmlformats.org/drawingml/2006/main">
+            <a:r>
+              <a:t>https://github.com/dparitosh/PMem/blob/codex/semantic-bridge-release/backend/postgres_migrations.py</a:t>
+            </a:r>
+          </a:p>
+          <a:p xmlns:a="http://schemas.openxmlformats.org/drawingml/2006/main">
+            <a:r>
+              <a:t>https://github.com/dparitosh/PMem/blob/codex/semantic-bridge-release/backend/depo_platform/database_setup.py</a:t>
+            </a:r>
+          </a:p>
+          <a:p xmlns:a="http://schemas.openxmlformats.org/drawingml/2006/main">
+            <a:r>
+              <a:t>https://github.com/dparitosh/PMem/blob/codex/semantic-bridge-release/infra/postgres/SCHEMA.md</a:t>
             </a:r>
           </a:p>
         </p:txBody>
@@ -1151,27 +1151,27 @@
           <a:lstStyle xmlns:a="http://schemas.openxmlformats.org/drawingml/2006/main"/>
           <a:p xmlns:a="http://schemas.openxmlformats.org/drawingml/2006/main">
             <a:r>
-              <a:t>Implementation baseline: commit 545d43a, 22 September 2026.</a:t>
-            </a:r>
-          </a:p>
-          <a:p xmlns:a="http://schemas.openxmlformats.org/drawingml/2006/main">
-            <a:r>
-              <a:t>https://github.com/dparitosh/PMem/blob/545d43a/backend/depo_platform/authorization.py</a:t>
-            </a:r>
-          </a:p>
-          <a:p xmlns:a="http://schemas.openxmlformats.org/drawingml/2006/main">
-            <a:r>
-              <a:t>https://github.com/dparitosh/PMem/blob/545d43a/backend/agentic_service/configuration.py</a:t>
-            </a:r>
-          </a:p>
-          <a:p xmlns:a="http://schemas.openxmlformats.org/drawingml/2006/main">
-            <a:r>
-              <a:t>https://github.com/dparitosh/PMem/blob/545d43a/infra/deployment/test-depo-deployment.ps1</a:t>
-            </a:r>
-          </a:p>
-          <a:p xmlns:a="http://schemas.openxmlformats.org/drawingml/2006/main">
-            <a:r>
-              <a:t>https://github.com/dparitosh/PMem/blob/545d43a/config/README.md</a:t>
+              <a:t>Implementation baseline: current release branch, 23 September 2026.</a:t>
+            </a:r>
+          </a:p>
+          <a:p xmlns:a="http://schemas.openxmlformats.org/drawingml/2006/main">
+            <a:r>
+              <a:t>https://github.com/dparitosh/PMem/blob/codex/semantic-bridge-release/backend/depo_platform/authorization.py</a:t>
+            </a:r>
+          </a:p>
+          <a:p xmlns:a="http://schemas.openxmlformats.org/drawingml/2006/main">
+            <a:r>
+              <a:t>https://github.com/dparitosh/PMem/blob/codex/semantic-bridge-release/backend/agentic_service/configuration.py</a:t>
+            </a:r>
+          </a:p>
+          <a:p xmlns:a="http://schemas.openxmlformats.org/drawingml/2006/main">
+            <a:r>
+              <a:t>https://github.com/dparitosh/PMem/blob/codex/semantic-bridge-release/infra/deployment/test-depo-deployment.ps1</a:t>
+            </a:r>
+          </a:p>
+          <a:p xmlns:a="http://schemas.openxmlformats.org/drawingml/2006/main">
+            <a:r>
+              <a:t>https://github.com/dparitosh/PMem/blob/codex/semantic-bridge-release/config/README.md</a:t>
             </a:r>
           </a:p>
         </p:txBody>
@@ -1241,17 +1241,17 @@
           <a:lstStyle xmlns:a="http://schemas.openxmlformats.org/drawingml/2006/main"/>
           <a:p xmlns:a="http://schemas.openxmlformats.org/drawingml/2006/main">
             <a:r>
-              <a:t>Implementation baseline: commit 545d43a, 22 September 2026.</a:t>
-            </a:r>
-          </a:p>
-          <a:p xmlns:a="http://schemas.openxmlformats.org/drawingml/2006/main">
-            <a:r>
-              <a:t>https://github.com/dparitosh/PMem/blob/545d43a/infra/deployment/CUSTOMER_RELEASE.md</a:t>
-            </a:r>
-          </a:p>
-          <a:p xmlns:a="http://schemas.openxmlformats.org/drawingml/2006/main">
-            <a:r>
-              <a:t>https://github.com/dparitosh/PMem/blob/545d43a/docs/INSTALLATION_REVIEW.md</a:t>
+              <a:t>Implementation baseline: current release branch, 23 September 2026.</a:t>
+            </a:r>
+          </a:p>
+          <a:p xmlns:a="http://schemas.openxmlformats.org/drawingml/2006/main">
+            <a:r>
+              <a:t>https://github.com/dparitosh/PMem/blob/codex/semantic-bridge-release/infra/deployment/CUSTOMER_RELEASE.md</a:t>
+            </a:r>
+          </a:p>
+          <a:p xmlns:a="http://schemas.openxmlformats.org/drawingml/2006/main">
+            <a:r>
+              <a:t>https://github.com/dparitosh/PMem/blob/codex/semantic-bridge-release/docs/INSTALLATION_REVIEW.md</a:t>
             </a:r>
           </a:p>
         </p:txBody>
@@ -1321,32 +1321,32 @@
           <a:lstStyle xmlns:a="http://schemas.openxmlformats.org/drawingml/2006/main"/>
           <a:p xmlns:a="http://schemas.openxmlformats.org/drawingml/2006/main">
             <a:r>
-              <a:t>Implementation baseline: commit 545d43a, 22 September 2026.</a:t>
-            </a:r>
-          </a:p>
-          <a:p xmlns:a="http://schemas.openxmlformats.org/drawingml/2006/main">
-            <a:r>
-              <a:t>https://github.com/dparitosh/PMem/blob/545d43a/backend/graph_service/router.py</a:t>
-            </a:r>
-          </a:p>
-          <a:p xmlns:a="http://schemas.openxmlformats.org/drawingml/2006/main">
-            <a:r>
-              <a:t>https://github.com/dparitosh/PMem/blob/545d43a/backend/data_pipeline_service/handlers.py</a:t>
-            </a:r>
-          </a:p>
-          <a:p xmlns:a="http://schemas.openxmlformats.org/drawingml/2006/main">
-            <a:r>
-              <a:t>https://github.com/dparitosh/PMem/blob/545d43a/backend/data_pipeline_service/speed_router.py</a:t>
-            </a:r>
-          </a:p>
-          <a:p xmlns:a="http://schemas.openxmlformats.org/drawingml/2006/main">
-            <a:r>
-              <a:t>https://github.com/dparitosh/PMem/blob/545d43a/infra/deployment/CUSTOMER_RELEASE.md</a:t>
-            </a:r>
-          </a:p>
-          <a:p xmlns:a="http://schemas.openxmlformats.org/drawingml/2006/main">
-            <a:r>
-              <a:t>https://github.com/dparitosh/PMem/blob/545d43a/docs/ACCELERATED_DELIVERY_TRACKER.md</a:t>
+              <a:t>Implementation baseline: current release branch, 23 September 2026.</a:t>
+            </a:r>
+          </a:p>
+          <a:p xmlns:a="http://schemas.openxmlformats.org/drawingml/2006/main">
+            <a:r>
+              <a:t>https://github.com/dparitosh/PMem/blob/codex/semantic-bridge-release/backend/graph_service/router.py</a:t>
+            </a:r>
+          </a:p>
+          <a:p xmlns:a="http://schemas.openxmlformats.org/drawingml/2006/main">
+            <a:r>
+              <a:t>https://github.com/dparitosh/PMem/blob/codex/semantic-bridge-release/backend/data_pipeline_service/handlers.py</a:t>
+            </a:r>
+          </a:p>
+          <a:p xmlns:a="http://schemas.openxmlformats.org/drawingml/2006/main">
+            <a:r>
+              <a:t>https://github.com/dparitosh/PMem/blob/codex/semantic-bridge-release/backend/data_pipeline_service/speed_router.py</a:t>
+            </a:r>
+          </a:p>
+          <a:p xmlns:a="http://schemas.openxmlformats.org/drawingml/2006/main">
+            <a:r>
+              <a:t>https://github.com/dparitosh/PMem/blob/codex/semantic-bridge-release/infra/deployment/CUSTOMER_RELEASE.md</a:t>
+            </a:r>
+          </a:p>
+          <a:p xmlns:a="http://schemas.openxmlformats.org/drawingml/2006/main">
+            <a:r>
+              <a:t>https://github.com/dparitosh/PMem/blob/codex/semantic-bridge-release/docs/ACCELERATED_DELIVERY_TRACKER.md</a:t>
             </a:r>
           </a:p>
         </p:txBody>
@@ -1416,22 +1416,22 @@
           <a:lstStyle xmlns:a="http://schemas.openxmlformats.org/drawingml/2006/main"/>
           <a:p xmlns:a="http://schemas.openxmlformats.org/drawingml/2006/main">
             <a:r>
-              <a:t>Implementation baseline: commit 545d43a, 22 September 2026.</a:t>
-            </a:r>
-          </a:p>
-          <a:p xmlns:a="http://schemas.openxmlformats.org/drawingml/2006/main">
-            <a:r>
-              <a:t>https://github.com/dparitosh/PMem/blob/545d43a/backend/agentic_service/bridge_jobs.py</a:t>
-            </a:r>
-          </a:p>
-          <a:p xmlns:a="http://schemas.openxmlformats.org/drawingml/2006/main">
-            <a:r>
-              <a:t>https://github.com/dparitosh/PMem/blob/545d43a/backend/data_pipeline_service/router.py</a:t>
-            </a:r>
-          </a:p>
-          <a:p xmlns:a="http://schemas.openxmlformats.org/drawingml/2006/main">
-            <a:r>
-              <a:t>https://github.com/dparitosh/PMem/blob/545d43a/backend/data_product_service/router.py</a:t>
+              <a:t>Implementation baseline: current release branch, 23 September 2026.</a:t>
+            </a:r>
+          </a:p>
+          <a:p xmlns:a="http://schemas.openxmlformats.org/drawingml/2006/main">
+            <a:r>
+              <a:t>https://github.com/dparitosh/PMem/blob/codex/semantic-bridge-release/backend/agentic_service/bridge_jobs.py</a:t>
+            </a:r>
+          </a:p>
+          <a:p xmlns:a="http://schemas.openxmlformats.org/drawingml/2006/main">
+            <a:r>
+              <a:t>https://github.com/dparitosh/PMem/blob/codex/semantic-bridge-release/backend/data_pipeline_service/router.py</a:t>
+            </a:r>
+          </a:p>
+          <a:p xmlns:a="http://schemas.openxmlformats.org/drawingml/2006/main">
+            <a:r>
+              <a:t>https://github.com/dparitosh/PMem/blob/codex/semantic-bridge-release/backend/data_product_service/router.py</a:t>
             </a:r>
           </a:p>
         </p:txBody>
@@ -1501,32 +1501,32 @@
           <a:lstStyle xmlns:a="http://schemas.openxmlformats.org/drawingml/2006/main"/>
           <a:p xmlns:a="http://schemas.openxmlformats.org/drawingml/2006/main">
             <a:r>
-              <a:t>Implementation baseline: commit 545d43a, 22 September 2026.</a:t>
-            </a:r>
-          </a:p>
-          <a:p xmlns:a="http://schemas.openxmlformats.org/drawingml/2006/main">
-            <a:r>
-              <a:t>https://github.com/dparitosh/PMem/blob/545d43a/infra/deployment/services.json</a:t>
-            </a:r>
-          </a:p>
-          <a:p xmlns:a="http://schemas.openxmlformats.org/drawingml/2006/main">
-            <a:r>
-              <a:t>https://github.com/dparitosh/PMem/blob/545d43a/infra/deployment/README.md</a:t>
-            </a:r>
-          </a:p>
-          <a:p xmlns:a="http://schemas.openxmlformats.org/drawingml/2006/main">
-            <a:r>
-              <a:t>https://github.com/dparitosh/PMem/blob/545d43a/infra/postgres/SCHEMA.md</a:t>
-            </a:r>
-          </a:p>
-          <a:p xmlns:a="http://schemas.openxmlformats.org/drawingml/2006/main">
-            <a:r>
-              <a:t>https://github.com/dparitosh/PMem/blob/545d43a/infra/neo4j/README.md</a:t>
-            </a:r>
-          </a:p>
-          <a:p xmlns:a="http://schemas.openxmlformats.org/drawingml/2006/main">
-            <a:r>
-              <a:t>https://github.com/dparitosh/PMem/blob/545d43a/infra/spark/README.md</a:t>
+              <a:t>Implementation baseline: current release branch, 23 September 2026.</a:t>
+            </a:r>
+          </a:p>
+          <a:p xmlns:a="http://schemas.openxmlformats.org/drawingml/2006/main">
+            <a:r>
+              <a:t>https://github.com/dparitosh/PMem/blob/codex/semantic-bridge-release/infra/deployment/services.json</a:t>
+            </a:r>
+          </a:p>
+          <a:p xmlns:a="http://schemas.openxmlformats.org/drawingml/2006/main">
+            <a:r>
+              <a:t>https://github.com/dparitosh/PMem/blob/codex/semantic-bridge-release/INSTALLATION.md</a:t>
+            </a:r>
+          </a:p>
+          <a:p xmlns:a="http://schemas.openxmlformats.org/drawingml/2006/main">
+            <a:r>
+              <a:t>https://github.com/dparitosh/PMem/blob/codex/semantic-bridge-release/infra/postgres/SCHEMA.md</a:t>
+            </a:r>
+          </a:p>
+          <a:p xmlns:a="http://schemas.openxmlformats.org/drawingml/2006/main">
+            <a:r>
+              <a:t>https://github.com/dparitosh/PMem/blob/codex/semantic-bridge-release/INSTALLATION.md</a:t>
+            </a:r>
+          </a:p>
+          <a:p xmlns:a="http://schemas.openxmlformats.org/drawingml/2006/main">
+            <a:r>
+              <a:t>https://github.com/dparitosh/PMem/blob/codex/semantic-bridge-release/INSTALLATION.md</a:t>
             </a:r>
           </a:p>
         </p:txBody>
@@ -1596,22 +1596,22 @@
           <a:lstStyle xmlns:a="http://schemas.openxmlformats.org/drawingml/2006/main"/>
           <a:p xmlns:a="http://schemas.openxmlformats.org/drawingml/2006/main">
             <a:r>
-              <a:t>Implementation baseline: commit 545d43a, 22 September 2026.</a:t>
-            </a:r>
-          </a:p>
-          <a:p xmlns:a="http://schemas.openxmlformats.org/drawingml/2006/main">
-            <a:r>
-              <a:t>https://github.com/dparitosh/PMem/blob/545d43a/infra/deployment/services.json</a:t>
-            </a:r>
-          </a:p>
-          <a:p xmlns:a="http://schemas.openxmlformats.org/drawingml/2006/main">
-            <a:r>
-              <a:t>https://github.com/dparitosh/PMem/blob/545d43a/backend/agentic_service/bridge_jobs.py</a:t>
-            </a:r>
-          </a:p>
-          <a:p xmlns:a="http://schemas.openxmlformats.org/drawingml/2006/main">
-            <a:r>
-              <a:t>https://github.com/dparitosh/PMem/blob/545d43a/backend/data_product_service/worker.py</a:t>
+              <a:t>Implementation baseline: current release branch, 23 September 2026.</a:t>
+            </a:r>
+          </a:p>
+          <a:p xmlns:a="http://schemas.openxmlformats.org/drawingml/2006/main">
+            <a:r>
+              <a:t>https://github.com/dparitosh/PMem/blob/codex/semantic-bridge-release/infra/deployment/services.json</a:t>
+            </a:r>
+          </a:p>
+          <a:p xmlns:a="http://schemas.openxmlformats.org/drawingml/2006/main">
+            <a:r>
+              <a:t>https://github.com/dparitosh/PMem/blob/codex/semantic-bridge-release/backend/agentic_service/bridge_jobs.py</a:t>
+            </a:r>
+          </a:p>
+          <a:p xmlns:a="http://schemas.openxmlformats.org/drawingml/2006/main">
+            <a:r>
+              <a:t>https://github.com/dparitosh/PMem/blob/codex/semantic-bridge-release/backend/data_product_service/worker.py</a:t>
             </a:r>
           </a:p>
         </p:txBody>
@@ -1681,27 +1681,27 @@
           <a:lstStyle xmlns:a="http://schemas.openxmlformats.org/drawingml/2006/main"/>
           <a:p xmlns:a="http://schemas.openxmlformats.org/drawingml/2006/main">
             <a:r>
-              <a:t>Implementation baseline: commit 545d43a, 22 September 2026.</a:t>
-            </a:r>
-          </a:p>
-          <a:p xmlns:a="http://schemas.openxmlformats.org/drawingml/2006/main">
-            <a:r>
-              <a:t>https://github.com/dparitosh/PMem/blob/545d43a/backend/data_pipeline_service/router.py</a:t>
-            </a:r>
-          </a:p>
-          <a:p xmlns:a="http://schemas.openxmlformats.org/drawingml/2006/main">
-            <a:r>
-              <a:t>https://github.com/dparitosh/PMem/blob/545d43a/backend/ceim_service/router.py</a:t>
-            </a:r>
-          </a:p>
-          <a:p xmlns:a="http://schemas.openxmlformats.org/drawingml/2006/main">
-            <a:r>
-              <a:t>https://github.com/dparitosh/PMem/blob/545d43a/backend/agentic_service/bridge_jobs.py</a:t>
-            </a:r>
-          </a:p>
-          <a:p xmlns:a="http://schemas.openxmlformats.org/drawingml/2006/main">
-            <a:r>
-              <a:t>https://github.com/dparitosh/PMem/blob/545d43a/backend/graph_service/bridge_router.py</a:t>
+              <a:t>Implementation baseline: current release branch, 23 September 2026.</a:t>
+            </a:r>
+          </a:p>
+          <a:p xmlns:a="http://schemas.openxmlformats.org/drawingml/2006/main">
+            <a:r>
+              <a:t>https://github.com/dparitosh/PMem/blob/codex/semantic-bridge-release/backend/data_pipeline_service/router.py</a:t>
+            </a:r>
+          </a:p>
+          <a:p xmlns:a="http://schemas.openxmlformats.org/drawingml/2006/main">
+            <a:r>
+              <a:t>https://github.com/dparitosh/PMem/blob/codex/semantic-bridge-release/backend/ceim_service/router.py</a:t>
+            </a:r>
+          </a:p>
+          <a:p xmlns:a="http://schemas.openxmlformats.org/drawingml/2006/main">
+            <a:r>
+              <a:t>https://github.com/dparitosh/PMem/blob/codex/semantic-bridge-release/backend/agentic_service/bridge_jobs.py</a:t>
+            </a:r>
+          </a:p>
+          <a:p xmlns:a="http://schemas.openxmlformats.org/drawingml/2006/main">
+            <a:r>
+              <a:t>https://github.com/dparitosh/PMem/blob/codex/semantic-bridge-release/backend/graph_service/bridge_router.py</a:t>
             </a:r>
           </a:p>
         </p:txBody>
@@ -1771,22 +1771,22 @@
           <a:lstStyle xmlns:a="http://schemas.openxmlformats.org/drawingml/2006/main"/>
           <a:p xmlns:a="http://schemas.openxmlformats.org/drawingml/2006/main">
             <a:r>
-              <a:t>Implementation baseline: commit 545d43a, 22 September 2026.</a:t>
-            </a:r>
-          </a:p>
-          <a:p xmlns:a="http://schemas.openxmlformats.org/drawingml/2006/main">
-            <a:r>
-              <a:t>https://github.com/dparitosh/PMem/blob/545d43a/backend/agentic_service/bridge_jobs.py</a:t>
-            </a:r>
-          </a:p>
-          <a:p xmlns:a="http://schemas.openxmlformats.org/drawingml/2006/main">
-            <a:r>
-              <a:t>https://github.com/dparitosh/PMem/blob/545d43a/backend/graph_service/bridge_publication.py</a:t>
-            </a:r>
-          </a:p>
-          <a:p xmlns:a="http://schemas.openxmlformats.org/drawingml/2006/main">
-            <a:r>
-              <a:t>https://github.com/dparitosh/PMem/blob/545d43a/frontend/src/Components/ontology/SemanticBridgeJobs.js</a:t>
+              <a:t>Implementation baseline: current release branch, 23 September 2026.</a:t>
+            </a:r>
+          </a:p>
+          <a:p xmlns:a="http://schemas.openxmlformats.org/drawingml/2006/main">
+            <a:r>
+              <a:t>https://github.com/dparitosh/PMem/blob/codex/semantic-bridge-release/backend/agentic_service/bridge_jobs.py</a:t>
+            </a:r>
+          </a:p>
+          <a:p xmlns:a="http://schemas.openxmlformats.org/drawingml/2006/main">
+            <a:r>
+              <a:t>https://github.com/dparitosh/PMem/blob/codex/semantic-bridge-release/backend/graph_service/bridge_publication.py</a:t>
+            </a:r>
+          </a:p>
+          <a:p xmlns:a="http://schemas.openxmlformats.org/drawingml/2006/main">
+            <a:r>
+              <a:t>https://github.com/dparitosh/PMem/blob/codex/semantic-bridge-release/frontend/src/Components/ontology/SemanticBridgeJobs.js</a:t>
             </a:r>
           </a:p>
         </p:txBody>
@@ -1856,22 +1856,22 @@
           <a:lstStyle xmlns:a="http://schemas.openxmlformats.org/drawingml/2006/main"/>
           <a:p xmlns:a="http://schemas.openxmlformats.org/drawingml/2006/main">
             <a:r>
-              <a:t>Implementation baseline: commit 545d43a, 22 September 2026.</a:t>
-            </a:r>
-          </a:p>
-          <a:p xmlns:a="http://schemas.openxmlformats.org/drawingml/2006/main">
-            <a:r>
-              <a:t>https://github.com/dparitosh/PMem/blob/545d43a/backend/data_pipeline_service/router.py</a:t>
-            </a:r>
-          </a:p>
-          <a:p xmlns:a="http://schemas.openxmlformats.org/drawingml/2006/main">
-            <a:r>
-              <a:t>https://github.com/dparitosh/PMem/blob/545d43a/backend/data_pipeline_service/run_records.py</a:t>
-            </a:r>
-          </a:p>
-          <a:p xmlns:a="http://schemas.openxmlformats.org/drawingml/2006/main">
-            <a:r>
-              <a:t>https://github.com/dparitosh/PMem/blob/545d43a/backend/data_pipeline_service/job_definitions.py</a:t>
+              <a:t>Implementation baseline: current release branch, 23 September 2026.</a:t>
+            </a:r>
+          </a:p>
+          <a:p xmlns:a="http://schemas.openxmlformats.org/drawingml/2006/main">
+            <a:r>
+              <a:t>https://github.com/dparitosh/PMem/blob/codex/semantic-bridge-release/backend/data_pipeline_service/router.py</a:t>
+            </a:r>
+          </a:p>
+          <a:p xmlns:a="http://schemas.openxmlformats.org/drawingml/2006/main">
+            <a:r>
+              <a:t>https://github.com/dparitosh/PMem/blob/codex/semantic-bridge-release/backend/data_pipeline_service/run_records.py</a:t>
+            </a:r>
+          </a:p>
+          <a:p xmlns:a="http://schemas.openxmlformats.org/drawingml/2006/main">
+            <a:r>
+              <a:t>https://github.com/dparitosh/PMem/blob/codex/semantic-bridge-release/backend/data_pipeline_service/job_definitions.py</a:t>
             </a:r>
           </a:p>
         </p:txBody>
@@ -1941,17 +1941,17 @@
           <a:lstStyle xmlns:a="http://schemas.openxmlformats.org/drawingml/2006/main"/>
           <a:p xmlns:a="http://schemas.openxmlformats.org/drawingml/2006/main">
             <a:r>
-              <a:t>Implementation baseline: commit 545d43a, 22 September 2026.</a:t>
-            </a:r>
-          </a:p>
-          <a:p xmlns:a="http://schemas.openxmlformats.org/drawingml/2006/main">
-            <a:r>
-              <a:t>https://github.com/dparitosh/PMem/blob/545d43a/backend/data_pipeline_service/handlers.py</a:t>
-            </a:r>
-          </a:p>
-          <a:p xmlns:a="http://schemas.openxmlformats.org/drawingml/2006/main">
-            <a:r>
-              <a:t>https://github.com/dparitosh/PMem/blob/545d43a/backend/data_pipeline_service/runner.py</a:t>
+              <a:t>Implementation baseline: current release branch, 23 September 2026.</a:t>
+            </a:r>
+          </a:p>
+          <a:p xmlns:a="http://schemas.openxmlformats.org/drawingml/2006/main">
+            <a:r>
+              <a:t>https://github.com/dparitosh/PMem/blob/codex/semantic-bridge-release/backend/data_pipeline_service/handlers.py</a:t>
+            </a:r>
+          </a:p>
+          <a:p xmlns:a="http://schemas.openxmlformats.org/drawingml/2006/main">
+            <a:r>
+              <a:t>https://github.com/dparitosh/PMem/blob/codex/semantic-bridge-release/backend/data_pipeline_service/runner.py</a:t>
             </a:r>
           </a:p>
         </p:txBody>
@@ -2021,17 +2021,17 @@
           <a:lstStyle xmlns:a="http://schemas.openxmlformats.org/drawingml/2006/main"/>
           <a:p xmlns:a="http://schemas.openxmlformats.org/drawingml/2006/main">
             <a:r>
-              <a:t>Implementation baseline: commit 545d43a, 22 September 2026.</a:t>
-            </a:r>
-          </a:p>
-          <a:p xmlns:a="http://schemas.openxmlformats.org/drawingml/2006/main">
-            <a:r>
-              <a:t>https://github.com/dparitosh/PMem/blob/545d43a/backend/data_pipeline_service/handlers.py</a:t>
-            </a:r>
-          </a:p>
-          <a:p xmlns:a="http://schemas.openxmlformats.org/drawingml/2006/main">
-            <a:r>
-              <a:t>https://github.com/dparitosh/PMem/blob/545d43a/backend/data_pipeline_service/runner.py</a:t>
+              <a:t>Implementation baseline: current release branch, 23 September 2026.</a:t>
+            </a:r>
+          </a:p>
+          <a:p xmlns:a="http://schemas.openxmlformats.org/drawingml/2006/main">
+            <a:r>
+              <a:t>https://github.com/dparitosh/PMem/blob/codex/semantic-bridge-release/backend/data_pipeline_service/handlers.py</a:t>
+            </a:r>
+          </a:p>
+          <a:p xmlns:a="http://schemas.openxmlformats.org/drawingml/2006/main">
+            <a:r>
+              <a:t>https://github.com/dparitosh/PMem/blob/codex/semantic-bridge-release/backend/data_pipeline_service/runner.py</a:t>
             </a:r>
           </a:p>
         </p:txBody>
@@ -2101,22 +2101,22 @@
           <a:lstStyle xmlns:a="http://schemas.openxmlformats.org/drawingml/2006/main"/>
           <a:p xmlns:a="http://schemas.openxmlformats.org/drawingml/2006/main">
             <a:r>
-              <a:t>Implementation baseline: commit 545d43a, 22 September 2026.</a:t>
-            </a:r>
-          </a:p>
-          <a:p xmlns:a="http://schemas.openxmlformats.org/drawingml/2006/main">
-            <a:r>
-              <a:t>https://github.com/dparitosh/PMem/blob/545d43a/backend/data_pipeline_service/speed_router.py</a:t>
-            </a:r>
-          </a:p>
-          <a:p xmlns:a="http://schemas.openxmlformats.org/drawingml/2006/main">
-            <a:r>
-              <a:t>https://github.com/dparitosh/PMem/blob/545d43a/backend/data_pipeline_service/speed_path.py</a:t>
-            </a:r>
-          </a:p>
-          <a:p xmlns:a="http://schemas.openxmlformats.org/drawingml/2006/main">
-            <a:r>
-              <a:t>https://github.com/dparitosh/PMem/blob/545d43a/infra/spark/README.md</a:t>
+              <a:t>Implementation baseline: current release branch, 23 September 2026.</a:t>
+            </a:r>
+          </a:p>
+          <a:p xmlns:a="http://schemas.openxmlformats.org/drawingml/2006/main">
+            <a:r>
+              <a:t>https://github.com/dparitosh/PMem/blob/codex/semantic-bridge-release/backend/data_pipeline_service/speed_router.py</a:t>
+            </a:r>
+          </a:p>
+          <a:p xmlns:a="http://schemas.openxmlformats.org/drawingml/2006/main">
+            <a:r>
+              <a:t>https://github.com/dparitosh/PMem/blob/codex/semantic-bridge-release/backend/data_pipeline_service/speed_path.py</a:t>
+            </a:r>
+          </a:p>
+          <a:p xmlns:a="http://schemas.openxmlformats.org/drawingml/2006/main">
+            <a:r>
+              <a:t>https://github.com/dparitosh/PMem/blob/codex/semantic-bridge-release/INSTALLATION.md</a:t>
             </a:r>
           </a:p>
         </p:txBody>
@@ -2184,7 +2184,7 @@
   </p:cSld>
   <p:clrMap bg1="lt1" tx1="dk1" bg2="lt2" tx2="dk2" accent1="accent1" accent2="accent2" accent3="accent3" accent4="accent4" accent5="accent5" accent6="accent6" hlink="hlink" folHlink="folHlink"/>
   <p:sldLayoutIdLst>
-    <p:sldLayoutId xmlns:r="http://schemas.openxmlformats.org/officeDocument/2006/relationships" id="2147483649" r:id="R806513493fef4995"/>
+    <p:sldLayoutId xmlns:r="http://schemas.openxmlformats.org/officeDocument/2006/relationships" id="2147483649" r:id="R4420e75cc44247b6"/>
   </p:sldLayoutIdLst>
   <p:txStyles>
     <p:titleStyle>
@@ -2735,7 +2735,7 @@
           <p:cNvPr id="5" name="DEPO DIGITAL THREAD">
             <a:extLst xmlns:a="http://schemas.openxmlformats.org/drawingml/2006/main">
               <a:ext uri="{FF2B5EF4-FFF2-40B4-BE49-F238E27FC236}">
-                <a16:creationId xmlns:a16="http://schemas.microsoft.com/office/drawing/2014/main" id="{FB18DCC8-82B6-454C-AA5D-9BF10B8C57A6}"/>
+                <a16:creationId xmlns:a16="http://schemas.microsoft.com/office/drawing/2014/main" id="{5CB089C1-634C-453F-923E-76626E8D135E}"/>
               </a:ext>
             </a:extLst>
           </p:cNvPr>
@@ -2792,7 +2792,7 @@
           <p:cNvPr id="2" name="Functional architecture&#10;and customer deployment">
             <a:extLst xmlns:a="http://schemas.openxmlformats.org/drawingml/2006/main">
               <a:ext uri="{FF2B5EF4-FFF2-40B4-BE49-F238E27FC236}">
-                <a16:creationId xmlns:a16="http://schemas.microsoft.com/office/drawing/2014/main" id="{7E7A2F40-6AEA-4B70-A297-FBA64138219F}"/>
+                <a16:creationId xmlns:a16="http://schemas.microsoft.com/office/drawing/2014/main" id="{A7722472-2614-4C3A-BAC5-35D4EDA0395C}"/>
               </a:ext>
             </a:extLst>
           </p:cNvPr>
@@ -2872,7 +2872,7 @@
           <p:cNvPr id="3" name="Semantic Bridge, governed data jobs and graph publication">
             <a:extLst xmlns:a="http://schemas.openxmlformats.org/drawingml/2006/main">
               <a:ext uri="{FF2B5EF4-FFF2-40B4-BE49-F238E27FC236}">
-                <a16:creationId xmlns:a16="http://schemas.microsoft.com/office/drawing/2014/main" id="{EEC27CBD-E1CD-4659-B210-F01BA82DB419}"/>
+                <a16:creationId xmlns:a16="http://schemas.microsoft.com/office/drawing/2014/main" id="{2552629C-DF8C-43F9-9DE6-FD6D8A87F772}"/>
               </a:ext>
             </a:extLst>
           </p:cNvPr>
@@ -2929,7 +2929,7 @@
           <p:cNvPr id="4" name="Consolidated presentation&#10;22 September 2026">
             <a:extLst xmlns:a="http://schemas.openxmlformats.org/drawingml/2006/main">
               <a:ext uri="{FF2B5EF4-FFF2-40B4-BE49-F238E27FC236}">
-                <a16:creationId xmlns:a16="http://schemas.microsoft.com/office/drawing/2014/main" id="{882998E7-D235-4488-A702-0C5116721375}"/>
+                <a16:creationId xmlns:a16="http://schemas.microsoft.com/office/drawing/2014/main" id="{B92618B1-0A33-45C8-A870-CB9D8DF29A00}"/>
               </a:ext>
             </a:extLst>
           </p:cNvPr>
@@ -3007,7 +3007,7 @@
     </p:spTree>
     <p:extLst>
       <p:ext uri="{BB962C8B-B14F-4D97-AF65-F5344CB8AC3E}">
-        <p14:creationId xmlns:p14="http://schemas.microsoft.com/office/powerpoint/2010/main" val="1524900491"/>
+        <p14:creationId xmlns:p14="http://schemas.microsoft.com/office/powerpoint/2010/main" val="1123464075"/>
       </p:ext>
     </p:extLst>
   </p:cSld>
@@ -3038,7 +3038,7 @@
           <p:cNvPr id="16" name="Document evidence workflow">
             <a:extLst xmlns:a="http://schemas.openxmlformats.org/drawingml/2006/main">
               <a:ext uri="{FF2B5EF4-FFF2-40B4-BE49-F238E27FC236}">
-                <a16:creationId xmlns:a16="http://schemas.microsoft.com/office/drawing/2014/main" id="{09562B6C-785F-45BC-B6A9-610013DB996A}"/>
+                <a16:creationId xmlns:a16="http://schemas.microsoft.com/office/drawing/2014/main" id="{B77D2756-45B5-45C7-AE9B-099EEC160146}"/>
               </a:ext>
             </a:extLst>
           </p:cNvPr>
@@ -3095,7 +3095,7 @@
           <p:cNvPr id="2" name="Structural enrichment preserves the link between a document and its pr">
             <a:extLst xmlns:a="http://schemas.openxmlformats.org/drawingml/2006/main">
               <a:ext uri="{FF2B5EF4-FFF2-40B4-BE49-F238E27FC236}">
-                <a16:creationId xmlns:a16="http://schemas.microsoft.com/office/drawing/2014/main" id="{7EFF7CC0-111E-4A91-BCFD-F37331515C35}"/>
+                <a16:creationId xmlns:a16="http://schemas.microsoft.com/office/drawing/2014/main" id="{B77482A6-374E-4C3D-AA91-1DC6875F79C4}"/>
               </a:ext>
             </a:extLst>
           </p:cNvPr>
@@ -3152,7 +3152,7 @@
           <p:cNvPr id="3" name="DEPO  /  Functional architecture">
             <a:extLst xmlns:a="http://schemas.openxmlformats.org/drawingml/2006/main">
               <a:ext uri="{FF2B5EF4-FFF2-40B4-BE49-F238E27FC236}">
-                <a16:creationId xmlns:a16="http://schemas.microsoft.com/office/drawing/2014/main" id="{3CAB1CD4-34F0-481B-8A6D-E3471DA48793}"/>
+                <a16:creationId xmlns:a16="http://schemas.microsoft.com/office/drawing/2014/main" id="{4785B757-3DA4-44DB-AB7B-B4109562DE02}"/>
               </a:ext>
             </a:extLst>
           </p:cNvPr>
@@ -3209,7 +3209,7 @@
           <p:cNvPr id="4" name="10">
             <a:extLst xmlns:a="http://schemas.openxmlformats.org/drawingml/2006/main">
               <a:ext uri="{FF2B5EF4-FFF2-40B4-BE49-F238E27FC236}">
-                <a16:creationId xmlns:a16="http://schemas.microsoft.com/office/drawing/2014/main" id="{0FED8504-AD23-44EF-B2B6-B596BDED044F}"/>
+                <a16:creationId xmlns:a16="http://schemas.microsoft.com/office/drawing/2014/main" id="{17E3A08B-471F-491F-98D4-2AE9D5F53615}"/>
               </a:ext>
             </a:extLst>
           </p:cNvPr>
@@ -3266,7 +3266,7 @@
           <p:cNvPr id="5" name="Retain">
             <a:extLst xmlns:a="http://schemas.openxmlformats.org/drawingml/2006/main">
               <a:ext uri="{FF2B5EF4-FFF2-40B4-BE49-F238E27FC236}">
-                <a16:creationId xmlns:a16="http://schemas.microsoft.com/office/drawing/2014/main" id="{92A5BE11-1562-4B16-9154-AA90279ABFFC}"/>
+                <a16:creationId xmlns:a16="http://schemas.microsoft.com/office/drawing/2014/main" id="{DA2B8D3A-2B9C-4975-9C0F-61ED8B516303}"/>
               </a:ext>
             </a:extLst>
           </p:cNvPr>
@@ -3353,7 +3353,7 @@
           <p:cNvPr id="6" name="Validate">
             <a:extLst xmlns:a="http://schemas.openxmlformats.org/drawingml/2006/main">
               <a:ext uri="{FF2B5EF4-FFF2-40B4-BE49-F238E27FC236}">
-                <a16:creationId xmlns:a16="http://schemas.microsoft.com/office/drawing/2014/main" id="{D4EBEBEB-8B37-4131-A755-FF9D74DC29B4}"/>
+                <a16:creationId xmlns:a16="http://schemas.microsoft.com/office/drawing/2014/main" id="{8770EB4C-7F63-44A2-A136-05143B844126}"/>
               </a:ext>
             </a:extLst>
           </p:cNvPr>
@@ -3440,7 +3440,7 @@
           <p:cNvPr id="7" name="Enrich">
             <a:extLst xmlns:a="http://schemas.openxmlformats.org/drawingml/2006/main">
               <a:ext uri="{FF2B5EF4-FFF2-40B4-BE49-F238E27FC236}">
-                <a16:creationId xmlns:a16="http://schemas.microsoft.com/office/drawing/2014/main" id="{1274259C-296D-4C96-BA46-4AF3D6162CF7}"/>
+                <a16:creationId xmlns:a16="http://schemas.microsoft.com/office/drawing/2014/main" id="{D1424D72-4617-4CA7-AAAC-9B9F2095A54A}"/>
               </a:ext>
             </a:extLst>
           </p:cNvPr>
@@ -3527,7 +3527,7 @@
           <p:cNvPr id="8" name="Normalize">
             <a:extLst xmlns:a="http://schemas.openxmlformats.org/drawingml/2006/main">
               <a:ext uri="{FF2B5EF4-FFF2-40B4-BE49-F238E27FC236}">
-                <a16:creationId xmlns:a16="http://schemas.microsoft.com/office/drawing/2014/main" id="{F6ECBBF4-AF90-49E7-936C-DE4982D09B44}"/>
+                <a16:creationId xmlns:a16="http://schemas.microsoft.com/office/drawing/2014/main" id="{90476516-3336-4069-9149-BDA1DB7C8581}"/>
               </a:ext>
             </a:extLst>
           </p:cNvPr>
@@ -3689,7 +3689,7 @@
           <p:cNvPr id="12" name="Reviewer context">
             <a:extLst xmlns:a="http://schemas.openxmlformats.org/drawingml/2006/main">
               <a:ext uri="{FF2B5EF4-FFF2-40B4-BE49-F238E27FC236}">
-                <a16:creationId xmlns:a16="http://schemas.microsoft.com/office/drawing/2014/main" id="{1598D56B-923B-416E-932E-7CBE02D502D6}"/>
+                <a16:creationId xmlns:a16="http://schemas.microsoft.com/office/drawing/2014/main" id="{C69C736F-2B79-4ADB-8BA8-7A7E037AA0BB}"/>
               </a:ext>
             </a:extLst>
           </p:cNvPr>
@@ -3746,7 +3746,7 @@
           <p:cNvPr id="13" name="The proposal carries provenance and content digests for traceability.">
             <a:extLst xmlns:a="http://schemas.openxmlformats.org/drawingml/2006/main">
               <a:ext uri="{FF2B5EF4-FFF2-40B4-BE49-F238E27FC236}">
-                <a16:creationId xmlns:a16="http://schemas.microsoft.com/office/drawing/2014/main" id="{6A6A1EBA-17B3-49B4-BE76-28C552BB4E20}"/>
+                <a16:creationId xmlns:a16="http://schemas.microsoft.com/office/drawing/2014/main" id="{40A7D90D-B1BF-4988-822F-A289D53A2A30}"/>
               </a:ext>
             </a:extLst>
           </p:cNvPr>
@@ -3803,7 +3803,7 @@
           <p:cNvPr id="14" name="Scope">
             <a:extLst xmlns:a="http://schemas.openxmlformats.org/drawingml/2006/main">
               <a:ext uri="{FF2B5EF4-FFF2-40B4-BE49-F238E27FC236}">
-                <a16:creationId xmlns:a16="http://schemas.microsoft.com/office/drawing/2014/main" id="{021C868A-0BA4-4282-B864-B25B31F016C5}"/>
+                <a16:creationId xmlns:a16="http://schemas.microsoft.com/office/drawing/2014/main" id="{F724719D-F759-4F9D-9AD3-FDA1595B76F2}"/>
               </a:ext>
             </a:extLst>
           </p:cNvPr>
@@ -3860,7 +3860,7 @@
           <p:cNvPr id="15" name="OCR, model-based entity extraction and embeddings require separate mod">
             <a:extLst xmlns:a="http://schemas.openxmlformats.org/drawingml/2006/main">
               <a:ext uri="{FF2B5EF4-FFF2-40B4-BE49-F238E27FC236}">
-                <a16:creationId xmlns:a16="http://schemas.microsoft.com/office/drawing/2014/main" id="{027668E7-234F-4A1E-8CD2-5D5C9EE85B20}"/>
+                <a16:creationId xmlns:a16="http://schemas.microsoft.com/office/drawing/2014/main" id="{59AFF63C-1E1F-4609-A26E-2E78C7AB3F5C}"/>
               </a:ext>
             </a:extLst>
           </p:cNvPr>
@@ -3915,7 +3915,7 @@
     </p:spTree>
     <p:extLst>
       <p:ext uri="{BB962C8B-B14F-4D97-AF65-F5344CB8AC3E}">
-        <p14:creationId xmlns:p14="http://schemas.microsoft.com/office/powerpoint/2010/main" val="740114423"/>
+        <p14:creationId xmlns:p14="http://schemas.microsoft.com/office/powerpoint/2010/main" val="1929783521"/>
       </p:ext>
     </p:extLst>
   </p:cSld>
@@ -3946,7 +3946,7 @@
           <p:cNvPr id="16" name="Data-product packaging and catalog registration">
             <a:extLst xmlns:a="http://schemas.openxmlformats.org/drawingml/2006/main">
               <a:ext uri="{FF2B5EF4-FFF2-40B4-BE49-F238E27FC236}">
-                <a16:creationId xmlns:a16="http://schemas.microsoft.com/office/drawing/2014/main" id="{5260FB22-DA7B-4BDF-9654-829EC84F27C1}"/>
+                <a16:creationId xmlns:a16="http://schemas.microsoft.com/office/drawing/2014/main" id="{F9598A66-6D72-4E85-890A-B992FE103F5F}"/>
               </a:ext>
             </a:extLst>
           </p:cNvPr>
@@ -4003,7 +4003,7 @@
           <p:cNvPr id="2" name="A product exposes a versioned package and its evidence for reuse.">
             <a:extLst xmlns:a="http://schemas.openxmlformats.org/drawingml/2006/main">
               <a:ext uri="{FF2B5EF4-FFF2-40B4-BE49-F238E27FC236}">
-                <a16:creationId xmlns:a16="http://schemas.microsoft.com/office/drawing/2014/main" id="{AED50F31-DC34-4CD2-B273-56E1E80CC0E5}"/>
+                <a16:creationId xmlns:a16="http://schemas.microsoft.com/office/drawing/2014/main" id="{3D6253FC-0459-4697-B84D-F445EF85070E}"/>
               </a:ext>
             </a:extLst>
           </p:cNvPr>
@@ -4060,7 +4060,7 @@
           <p:cNvPr id="3" name="DEPO  /  Functional architecture">
             <a:extLst xmlns:a="http://schemas.openxmlformats.org/drawingml/2006/main">
               <a:ext uri="{FF2B5EF4-FFF2-40B4-BE49-F238E27FC236}">
-                <a16:creationId xmlns:a16="http://schemas.microsoft.com/office/drawing/2014/main" id="{A4D5BAAE-B774-4301-B695-D0E0E8917035}"/>
+                <a16:creationId xmlns:a16="http://schemas.microsoft.com/office/drawing/2014/main" id="{1604482B-3E32-42A7-8BAB-DC643D7C73FF}"/>
               </a:ext>
             </a:extLst>
           </p:cNvPr>
@@ -4117,7 +4117,7 @@
           <p:cNvPr id="4" name="11">
             <a:extLst xmlns:a="http://schemas.openxmlformats.org/drawingml/2006/main">
               <a:ext uri="{FF2B5EF4-FFF2-40B4-BE49-F238E27FC236}">
-                <a16:creationId xmlns:a16="http://schemas.microsoft.com/office/drawing/2014/main" id="{A94EFE1B-4AD6-49D6-856F-5F3570BA8787}"/>
+                <a16:creationId xmlns:a16="http://schemas.microsoft.com/office/drawing/2014/main" id="{AE7B9362-0F3E-4660-B8D5-2AADE9E29EF8}"/>
               </a:ext>
             </a:extLst>
           </p:cNvPr>
@@ -4174,7 +4174,7 @@
           <p:cNvPr id="5" name="Evidence">
             <a:extLst xmlns:a="http://schemas.openxmlformats.org/drawingml/2006/main">
               <a:ext uri="{FF2B5EF4-FFF2-40B4-BE49-F238E27FC236}">
-                <a16:creationId xmlns:a16="http://schemas.microsoft.com/office/drawing/2014/main" id="{1CEFB83C-D12B-4FF3-AD83-0C02EE40CCEE}"/>
+                <a16:creationId xmlns:a16="http://schemas.microsoft.com/office/drawing/2014/main" id="{D27A814F-0444-4010-88E3-5ACCA449CB59}"/>
               </a:ext>
             </a:extLst>
           </p:cNvPr>
@@ -4261,7 +4261,7 @@
           <p:cNvPr id="6" name="Product manifest">
             <a:extLst xmlns:a="http://schemas.openxmlformats.org/drawingml/2006/main">
               <a:ext uri="{FF2B5EF4-FFF2-40B4-BE49-F238E27FC236}">
-                <a16:creationId xmlns:a16="http://schemas.microsoft.com/office/drawing/2014/main" id="{B30C22A0-826C-4ADC-80DF-43B7343D2047}"/>
+                <a16:creationId xmlns:a16="http://schemas.microsoft.com/office/drawing/2014/main" id="{D2E4E9D0-E21A-46FD-84F8-B1633C16AABB}"/>
               </a:ext>
             </a:extLst>
           </p:cNvPr>
@@ -4348,7 +4348,7 @@
           <p:cNvPr id="7" name="Durable outbox">
             <a:extLst xmlns:a="http://schemas.openxmlformats.org/drawingml/2006/main">
               <a:ext uri="{FF2B5EF4-FFF2-40B4-BE49-F238E27FC236}">
-                <a16:creationId xmlns:a16="http://schemas.microsoft.com/office/drawing/2014/main" id="{D14B2F6C-5FA8-4C59-B16D-D43F34F95CB0}"/>
+                <a16:creationId xmlns:a16="http://schemas.microsoft.com/office/drawing/2014/main" id="{5D0BC655-BE5C-4C72-BE90-5D149A1777E1}"/>
               </a:ext>
             </a:extLst>
           </p:cNvPr>
@@ -4435,7 +4435,7 @@
           <p:cNvPr id="8" name="Catalog">
             <a:extLst xmlns:a="http://schemas.openxmlformats.org/drawingml/2006/main">
               <a:ext uri="{FF2B5EF4-FFF2-40B4-BE49-F238E27FC236}">
-                <a16:creationId xmlns:a16="http://schemas.microsoft.com/office/drawing/2014/main" id="{3DE428F6-FC68-42C3-95BE-70D67F6B380B}"/>
+                <a16:creationId xmlns:a16="http://schemas.microsoft.com/office/drawing/2014/main" id="{8CE3D710-987B-4082-B26D-3435982A0318}"/>
               </a:ext>
             </a:extLst>
           </p:cNvPr>
@@ -4597,7 +4597,7 @@
           <p:cNvPr id="12" name="Recovery">
             <a:extLst xmlns:a="http://schemas.openxmlformats.org/drawingml/2006/main">
               <a:ext uri="{FF2B5EF4-FFF2-40B4-BE49-F238E27FC236}">
-                <a16:creationId xmlns:a16="http://schemas.microsoft.com/office/drawing/2014/main" id="{65E93067-D996-4EAF-8E99-BF00A1AA08B1}"/>
+                <a16:creationId xmlns:a16="http://schemas.microsoft.com/office/drawing/2014/main" id="{4D1C4EFE-94B7-49A4-8808-5BF2EB524946}"/>
               </a:ext>
             </a:extLst>
           </p:cNvPr>
@@ -4654,7 +4654,7 @@
           <p:cNvPr id="13" name="The outbox worker periodically reconciles pending registrations.">
             <a:extLst xmlns:a="http://schemas.openxmlformats.org/drawingml/2006/main">
               <a:ext uri="{FF2B5EF4-FFF2-40B4-BE49-F238E27FC236}">
-                <a16:creationId xmlns:a16="http://schemas.microsoft.com/office/drawing/2014/main" id="{A195B645-7790-4C78-BA97-9E30F609DF95}"/>
+                <a16:creationId xmlns:a16="http://schemas.microsoft.com/office/drawing/2014/main" id="{75FE99D2-A73B-4EBF-B426-73E9999F1CC5}"/>
               </a:ext>
             </a:extLst>
           </p:cNvPr>
@@ -4711,7 +4711,7 @@
           <p:cNvPr id="14" name="Boundary">
             <a:extLst xmlns:a="http://schemas.openxmlformats.org/drawingml/2006/main">
               <a:ext uri="{FF2B5EF4-FFF2-40B4-BE49-F238E27FC236}">
-                <a16:creationId xmlns:a16="http://schemas.microsoft.com/office/drawing/2014/main" id="{1EA0432D-ED0E-474F-9978-EF2910238C83}"/>
+                <a16:creationId xmlns:a16="http://schemas.microsoft.com/office/drawing/2014/main" id="{015F5706-EE1F-49B4-B40C-16122BAC2BEE}"/>
               </a:ext>
             </a:extLst>
           </p:cNvPr>
@@ -4768,7 +4768,7 @@
           <p:cNvPr id="15" name="Packaging and catalog registration are separate from graph mutation. A">
             <a:extLst xmlns:a="http://schemas.openxmlformats.org/drawingml/2006/main">
               <a:ext uri="{FF2B5EF4-FFF2-40B4-BE49-F238E27FC236}">
-                <a16:creationId xmlns:a16="http://schemas.microsoft.com/office/drawing/2014/main" id="{8320082F-2875-4A20-B55F-E1AC7DEADF04}"/>
+                <a16:creationId xmlns:a16="http://schemas.microsoft.com/office/drawing/2014/main" id="{4921A355-1371-492D-84D4-A9F18E995263}"/>
               </a:ext>
             </a:extLst>
           </p:cNvPr>
@@ -4823,7 +4823,7 @@
     </p:spTree>
     <p:extLst>
       <p:ext uri="{BB962C8B-B14F-4D97-AF65-F5344CB8AC3E}">
-        <p14:creationId xmlns:p14="http://schemas.microsoft.com/office/powerpoint/2010/main" val="1521751792"/>
+        <p14:creationId xmlns:p14="http://schemas.microsoft.com/office/powerpoint/2010/main" val="133838991"/>
       </p:ext>
     </p:extLst>
   </p:cSld>
@@ -4854,7 +4854,7 @@
           <p:cNvPr id="17" name="Agentic assistance and semantic retrieval">
             <a:extLst xmlns:a="http://schemas.openxmlformats.org/drawingml/2006/main">
               <a:ext uri="{FF2B5EF4-FFF2-40B4-BE49-F238E27FC236}">
-                <a16:creationId xmlns:a16="http://schemas.microsoft.com/office/drawing/2014/main" id="{9DC11450-9A14-4264-B7B1-3A9C483ABC4F}"/>
+                <a16:creationId xmlns:a16="http://schemas.microsoft.com/office/drawing/2014/main" id="{521D7402-456B-436C-BD03-4B796F290B2D}"/>
               </a:ext>
             </a:extLst>
           </p:cNvPr>
@@ -4911,7 +4911,7 @@
           <p:cNvPr id="2" name="The Knowledge Companion retrieves bounded graph evidence. Tool workflo">
             <a:extLst xmlns:a="http://schemas.openxmlformats.org/drawingml/2006/main">
               <a:ext uri="{FF2B5EF4-FFF2-40B4-BE49-F238E27FC236}">
-                <a16:creationId xmlns:a16="http://schemas.microsoft.com/office/drawing/2014/main" id="{18154540-9F9E-4BE6-A0F5-04A8FC1A1329}"/>
+                <a16:creationId xmlns:a16="http://schemas.microsoft.com/office/drawing/2014/main" id="{39D862E7-A1F4-4D33-A36D-3531AAA84AEE}"/>
               </a:ext>
             </a:extLst>
           </p:cNvPr>
@@ -4968,7 +4968,7 @@
           <p:cNvPr id="3" name="DEPO  /  Functional architecture">
             <a:extLst xmlns:a="http://schemas.openxmlformats.org/drawingml/2006/main">
               <a:ext uri="{FF2B5EF4-FFF2-40B4-BE49-F238E27FC236}">
-                <a16:creationId xmlns:a16="http://schemas.microsoft.com/office/drawing/2014/main" id="{0D1649BE-7A18-4642-9E1D-DD052A983C64}"/>
+                <a16:creationId xmlns:a16="http://schemas.microsoft.com/office/drawing/2014/main" id="{CBCDCF09-94B7-49DA-BFDF-F6F45076BF9F}"/>
               </a:ext>
             </a:extLst>
           </p:cNvPr>
@@ -5025,7 +5025,7 @@
           <p:cNvPr id="4" name="12">
             <a:extLst xmlns:a="http://schemas.openxmlformats.org/drawingml/2006/main">
               <a:ext uri="{FF2B5EF4-FFF2-40B4-BE49-F238E27FC236}">
-                <a16:creationId xmlns:a16="http://schemas.microsoft.com/office/drawing/2014/main" id="{E5038428-4206-4147-8CC1-78EE4842DF7B}"/>
+                <a16:creationId xmlns:a16="http://schemas.microsoft.com/office/drawing/2014/main" id="{B619E487-9D21-4D09-A111-58D2DBBD4918}"/>
               </a:ext>
             </a:extLst>
           </p:cNvPr>
@@ -5082,7 +5082,7 @@
           <p:cNvPr id="5" name="User request">
             <a:extLst xmlns:a="http://schemas.openxmlformats.org/drawingml/2006/main">
               <a:ext uri="{FF2B5EF4-FFF2-40B4-BE49-F238E27FC236}">
-                <a16:creationId xmlns:a16="http://schemas.microsoft.com/office/drawing/2014/main" id="{C0F751DB-E5F1-42B7-81AB-29784AC83261}"/>
+                <a16:creationId xmlns:a16="http://schemas.microsoft.com/office/drawing/2014/main" id="{23018E6D-844B-4F38-BE49-670F227439CC}"/>
               </a:ext>
             </a:extLst>
           </p:cNvPr>
@@ -5169,7 +5169,7 @@
           <p:cNvPr id="6" name="Agentic service">
             <a:extLst xmlns:a="http://schemas.openxmlformats.org/drawingml/2006/main">
               <a:ext uri="{FF2B5EF4-FFF2-40B4-BE49-F238E27FC236}">
-                <a16:creationId xmlns:a16="http://schemas.microsoft.com/office/drawing/2014/main" id="{B04D0B9D-4AD1-4133-B5EC-68A3E04FF2C1}"/>
+                <a16:creationId xmlns:a16="http://schemas.microsoft.com/office/drawing/2014/main" id="{9FF198BD-70F3-43D0-87F4-A38D5FCAFE5B}"/>
               </a:ext>
             </a:extLst>
           </p:cNvPr>
@@ -5256,7 +5256,7 @@
           <p:cNvPr id="7" name="Serving APIs">
             <a:extLst xmlns:a="http://schemas.openxmlformats.org/drawingml/2006/main">
               <a:ext uri="{FF2B5EF4-FFF2-40B4-BE49-F238E27FC236}">
-                <a16:creationId xmlns:a16="http://schemas.microsoft.com/office/drawing/2014/main" id="{3584377F-5093-4928-BEEC-F489DCBBF082}"/>
+                <a16:creationId xmlns:a16="http://schemas.microsoft.com/office/drawing/2014/main" id="{70963B78-C35B-4786-98C0-A255FCE8D59D}"/>
               </a:ext>
             </a:extLst>
           </p:cNvPr>
@@ -5343,7 +5343,7 @@
           <p:cNvPr id="8" name="Response">
             <a:extLst xmlns:a="http://schemas.openxmlformats.org/drawingml/2006/main">
               <a:ext uri="{FF2B5EF4-FFF2-40B4-BE49-F238E27FC236}">
-                <a16:creationId xmlns:a16="http://schemas.microsoft.com/office/drawing/2014/main" id="{64A4970A-109D-4BEC-8675-0F2491555AC0}"/>
+                <a16:creationId xmlns:a16="http://schemas.microsoft.com/office/drawing/2014/main" id="{98865D50-5D7F-47CB-A7FB-9EC0C5C10AD8}"/>
               </a:ext>
             </a:extLst>
           </p:cNvPr>
@@ -5505,7 +5505,7 @@
           <p:cNvPr id="12" name="Mutation requests">
             <a:extLst xmlns:a="http://schemas.openxmlformats.org/drawingml/2006/main">
               <a:ext uri="{FF2B5EF4-FFF2-40B4-BE49-F238E27FC236}">
-                <a16:creationId xmlns:a16="http://schemas.microsoft.com/office/drawing/2014/main" id="{576868A0-DC7F-4BB5-A3FA-495C4F2907B3}"/>
+                <a16:creationId xmlns:a16="http://schemas.microsoft.com/office/drawing/2014/main" id="{37D1B4C6-EFBF-4FA0-B431-0470CB4C77D9}"/>
               </a:ext>
             </a:extLst>
           </p:cNvPr>
@@ -5562,7 +5562,7 @@
           <p:cNvPr id="13" name="Tool and Bridge actions require the relevant approval. Services own pu">
             <a:extLst xmlns:a="http://schemas.openxmlformats.org/drawingml/2006/main">
               <a:ext uri="{FF2B5EF4-FFF2-40B4-BE49-F238E27FC236}">
-                <a16:creationId xmlns:a16="http://schemas.microsoft.com/office/drawing/2014/main" id="{A547C17E-480D-4865-B280-A0DCF4E5BA7F}"/>
+                <a16:creationId xmlns:a16="http://schemas.microsoft.com/office/drawing/2014/main" id="{60A1E75A-2397-4290-AE88-C3453D7362DE}"/>
               </a:ext>
             </a:extLst>
           </p:cNvPr>
@@ -5619,7 +5619,7 @@
           <p:cNvPr id="14" name="Optional integrations">
             <a:extLst xmlns:a="http://schemas.openxmlformats.org/drawingml/2006/main">
               <a:ext uri="{FF2B5EF4-FFF2-40B4-BE49-F238E27FC236}">
-                <a16:creationId xmlns:a16="http://schemas.microsoft.com/office/drawing/2014/main" id="{1343E4B2-14C8-4416-8BDE-84CC220B5CA3}"/>
+                <a16:creationId xmlns:a16="http://schemas.microsoft.com/office/drawing/2014/main" id="{5E095BD9-9B6D-46D3-A191-176C44D0D0D7}"/>
               </a:ext>
             </a:extLst>
           </p:cNvPr>
@@ -5676,7 +5676,7 @@
           <p:cNvPr id="15" name="Remote DT agent and OSLC remain disabled until configured. An external">
             <a:extLst xmlns:a="http://schemas.openxmlformats.org/drawingml/2006/main">
               <a:ext uri="{FF2B5EF4-FFF2-40B4-BE49-F238E27FC236}">
-                <a16:creationId xmlns:a16="http://schemas.microsoft.com/office/drawing/2014/main" id="{EC9C6384-6159-43BA-9F68-6719742B48AF}"/>
+                <a16:creationId xmlns:a16="http://schemas.microsoft.com/office/drawing/2014/main" id="{90A02A0A-C181-42C9-B651-441BECE73C74}"/>
               </a:ext>
             </a:extLst>
           </p:cNvPr>
@@ -5733,7 +5733,7 @@
           <p:cNvPr id="16" name="Bounded SPARQL and approved federation APIs exist. They need configure">
             <a:extLst xmlns:a="http://schemas.openxmlformats.org/drawingml/2006/main">
               <a:ext uri="{FF2B5EF4-FFF2-40B4-BE49-F238E27FC236}">
-                <a16:creationId xmlns:a16="http://schemas.microsoft.com/office/drawing/2014/main" id="{A7D0E07F-5C8D-4BB1-B2F8-75017CAC3CCF}"/>
+                <a16:creationId xmlns:a16="http://schemas.microsoft.com/office/drawing/2014/main" id="{336052E1-F7C3-4DC6-845F-FD9344A1A890}"/>
               </a:ext>
             </a:extLst>
           </p:cNvPr>
@@ -5788,7 +5788,7 @@
     </p:spTree>
     <p:extLst>
       <p:ext uri="{BB962C8B-B14F-4D97-AF65-F5344CB8AC3E}">
-        <p14:creationId xmlns:p14="http://schemas.microsoft.com/office/powerpoint/2010/main" val="1889529611"/>
+        <p14:creationId xmlns:p14="http://schemas.microsoft.com/office/powerpoint/2010/main" val="1656090923"/>
       </p:ext>
     </p:extLst>
   </p:cSld>
@@ -5819,7 +5819,7 @@
           <p:cNvPr id="7" name="Functional workflows in the frontend">
             <a:extLst xmlns:a="http://schemas.openxmlformats.org/drawingml/2006/main">
               <a:ext uri="{FF2B5EF4-FFF2-40B4-BE49-F238E27FC236}">
-                <a16:creationId xmlns:a16="http://schemas.microsoft.com/office/drawing/2014/main" id="{F67E0E5E-7AEF-4D87-96AA-37272E22CEFB}"/>
+                <a16:creationId xmlns:a16="http://schemas.microsoft.com/office/drawing/2014/main" id="{C8BD5CA7-7332-4EBD-8CDF-316DE6B0C365}"/>
               </a:ext>
             </a:extLst>
           </p:cNvPr>
@@ -5876,7 +5876,7 @@
           <p:cNvPr id="2" name="The UI connects user decisions to service-owned evidence and authoriza">
             <a:extLst xmlns:a="http://schemas.openxmlformats.org/drawingml/2006/main">
               <a:ext uri="{FF2B5EF4-FFF2-40B4-BE49-F238E27FC236}">
-                <a16:creationId xmlns:a16="http://schemas.microsoft.com/office/drawing/2014/main" id="{C0C9FBA3-0A6B-4ADD-A416-560684B2B7DE}"/>
+                <a16:creationId xmlns:a16="http://schemas.microsoft.com/office/drawing/2014/main" id="{F4D20C75-4EA0-4891-97D5-3EFEC6851F41}"/>
               </a:ext>
             </a:extLst>
           </p:cNvPr>
@@ -5933,7 +5933,7 @@
           <p:cNvPr id="3" name="DEPO  /  Functional architecture">
             <a:extLst xmlns:a="http://schemas.openxmlformats.org/drawingml/2006/main">
               <a:ext uri="{FF2B5EF4-FFF2-40B4-BE49-F238E27FC236}">
-                <a16:creationId xmlns:a16="http://schemas.microsoft.com/office/drawing/2014/main" id="{8EC5D292-69E7-48AE-8989-319D5E21C132}"/>
+                <a16:creationId xmlns:a16="http://schemas.microsoft.com/office/drawing/2014/main" id="{CB9EA31B-61C7-4B2D-895F-0AA03D038C84}"/>
               </a:ext>
             </a:extLst>
           </p:cNvPr>
@@ -5990,7 +5990,7 @@
           <p:cNvPr id="4" name="13">
             <a:extLst xmlns:a="http://schemas.openxmlformats.org/drawingml/2006/main">
               <a:ext uri="{FF2B5EF4-FFF2-40B4-BE49-F238E27FC236}">
-                <a16:creationId xmlns:a16="http://schemas.microsoft.com/office/drawing/2014/main" id="{67C0EF7C-D755-491E-98FB-10C149FCBF33}"/>
+                <a16:creationId xmlns:a16="http://schemas.microsoft.com/office/drawing/2014/main" id="{09A3088A-A6B2-4659-9995-61F0B4BA39A7}"/>
               </a:ext>
             </a:extLst>
           </p:cNvPr>
@@ -6440,7 +6440,7 @@
           <p:cNvPr id="6" name="Read credentials and approval credentials serve different operations. ">
             <a:extLst xmlns:a="http://schemas.openxmlformats.org/drawingml/2006/main">
               <a:ext uri="{FF2B5EF4-FFF2-40B4-BE49-F238E27FC236}">
-                <a16:creationId xmlns:a16="http://schemas.microsoft.com/office/drawing/2014/main" id="{75CB38D3-4B84-461D-9360-F8441D75028E}"/>
+                <a16:creationId xmlns:a16="http://schemas.microsoft.com/office/drawing/2014/main" id="{84E4DA61-686A-4B91-9DFA-5DB5FA59F5E2}"/>
               </a:ext>
             </a:extLst>
           </p:cNvPr>
@@ -6495,7 +6495,7 @@
     </p:spTree>
     <p:extLst>
       <p:ext uri="{BB962C8B-B14F-4D97-AF65-F5344CB8AC3E}">
-        <p14:creationId xmlns:p14="http://schemas.microsoft.com/office/powerpoint/2010/main" val="1017920556"/>
+        <p14:creationId xmlns:p14="http://schemas.microsoft.com/office/powerpoint/2010/main" val="2001168931"/>
       </p:ext>
     </p:extLst>
   </p:cSld>
@@ -6526,7 +6526,7 @@
           <p:cNvPr id="16" name="Customer deployment topology">
             <a:extLst xmlns:a="http://schemas.openxmlformats.org/drawingml/2006/main">
               <a:ext uri="{FF2B5EF4-FFF2-40B4-BE49-F238E27FC236}">
-                <a16:creationId xmlns:a16="http://schemas.microsoft.com/office/drawing/2014/main" id="{1D83DC62-DD56-40C3-A0B8-D24A29C52BD3}"/>
+                <a16:creationId xmlns:a16="http://schemas.microsoft.com/office/drawing/2014/main" id="{9F1539E0-164A-4942-BB97-4C2D0CC62F06}"/>
               </a:ext>
             </a:extLst>
           </p:cNvPr>
@@ -6583,7 +6583,7 @@
           <p:cNvPr id="2" name="The same application supports local or customer-managed databases.">
             <a:extLst xmlns:a="http://schemas.openxmlformats.org/drawingml/2006/main">
               <a:ext uri="{FF2B5EF4-FFF2-40B4-BE49-F238E27FC236}">
-                <a16:creationId xmlns:a16="http://schemas.microsoft.com/office/drawing/2014/main" id="{AE2F652B-A4F8-4F87-A544-C11D0888129C}"/>
+                <a16:creationId xmlns:a16="http://schemas.microsoft.com/office/drawing/2014/main" id="{1D1C066F-1B75-4886-A72E-0D5A579A6308}"/>
               </a:ext>
             </a:extLst>
           </p:cNvPr>
@@ -6640,7 +6640,7 @@
           <p:cNvPr id="3" name="DEPO  /  Functional architecture">
             <a:extLst xmlns:a="http://schemas.openxmlformats.org/drawingml/2006/main">
               <a:ext uri="{FF2B5EF4-FFF2-40B4-BE49-F238E27FC236}">
-                <a16:creationId xmlns:a16="http://schemas.microsoft.com/office/drawing/2014/main" id="{B35B9815-220E-4C78-B142-AB73E5D8DDAB}"/>
+                <a16:creationId xmlns:a16="http://schemas.microsoft.com/office/drawing/2014/main" id="{191C3E15-5E6C-4FCC-958B-0AB4A4B2100C}"/>
               </a:ext>
             </a:extLst>
           </p:cNvPr>
@@ -6697,7 +6697,7 @@
           <p:cNvPr id="4" name="14">
             <a:extLst xmlns:a="http://schemas.openxmlformats.org/drawingml/2006/main">
               <a:ext uri="{FF2B5EF4-FFF2-40B4-BE49-F238E27FC236}">
-                <a16:creationId xmlns:a16="http://schemas.microsoft.com/office/drawing/2014/main" id="{C1EB3482-8724-4D0F-837C-09AC11679E72}"/>
+                <a16:creationId xmlns:a16="http://schemas.microsoft.com/office/drawing/2014/main" id="{12E09FA5-2E0C-4067-B111-5C255E885BC5}"/>
               </a:ext>
             </a:extLst>
           </p:cNvPr>
@@ -6754,7 +6754,7 @@
           <p:cNvPr id="5" name="Browser">
             <a:extLst xmlns:a="http://schemas.openxmlformats.org/drawingml/2006/main">
               <a:ext uri="{FF2B5EF4-FFF2-40B4-BE49-F238E27FC236}">
-                <a16:creationId xmlns:a16="http://schemas.microsoft.com/office/drawing/2014/main" id="{77800B0E-902C-453B-8FE4-5366468C9138}"/>
+                <a16:creationId xmlns:a16="http://schemas.microsoft.com/office/drawing/2014/main" id="{CF252C22-A9E8-4548-83D7-775A571B8850}"/>
               </a:ext>
             </a:extLst>
           </p:cNvPr>
@@ -6841,7 +6841,7 @@
           <p:cNvPr id="6" name="Web server / proxy">
             <a:extLst xmlns:a="http://schemas.openxmlformats.org/drawingml/2006/main">
               <a:ext uri="{FF2B5EF4-FFF2-40B4-BE49-F238E27FC236}">
-                <a16:creationId xmlns:a16="http://schemas.microsoft.com/office/drawing/2014/main" id="{3B778BB5-CEAC-4BF7-98B0-B42388BCFED8}"/>
+                <a16:creationId xmlns:a16="http://schemas.microsoft.com/office/drawing/2014/main" id="{85D0C311-46AA-4D6B-8A43-54C749295CF7}"/>
               </a:ext>
             </a:extLst>
           </p:cNvPr>
@@ -6928,7 +6928,7 @@
           <p:cNvPr id="7" name="DEPO services">
             <a:extLst xmlns:a="http://schemas.openxmlformats.org/drawingml/2006/main">
               <a:ext uri="{FF2B5EF4-FFF2-40B4-BE49-F238E27FC236}">
-                <a16:creationId xmlns:a16="http://schemas.microsoft.com/office/drawing/2014/main" id="{B0FF4DED-4806-491B-A1C4-D56C8171B86C}"/>
+                <a16:creationId xmlns:a16="http://schemas.microsoft.com/office/drawing/2014/main" id="{A9278E0A-25D5-457D-95C3-6689E3FC4E96}"/>
               </a:ext>
             </a:extLst>
           </p:cNvPr>
@@ -7065,7 +7065,7 @@
           <p:cNvPr id="10" name="PostgreSQL">
             <a:extLst xmlns:a="http://schemas.openxmlformats.org/drawingml/2006/main">
               <a:ext uri="{FF2B5EF4-FFF2-40B4-BE49-F238E27FC236}">
-                <a16:creationId xmlns:a16="http://schemas.microsoft.com/office/drawing/2014/main" id="{AD010A30-0330-4952-A824-09FCB470A2CC}"/>
+                <a16:creationId xmlns:a16="http://schemas.microsoft.com/office/drawing/2014/main" id="{112C7075-E60F-4CD2-B426-221E205E4DDF}"/>
               </a:ext>
             </a:extLst>
           </p:cNvPr>
@@ -7122,7 +7122,7 @@
           <p:cNvPr id="11" name="Local service, portable instance or managed database. Application sche">
             <a:extLst xmlns:a="http://schemas.openxmlformats.org/drawingml/2006/main">
               <a:ext uri="{FF2B5EF4-FFF2-40B4-BE49-F238E27FC236}">
-                <a16:creationId xmlns:a16="http://schemas.microsoft.com/office/drawing/2014/main" id="{A9FB39B6-6E1D-4AE6-9784-9C08CB01BCBC}"/>
+                <a16:creationId xmlns:a16="http://schemas.microsoft.com/office/drawing/2014/main" id="{51A1D99A-4103-4F54-96CE-4DCA044529CD}"/>
               </a:ext>
             </a:extLst>
           </p:cNvPr>
@@ -7179,7 +7179,7 @@
           <p:cNvPr id="12" name="Neo4j">
             <a:extLst xmlns:a="http://schemas.openxmlformats.org/drawingml/2006/main">
               <a:ext uri="{FF2B5EF4-FFF2-40B4-BE49-F238E27FC236}">
-                <a16:creationId xmlns:a16="http://schemas.microsoft.com/office/drawing/2014/main" id="{06DA2952-7825-4BD3-8556-2DCA36EEE60F}"/>
+                <a16:creationId xmlns:a16="http://schemas.microsoft.com/office/drawing/2014/main" id="{E196BE72-3145-4ACC-836B-3B1E88D0AB2D}"/>
               </a:ext>
             </a:extLst>
           </p:cNvPr>
@@ -7236,7 +7236,7 @@
           <p:cNvPr id="13" name="On-premises, hosted server or Aura. Production uses verified TLS with ">
             <a:extLst xmlns:a="http://schemas.openxmlformats.org/drawingml/2006/main">
               <a:ext uri="{FF2B5EF4-FFF2-40B4-BE49-F238E27FC236}">
-                <a16:creationId xmlns:a16="http://schemas.microsoft.com/office/drawing/2014/main" id="{78F49BD0-1617-455F-A1FA-D1CC4DCC3182}"/>
+                <a16:creationId xmlns:a16="http://schemas.microsoft.com/office/drawing/2014/main" id="{91573629-866F-404C-90E8-14382648DD04}"/>
               </a:ext>
             </a:extLst>
           </p:cNvPr>
@@ -7293,7 +7293,7 @@
           <p:cNvPr id="14" name="Spark / PySpark">
             <a:extLst xmlns:a="http://schemas.openxmlformats.org/drawingml/2006/main">
               <a:ext uri="{FF2B5EF4-FFF2-40B4-BE49-F238E27FC236}">
-                <a16:creationId xmlns:a16="http://schemas.microsoft.com/office/drawing/2014/main" id="{CB0FCEC9-40D4-481B-83D3-4886F665FB26}"/>
+                <a16:creationId xmlns:a16="http://schemas.microsoft.com/office/drawing/2014/main" id="{BD2F7F2E-C11A-41C1-B143-7E02D078B2A8}"/>
               </a:ext>
             </a:extLst>
           </p:cNvPr>
@@ -7350,7 +7350,7 @@
           <p:cNvPr id="15" name="Optional compute beside the pipeline service. Spark 4.1.2, Scala 2.13 ">
             <a:extLst xmlns:a="http://schemas.openxmlformats.org/drawingml/2006/main">
               <a:ext uri="{FF2B5EF4-FFF2-40B4-BE49-F238E27FC236}">
-                <a16:creationId xmlns:a16="http://schemas.microsoft.com/office/drawing/2014/main" id="{BA3236FE-129E-4229-8A7D-E66514E428C4}"/>
+                <a16:creationId xmlns:a16="http://schemas.microsoft.com/office/drawing/2014/main" id="{AE62DE0E-9DF6-4127-8C82-52973C92915C}"/>
               </a:ext>
             </a:extLst>
           </p:cNvPr>
@@ -7405,7 +7405,7 @@
     </p:spTree>
     <p:extLst>
       <p:ext uri="{BB962C8B-B14F-4D97-AF65-F5344CB8AC3E}">
-        <p14:creationId xmlns:p14="http://schemas.microsoft.com/office/powerpoint/2010/main" val="740856511"/>
+        <p14:creationId xmlns:p14="http://schemas.microsoft.com/office/powerpoint/2010/main" val="1100213672"/>
       </p:ext>
     </p:extLst>
   </p:cSld>
@@ -7436,7 +7436,7 @@
           <p:cNvPr id="16" name="One application installation sequence">
             <a:extLst xmlns:a="http://schemas.openxmlformats.org/drawingml/2006/main">
               <a:ext uri="{FF2B5EF4-FFF2-40B4-BE49-F238E27FC236}">
-                <a16:creationId xmlns:a16="http://schemas.microsoft.com/office/drawing/2014/main" id="{CAC88DBD-9F8B-4B6A-BF5B-E4AA58C27204}"/>
+                <a16:creationId xmlns:a16="http://schemas.microsoft.com/office/drawing/2014/main" id="{5E7B0D97-B7DC-48B4-840A-E7F2CF638FE2}"/>
               </a:ext>
             </a:extLst>
           </p:cNvPr>
@@ -7493,7 +7493,7 @@
           <p:cNvPr id="2" name="A single installer owns frontend dependencies and the backend Python e">
             <a:extLst xmlns:a="http://schemas.openxmlformats.org/drawingml/2006/main">
               <a:ext uri="{FF2B5EF4-FFF2-40B4-BE49-F238E27FC236}">
-                <a16:creationId xmlns:a16="http://schemas.microsoft.com/office/drawing/2014/main" id="{5F63816E-1530-49CA-9538-7A707A3E5FB5}"/>
+                <a16:creationId xmlns:a16="http://schemas.microsoft.com/office/drawing/2014/main" id="{C1E822A3-CE9A-4044-A45C-2158BAEDD563}"/>
               </a:ext>
             </a:extLst>
           </p:cNvPr>
@@ -7550,7 +7550,7 @@
           <p:cNvPr id="3" name="DEPO  /  Functional architecture">
             <a:extLst xmlns:a="http://schemas.openxmlformats.org/drawingml/2006/main">
               <a:ext uri="{FF2B5EF4-FFF2-40B4-BE49-F238E27FC236}">
-                <a16:creationId xmlns:a16="http://schemas.microsoft.com/office/drawing/2014/main" id="{9DA1D93C-C4F1-4816-870F-AFAD7475B4ED}"/>
+                <a16:creationId xmlns:a16="http://schemas.microsoft.com/office/drawing/2014/main" id="{B096D4B8-73AE-443D-94C0-B963432A66D9}"/>
               </a:ext>
             </a:extLst>
           </p:cNvPr>
@@ -7607,7 +7607,7 @@
           <p:cNvPr id="4" name="15">
             <a:extLst xmlns:a="http://schemas.openxmlformats.org/drawingml/2006/main">
               <a:ext uri="{FF2B5EF4-FFF2-40B4-BE49-F238E27FC236}">
-                <a16:creationId xmlns:a16="http://schemas.microsoft.com/office/drawing/2014/main" id="{FABEDF8E-DC81-43A1-8533-806970129903}"/>
+                <a16:creationId xmlns:a16="http://schemas.microsoft.com/office/drawing/2014/main" id="{D53CF125-6372-431F-B1F6-A12065A6735A}"/>
               </a:ext>
             </a:extLst>
           </p:cNvPr>
@@ -7664,7 +7664,7 @@
           <p:cNvPr id="5" name="1  Provision">
             <a:extLst xmlns:a="http://schemas.openxmlformats.org/drawingml/2006/main">
               <a:ext uri="{FF2B5EF4-FFF2-40B4-BE49-F238E27FC236}">
-                <a16:creationId xmlns:a16="http://schemas.microsoft.com/office/drawing/2014/main" id="{CB9F33ED-B3F0-4927-BFC4-4E1987C07DBF}"/>
+                <a16:creationId xmlns:a16="http://schemas.microsoft.com/office/drawing/2014/main" id="{5156253B-8EDD-4440-BFD0-81F4513E79DE}"/>
               </a:ext>
             </a:extLst>
           </p:cNvPr>
@@ -7751,7 +7751,7 @@
           <p:cNvPr id="6" name="2  Configure">
             <a:extLst xmlns:a="http://schemas.openxmlformats.org/drawingml/2006/main">
               <a:ext uri="{FF2B5EF4-FFF2-40B4-BE49-F238E27FC236}">
-                <a16:creationId xmlns:a16="http://schemas.microsoft.com/office/drawing/2014/main" id="{C096EA1A-6BF1-4CA6-B139-DAEF2D1F4CC7}"/>
+                <a16:creationId xmlns:a16="http://schemas.microsoft.com/office/drawing/2014/main" id="{4DCB5014-CA79-4F69-8748-60EDAAF52948}"/>
               </a:ext>
             </a:extLst>
           </p:cNvPr>
@@ -7838,7 +7838,7 @@
           <p:cNvPr id="7" name="3  Install">
             <a:extLst xmlns:a="http://schemas.openxmlformats.org/drawingml/2006/main">
               <a:ext uri="{FF2B5EF4-FFF2-40B4-BE49-F238E27FC236}">
-                <a16:creationId xmlns:a16="http://schemas.microsoft.com/office/drawing/2014/main" id="{876DCC1E-28AA-4823-9701-2A2CA3313B33}"/>
+                <a16:creationId xmlns:a16="http://schemas.microsoft.com/office/drawing/2014/main" id="{4B8110AA-5F2E-47CB-A8DD-2C6C0F2710B0}"/>
               </a:ext>
             </a:extLst>
           </p:cNvPr>
@@ -7925,7 +7925,7 @@
           <p:cNvPr id="8" name="4  Initialize">
             <a:extLst xmlns:a="http://schemas.openxmlformats.org/drawingml/2006/main">
               <a:ext uri="{FF2B5EF4-FFF2-40B4-BE49-F238E27FC236}">
-                <a16:creationId xmlns:a16="http://schemas.microsoft.com/office/drawing/2014/main" id="{8DEF63C6-3D04-451D-B6F2-44540282D2D5}"/>
+                <a16:creationId xmlns:a16="http://schemas.microsoft.com/office/drawing/2014/main" id="{4E9A3D33-FE6C-41D8-A2AD-50BDF899D1DE}"/>
               </a:ext>
             </a:extLst>
           </p:cNvPr>
@@ -8087,7 +8087,7 @@
           <p:cNvPr id="12" name="Runtime baseline">
             <a:extLst xmlns:a="http://schemas.openxmlformats.org/drawingml/2006/main">
               <a:ext uri="{FF2B5EF4-FFF2-40B4-BE49-F238E27FC236}">
-                <a16:creationId xmlns:a16="http://schemas.microsoft.com/office/drawing/2014/main" id="{66108A26-1E91-40CB-A80E-43221B62AFFB}"/>
+                <a16:creationId xmlns:a16="http://schemas.microsoft.com/office/drawing/2014/main" id="{753CAB91-4075-42E4-84A3-253F9769A02E}"/>
               </a:ext>
             </a:extLst>
           </p:cNvPr>
@@ -8144,7 +8144,7 @@
           <p:cNvPr id="13" name="Python 3.11+, Node.js 24+ and npm 10.2+. PySpark comes from the approv">
             <a:extLst xmlns:a="http://schemas.openxmlformats.org/drawingml/2006/main">
               <a:ext uri="{FF2B5EF4-FFF2-40B4-BE49-F238E27FC236}">
-                <a16:creationId xmlns:a16="http://schemas.microsoft.com/office/drawing/2014/main" id="{E3EBF056-C3A5-41F3-BB3E-6F7AC4D33111}"/>
+                <a16:creationId xmlns:a16="http://schemas.microsoft.com/office/drawing/2014/main" id="{48D1E69A-9FF4-4850-B0C3-CE194FD69C61}"/>
               </a:ext>
             </a:extLst>
           </p:cNvPr>
@@ -8201,7 +8201,7 @@
           <p:cNvPr id="14" name="Start and accept">
             <a:extLst xmlns:a="http://schemas.openxmlformats.org/drawingml/2006/main">
               <a:ext uri="{FF2B5EF4-FFF2-40B4-BE49-F238E27FC236}">
-                <a16:creationId xmlns:a16="http://schemas.microsoft.com/office/drawing/2014/main" id="{8891CC4B-73C6-4DA8-8F97-63C13FDBB0CD}"/>
+                <a16:creationId xmlns:a16="http://schemas.microsoft.com/office/drawing/2014/main" id="{9A791C0C-D959-4C24-AEC7-D324D4C40B27}"/>
               </a:ext>
             </a:extLst>
           </p:cNvPr>
@@ -8258,7 +8258,7 @@
           <p:cNvPr id="15" name="Start services, serve frontend/dist, run Production preflight and veri">
             <a:extLst xmlns:a="http://schemas.openxmlformats.org/drawingml/2006/main">
               <a:ext uri="{FF2B5EF4-FFF2-40B4-BE49-F238E27FC236}">
-                <a16:creationId xmlns:a16="http://schemas.microsoft.com/office/drawing/2014/main" id="{0F45C4AA-CE5B-449A-BE82-E6F26576267E}"/>
+                <a16:creationId xmlns:a16="http://schemas.microsoft.com/office/drawing/2014/main" id="{6ED2EB6D-C609-4EA5-824D-CDC4ED13C901}"/>
               </a:ext>
             </a:extLst>
           </p:cNvPr>
@@ -8313,7 +8313,7 @@
     </p:spTree>
     <p:extLst>
       <p:ext uri="{BB962C8B-B14F-4D97-AF65-F5344CB8AC3E}">
-        <p14:creationId xmlns:p14="http://schemas.microsoft.com/office/powerpoint/2010/main" val="1968032458"/>
+        <p14:creationId xmlns:p14="http://schemas.microsoft.com/office/powerpoint/2010/main" val="1987408256"/>
       </p:ext>
     </p:extLst>
   </p:cSld>
@@ -8344,7 +8344,7 @@
           <p:cNvPr id="7" name="PostgreSQL ownership and schema checks">
             <a:extLst xmlns:a="http://schemas.openxmlformats.org/drawingml/2006/main">
               <a:ext uri="{FF2B5EF4-FFF2-40B4-BE49-F238E27FC236}">
-                <a16:creationId xmlns:a16="http://schemas.microsoft.com/office/drawing/2014/main" id="{E25A943B-0B1F-4980-BC6C-77A7FE67188C}"/>
+                <a16:creationId xmlns:a16="http://schemas.microsoft.com/office/drawing/2014/main" id="{4E469165-8789-459D-A6E8-53889D64FCAA}"/>
               </a:ext>
             </a:extLst>
           </p:cNvPr>
@@ -8401,7 +8401,7 @@
           <p:cNvPr id="2" name="Eight tables and one view contain forty required columns. JSON documen">
             <a:extLst xmlns:a="http://schemas.openxmlformats.org/drawingml/2006/main">
               <a:ext uri="{FF2B5EF4-FFF2-40B4-BE49-F238E27FC236}">
-                <a16:creationId xmlns:a16="http://schemas.microsoft.com/office/drawing/2014/main" id="{F57DFB51-A585-47AE-AAEE-CC9AB203C450}"/>
+                <a16:creationId xmlns:a16="http://schemas.microsoft.com/office/drawing/2014/main" id="{C4A91A9C-9468-47BD-A73A-041BF4AF34B8}"/>
               </a:ext>
             </a:extLst>
           </p:cNvPr>
@@ -8458,7 +8458,7 @@
           <p:cNvPr id="3" name="DEPO  /  Functional architecture">
             <a:extLst xmlns:a="http://schemas.openxmlformats.org/drawingml/2006/main">
               <a:ext uri="{FF2B5EF4-FFF2-40B4-BE49-F238E27FC236}">
-                <a16:creationId xmlns:a16="http://schemas.microsoft.com/office/drawing/2014/main" id="{C990E7CB-07E9-41B8-A52C-01B73D41ABD6}"/>
+                <a16:creationId xmlns:a16="http://schemas.microsoft.com/office/drawing/2014/main" id="{2827B342-C2D2-4AD4-A3E9-9A8FBBA225D1}"/>
               </a:ext>
             </a:extLst>
           </p:cNvPr>
@@ -8515,7 +8515,7 @@
           <p:cNvPr id="4" name="16">
             <a:extLst xmlns:a="http://schemas.openxmlformats.org/drawingml/2006/main">
               <a:ext uri="{FF2B5EF4-FFF2-40B4-BE49-F238E27FC236}">
-                <a16:creationId xmlns:a16="http://schemas.microsoft.com/office/drawing/2014/main" id="{D25AFE9F-47B0-4A9C-A12F-F3E2B1CBAD88}"/>
+                <a16:creationId xmlns:a16="http://schemas.microsoft.com/office/drawing/2014/main" id="{801F4ABA-A040-413F-89A5-95838D044BFE}"/>
               </a:ext>
             </a:extLst>
           </p:cNvPr>
@@ -9030,7 +9030,7 @@
           <p:cNvPr id="6" name="InitializeDatabase applies migrations. CheckOnly verifies columns/type">
             <a:extLst xmlns:a="http://schemas.openxmlformats.org/drawingml/2006/main">
               <a:ext uri="{FF2B5EF4-FFF2-40B4-BE49-F238E27FC236}">
-                <a16:creationId xmlns:a16="http://schemas.microsoft.com/office/drawing/2014/main" id="{827F7748-3495-423C-84CB-64A97966566F}"/>
+                <a16:creationId xmlns:a16="http://schemas.microsoft.com/office/drawing/2014/main" id="{D06F4217-375A-4F80-998F-36A10B847C06}"/>
               </a:ext>
             </a:extLst>
           </p:cNvPr>
@@ -9085,7 +9085,7 @@
     </p:spTree>
     <p:extLst>
       <p:ext uri="{BB962C8B-B14F-4D97-AF65-F5344CB8AC3E}">
-        <p14:creationId xmlns:p14="http://schemas.microsoft.com/office/powerpoint/2010/main" val="734730956"/>
+        <p14:creationId xmlns:p14="http://schemas.microsoft.com/office/powerpoint/2010/main" val="502599453"/>
       </p:ext>
     </p:extLst>
   </p:cSld>
@@ -9116,7 +9116,7 @@
           <p:cNvPr id="14" name="API-key authentication and trust boundaries">
             <a:extLst xmlns:a="http://schemas.openxmlformats.org/drawingml/2006/main">
               <a:ext uri="{FF2B5EF4-FFF2-40B4-BE49-F238E27FC236}">
-                <a16:creationId xmlns:a16="http://schemas.microsoft.com/office/drawing/2014/main" id="{C77F8E61-38B4-4E81-A691-419134B676D7}"/>
+                <a16:creationId xmlns:a16="http://schemas.microsoft.com/office/drawing/2014/main" id="{43BF1939-D5D4-4EA4-9393-4725FFC66CAF}"/>
               </a:ext>
             </a:extLst>
           </p:cNvPr>
@@ -9173,7 +9173,7 @@
           <p:cNvPr id="2" name="This delivery uses AUTH_MODE=token. Entra and GitHub Actions are not i">
             <a:extLst xmlns:a="http://schemas.openxmlformats.org/drawingml/2006/main">
               <a:ext uri="{FF2B5EF4-FFF2-40B4-BE49-F238E27FC236}">
-                <a16:creationId xmlns:a16="http://schemas.microsoft.com/office/drawing/2014/main" id="{BCEE32D5-F832-42EE-A77F-A3A6F71CB5BC}"/>
+                <a16:creationId xmlns:a16="http://schemas.microsoft.com/office/drawing/2014/main" id="{2E5955EF-A8A3-4702-AA93-50E6D07B3C0C}"/>
               </a:ext>
             </a:extLst>
           </p:cNvPr>
@@ -9230,7 +9230,7 @@
           <p:cNvPr id="3" name="DEPO  /  Functional architecture">
             <a:extLst xmlns:a="http://schemas.openxmlformats.org/drawingml/2006/main">
               <a:ext uri="{FF2B5EF4-FFF2-40B4-BE49-F238E27FC236}">
-                <a16:creationId xmlns:a16="http://schemas.microsoft.com/office/drawing/2014/main" id="{67E13E90-A82A-4F89-952E-893E8FD5B0B9}"/>
+                <a16:creationId xmlns:a16="http://schemas.microsoft.com/office/drawing/2014/main" id="{DEAA5A3D-D630-485D-B449-671571120C34}"/>
               </a:ext>
             </a:extLst>
           </p:cNvPr>
@@ -9287,7 +9287,7 @@
           <p:cNvPr id="4" name="17">
             <a:extLst xmlns:a="http://schemas.openxmlformats.org/drawingml/2006/main">
               <a:ext uri="{FF2B5EF4-FFF2-40B4-BE49-F238E27FC236}">
-                <a16:creationId xmlns:a16="http://schemas.microsoft.com/office/drawing/2014/main" id="{E146A254-780C-4C3E-B72F-CCE636676B13}"/>
+                <a16:creationId xmlns:a16="http://schemas.microsoft.com/office/drawing/2014/main" id="{EE33492C-F7FA-4E23-8D0B-B94C819E69BC}"/>
               </a:ext>
             </a:extLst>
           </p:cNvPr>
@@ -9344,7 +9344,7 @@
           <p:cNvPr id="5" name="User access">
             <a:extLst xmlns:a="http://schemas.openxmlformats.org/drawingml/2006/main">
               <a:ext uri="{FF2B5EF4-FFF2-40B4-BE49-F238E27FC236}">
-                <a16:creationId xmlns:a16="http://schemas.microsoft.com/office/drawing/2014/main" id="{858BF5AE-6FE7-45AE-AA16-CDD87C2B96D3}"/>
+                <a16:creationId xmlns:a16="http://schemas.microsoft.com/office/drawing/2014/main" id="{338079B4-8D7E-4D5B-96F9-8BDBA7123B83}"/>
               </a:ext>
             </a:extLst>
           </p:cNvPr>
@@ -9431,7 +9431,7 @@
           <p:cNvPr id="6" name="Approval">
             <a:extLst xmlns:a="http://schemas.openxmlformats.org/drawingml/2006/main">
               <a:ext uri="{FF2B5EF4-FFF2-40B4-BE49-F238E27FC236}">
-                <a16:creationId xmlns:a16="http://schemas.microsoft.com/office/drawing/2014/main" id="{56DFC814-037C-4A30-840A-FEEBDE4721D8}"/>
+                <a16:creationId xmlns:a16="http://schemas.microsoft.com/office/drawing/2014/main" id="{4289E52E-FADB-4F28-A6B4-BDD1D79C662C}"/>
               </a:ext>
             </a:extLst>
           </p:cNvPr>
@@ -9518,7 +9518,7 @@
           <p:cNvPr id="7" name="Service call">
             <a:extLst xmlns:a="http://schemas.openxmlformats.org/drawingml/2006/main">
               <a:ext uri="{FF2B5EF4-FFF2-40B4-BE49-F238E27FC236}">
-                <a16:creationId xmlns:a16="http://schemas.microsoft.com/office/drawing/2014/main" id="{E98A3ACE-8670-4B0E-9316-FCC9CA25B374}"/>
+                <a16:creationId xmlns:a16="http://schemas.microsoft.com/office/drawing/2014/main" id="{41FBC5B4-8939-47F0-B688-7196AC2F43F7}"/>
               </a:ext>
             </a:extLst>
           </p:cNvPr>
@@ -9655,7 +9655,7 @@
           <p:cNvPr id="10" name="Configuration">
             <a:extLst xmlns:a="http://schemas.openxmlformats.org/drawingml/2006/main">
               <a:ext uri="{FF2B5EF4-FFF2-40B4-BE49-F238E27FC236}">
-                <a16:creationId xmlns:a16="http://schemas.microsoft.com/office/drawing/2014/main" id="{D439B759-10AB-4575-9E15-EA91BD2C737E}"/>
+                <a16:creationId xmlns:a16="http://schemas.microsoft.com/office/drawing/2014/main" id="{1E091FE4-0CC4-4167-8EE9-974AA7C6A06B}"/>
               </a:ext>
             </a:extLst>
           </p:cNvPr>
@@ -9712,7 +9712,7 @@
           <p:cNvPr id="11" name="One root server env. No duplicate keys. VITE settings contain only pub">
             <a:extLst xmlns:a="http://schemas.openxmlformats.org/drawingml/2006/main">
               <a:ext uri="{FF2B5EF4-FFF2-40B4-BE49-F238E27FC236}">
-                <a16:creationId xmlns:a16="http://schemas.microsoft.com/office/drawing/2014/main" id="{0D72EFCA-5C9C-43F9-AAD6-54E0BCBB5ACD}"/>
+                <a16:creationId xmlns:a16="http://schemas.microsoft.com/office/drawing/2014/main" id="{B0081D02-0577-41EB-8418-D4BCECB1DA67}"/>
               </a:ext>
             </a:extLst>
           </p:cNvPr>
@@ -9769,7 +9769,7 @@
           <p:cNvPr id="12" name="Customer controls">
             <a:extLst xmlns:a="http://schemas.openxmlformats.org/drawingml/2006/main">
               <a:ext uri="{FF2B5EF4-FFF2-40B4-BE49-F238E27FC236}">
-                <a16:creationId xmlns:a16="http://schemas.microsoft.com/office/drawing/2014/main" id="{0D91C443-C6C2-4BF1-A389-033CBD0E22D8}"/>
+                <a16:creationId xmlns:a16="http://schemas.microsoft.com/office/drawing/2014/main" id="{0FDC77E8-57A5-42BE-B652-9FCF2E7C308D}"/>
               </a:ext>
             </a:extLst>
           </p:cNvPr>
@@ -9826,7 +9826,7 @@
           <p:cNvPr id="13" name="HTTPS ingress, distinct strong keys, protected secret storage, rotatio">
             <a:extLst xmlns:a="http://schemas.openxmlformats.org/drawingml/2006/main">
               <a:ext uri="{FF2B5EF4-FFF2-40B4-BE49-F238E27FC236}">
-                <a16:creationId xmlns:a16="http://schemas.microsoft.com/office/drawing/2014/main" id="{795DC9C6-0E14-4DCA-8630-EC03B2DBABBC}"/>
+                <a16:creationId xmlns:a16="http://schemas.microsoft.com/office/drawing/2014/main" id="{51DD0F24-9AE1-4249-9D77-78F3856FA8DB}"/>
               </a:ext>
             </a:extLst>
           </p:cNvPr>
@@ -9881,7 +9881,7 @@
     </p:spTree>
     <p:extLst>
       <p:ext uri="{BB962C8B-B14F-4D97-AF65-F5344CB8AC3E}">
-        <p14:creationId xmlns:p14="http://schemas.microsoft.com/office/powerpoint/2010/main" val="983308199"/>
+        <p14:creationId xmlns:p14="http://schemas.microsoft.com/office/powerpoint/2010/main" val="801105042"/>
       </p:ext>
     </p:extLst>
   </p:cSld>
@@ -9912,7 +9912,7 @@
           <p:cNvPr id="7" name="Customer release acceptance">
             <a:extLst xmlns:a="http://schemas.openxmlformats.org/drawingml/2006/main">
               <a:ext uri="{FF2B5EF4-FFF2-40B4-BE49-F238E27FC236}">
-                <a16:creationId xmlns:a16="http://schemas.microsoft.com/office/drawing/2014/main" id="{99601719-9827-4597-85C3-38410F6E3167}"/>
+                <a16:creationId xmlns:a16="http://schemas.microsoft.com/office/drawing/2014/main" id="{19147DA4-C403-4509-8E79-E1177B22C5AE}"/>
               </a:ext>
             </a:extLst>
           </p:cNvPr>
@@ -9969,7 +9969,7 @@
           <p:cNvPr id="2" name="Repository checks support deployment. Target-environment evidence dete">
             <a:extLst xmlns:a="http://schemas.openxmlformats.org/drawingml/2006/main">
               <a:ext uri="{FF2B5EF4-FFF2-40B4-BE49-F238E27FC236}">
-                <a16:creationId xmlns:a16="http://schemas.microsoft.com/office/drawing/2014/main" id="{D44580FA-0EAF-44C3-9801-F90C65D9BB79}"/>
+                <a16:creationId xmlns:a16="http://schemas.microsoft.com/office/drawing/2014/main" id="{0B7EA527-9D95-4C13-8881-60AD2024958A}"/>
               </a:ext>
             </a:extLst>
           </p:cNvPr>
@@ -10026,7 +10026,7 @@
           <p:cNvPr id="3" name="DEPO  /  Functional architecture">
             <a:extLst xmlns:a="http://schemas.openxmlformats.org/drawingml/2006/main">
               <a:ext uri="{FF2B5EF4-FFF2-40B4-BE49-F238E27FC236}">
-                <a16:creationId xmlns:a16="http://schemas.microsoft.com/office/drawing/2014/main" id="{C9245B56-A639-4C53-B572-3A2985B74A8F}"/>
+                <a16:creationId xmlns:a16="http://schemas.microsoft.com/office/drawing/2014/main" id="{9657DB7B-E2D3-48F0-9243-5A40B97AE1F4}"/>
               </a:ext>
             </a:extLst>
           </p:cNvPr>
@@ -10083,7 +10083,7 @@
           <p:cNvPr id="4" name="18">
             <a:extLst xmlns:a="http://schemas.openxmlformats.org/drawingml/2006/main">
               <a:ext uri="{FF2B5EF4-FFF2-40B4-BE49-F238E27FC236}">
-                <a16:creationId xmlns:a16="http://schemas.microsoft.com/office/drawing/2014/main" id="{7AC02261-C999-476B-9412-62010887E579}"/>
+                <a16:creationId xmlns:a16="http://schemas.microsoft.com/office/drawing/2014/main" id="{89A8F5EC-8C28-4917-B6AB-7988D963E60C}"/>
               </a:ext>
             </a:extLst>
           </p:cNvPr>
@@ -10462,7 +10462,7 @@
           <p:cNvPr id="6" name="Open release gates include a certified pinned Python lock and live cus">
             <a:extLst xmlns:a="http://schemas.openxmlformats.org/drawingml/2006/main">
               <a:ext uri="{FF2B5EF4-FFF2-40B4-BE49-F238E27FC236}">
-                <a16:creationId xmlns:a16="http://schemas.microsoft.com/office/drawing/2014/main" id="{BB4A1D32-2BFA-4F03-BB26-781855B1ADF8}"/>
+                <a16:creationId xmlns:a16="http://schemas.microsoft.com/office/drawing/2014/main" id="{A263187B-C26F-4DB4-8E17-A16DE71357D4}"/>
               </a:ext>
             </a:extLst>
           </p:cNvPr>
@@ -10517,7 +10517,7 @@
     </p:spTree>
     <p:extLst>
       <p:ext uri="{BB962C8B-B14F-4D97-AF65-F5344CB8AC3E}">
-        <p14:creationId xmlns:p14="http://schemas.microsoft.com/office/powerpoint/2010/main" val="880760393"/>
+        <p14:creationId xmlns:p14="http://schemas.microsoft.com/office/powerpoint/2010/main" val="941805588"/>
       </p:ext>
     </p:extLst>
   </p:cSld>
@@ -10548,7 +10548,7 @@
           <p:cNvPr id="11" name="Implemented capabilities and bounded next work">
             <a:extLst xmlns:a="http://schemas.openxmlformats.org/drawingml/2006/main">
               <a:ext uri="{FF2B5EF4-FFF2-40B4-BE49-F238E27FC236}">
-                <a16:creationId xmlns:a16="http://schemas.microsoft.com/office/drawing/2014/main" id="{1C721285-F41B-46AC-AF36-2D10CDAB37CA}"/>
+                <a16:creationId xmlns:a16="http://schemas.microsoft.com/office/drawing/2014/main" id="{E4E6FA89-C290-48EB-97C1-2DB27F33EC4E}"/>
               </a:ext>
             </a:extLst>
           </p:cNvPr>
@@ -10605,7 +10605,7 @@
           <p:cNvPr id="2" name="Feature availability and production operation require separate evidenc">
             <a:extLst xmlns:a="http://schemas.openxmlformats.org/drawingml/2006/main">
               <a:ext uri="{FF2B5EF4-FFF2-40B4-BE49-F238E27FC236}">
-                <a16:creationId xmlns:a16="http://schemas.microsoft.com/office/drawing/2014/main" id="{1D3460B4-8E22-454B-90A8-8CAD8511F297}"/>
+                <a16:creationId xmlns:a16="http://schemas.microsoft.com/office/drawing/2014/main" id="{3B3BB356-F648-4108-95BC-34268ECD35A6}"/>
               </a:ext>
             </a:extLst>
           </p:cNvPr>
@@ -10662,7 +10662,7 @@
           <p:cNvPr id="3" name="DEPO  /  Functional architecture">
             <a:extLst xmlns:a="http://schemas.openxmlformats.org/drawingml/2006/main">
               <a:ext uri="{FF2B5EF4-FFF2-40B4-BE49-F238E27FC236}">
-                <a16:creationId xmlns:a16="http://schemas.microsoft.com/office/drawing/2014/main" id="{93FEA57B-51EC-496D-927C-83891F21D5E5}"/>
+                <a16:creationId xmlns:a16="http://schemas.microsoft.com/office/drawing/2014/main" id="{860699C8-4247-490E-972A-4A28C3B35E83}"/>
               </a:ext>
             </a:extLst>
           </p:cNvPr>
@@ -10719,7 +10719,7 @@
           <p:cNvPr id="4" name="19">
             <a:extLst xmlns:a="http://schemas.openxmlformats.org/drawingml/2006/main">
               <a:ext uri="{FF2B5EF4-FFF2-40B4-BE49-F238E27FC236}">
-                <a16:creationId xmlns:a16="http://schemas.microsoft.com/office/drawing/2014/main" id="{AE83D3F8-F18B-4F81-B58B-43106A6F73AA}"/>
+                <a16:creationId xmlns:a16="http://schemas.microsoft.com/office/drawing/2014/main" id="{0C8F1224-AE4F-4AE2-8762-F4461488E2A1}"/>
               </a:ext>
             </a:extLst>
           </p:cNvPr>
@@ -10776,7 +10776,7 @@
           <p:cNvPr id="5" name="Implemented">
             <a:extLst xmlns:a="http://schemas.openxmlformats.org/drawingml/2006/main">
               <a:ext uri="{FF2B5EF4-FFF2-40B4-BE49-F238E27FC236}">
-                <a16:creationId xmlns:a16="http://schemas.microsoft.com/office/drawing/2014/main" id="{5DB07771-4AD7-4669-9689-5084B0B3B054}"/>
+                <a16:creationId xmlns:a16="http://schemas.microsoft.com/office/drawing/2014/main" id="{719C774D-859C-4DC9-A5A8-8E989DA101B1}"/>
               </a:ext>
             </a:extLst>
           </p:cNvPr>
@@ -10833,7 +10833,7 @@
           <p:cNvPr id="6" name="Reviewed Bridge publication&#10;Governed job definitions and runs&#10;RDF prof">
             <a:extLst xmlns:a="http://schemas.openxmlformats.org/drawingml/2006/main">
               <a:ext uri="{FF2B5EF4-FFF2-40B4-BE49-F238E27FC236}">
-                <a16:creationId xmlns:a16="http://schemas.microsoft.com/office/drawing/2014/main" id="{BA80E358-3467-402C-90B9-D55145DD8E55}"/>
+                <a16:creationId xmlns:a16="http://schemas.microsoft.com/office/drawing/2014/main" id="{3B9D073A-6375-4800-9941-C00FD8F6FE32}"/>
               </a:ext>
             </a:extLst>
           </p:cNvPr>
@@ -10982,7 +10982,7 @@
           <p:cNvPr id="7" name="Customer acceptance">
             <a:extLst xmlns:a="http://schemas.openxmlformats.org/drawingml/2006/main">
               <a:ext uri="{FF2B5EF4-FFF2-40B4-BE49-F238E27FC236}">
-                <a16:creationId xmlns:a16="http://schemas.microsoft.com/office/drawing/2014/main" id="{E0736764-AB4E-4701-B8F0-1FF0EC6EEFC3}"/>
+                <a16:creationId xmlns:a16="http://schemas.microsoft.com/office/drawing/2014/main" id="{18E3D551-A867-4808-B5C6-28DA0F2F87F8}"/>
               </a:ext>
             </a:extLst>
           </p:cNvPr>
@@ -11039,7 +11039,7 @@
           <p:cNvPr id="8" name="Source and mapping suitability&#10;API keys and TLS trust&#10;Spark capacity a">
             <a:extLst xmlns:a="http://schemas.openxmlformats.org/drawingml/2006/main">
               <a:ext uri="{FF2B5EF4-FFF2-40B4-BE49-F238E27FC236}">
-                <a16:creationId xmlns:a16="http://schemas.microsoft.com/office/drawing/2014/main" id="{7F90B778-513D-4503-9D3F-852DA7329948}"/>
+                <a16:creationId xmlns:a16="http://schemas.microsoft.com/office/drawing/2014/main" id="{9F1AF00F-E7D6-49EF-9AA0-57A166A9C26B}"/>
               </a:ext>
             </a:extLst>
           </p:cNvPr>
@@ -11188,7 +11188,7 @@
           <p:cNvPr id="9" name="Further product work">
             <a:extLst xmlns:a="http://schemas.openxmlformats.org/drawingml/2006/main">
               <a:ext uri="{FF2B5EF4-FFF2-40B4-BE49-F238E27FC236}">
-                <a16:creationId xmlns:a16="http://schemas.microsoft.com/office/drawing/2014/main" id="{01A5CC4D-FDA0-4314-81D8-55400C53BAE7}"/>
+                <a16:creationId xmlns:a16="http://schemas.microsoft.com/office/drawing/2014/main" id="{79E0F10D-25C6-444A-A986-79ECCC8D1F6C}"/>
               </a:ext>
             </a:extLst>
           </p:cNvPr>
@@ -11245,7 +11245,7 @@
           <p:cNvPr id="10" name="Distributed reasoning and semantic ML need explicit output contracts. ">
             <a:extLst xmlns:a="http://schemas.openxmlformats.org/drawingml/2006/main">
               <a:ext uri="{FF2B5EF4-FFF2-40B4-BE49-F238E27FC236}">
-                <a16:creationId xmlns:a16="http://schemas.microsoft.com/office/drawing/2014/main" id="{52000555-0B45-4862-81C3-66E2A04B2555}"/>
+                <a16:creationId xmlns:a16="http://schemas.microsoft.com/office/drawing/2014/main" id="{75BF3964-F48E-4B89-9646-8DF06626EBEC}"/>
               </a:ext>
             </a:extLst>
           </p:cNvPr>
@@ -11300,7 +11300,7 @@
     </p:spTree>
     <p:extLst>
       <p:ext uri="{BB962C8B-B14F-4D97-AF65-F5344CB8AC3E}">
-        <p14:creationId xmlns:p14="http://schemas.microsoft.com/office/powerpoint/2010/main" val="504375841"/>
+        <p14:creationId xmlns:p14="http://schemas.microsoft.com/office/powerpoint/2010/main" val="597867112"/>
       </p:ext>
     </p:extLst>
   </p:cSld>
@@ -11331,7 +11331,7 @@
           <p:cNvPr id="16" name="Engineering data to usable graph evidence">
             <a:extLst xmlns:a="http://schemas.openxmlformats.org/drawingml/2006/main">
               <a:ext uri="{FF2B5EF4-FFF2-40B4-BE49-F238E27FC236}">
-                <a16:creationId xmlns:a16="http://schemas.microsoft.com/office/drawing/2014/main" id="{E25DDD2F-3892-4FC3-AE3B-9AE8C34C69B6}"/>
+                <a16:creationId xmlns:a16="http://schemas.microsoft.com/office/drawing/2014/main" id="{6A2B7355-051E-404A-9B6A-B2C5DBBDB1D0}"/>
               </a:ext>
             </a:extLst>
           </p:cNvPr>
@@ -11388,7 +11388,7 @@
           <p:cNvPr id="2" name="Each stage has an accountable user and a retained output.">
             <a:extLst xmlns:a="http://schemas.openxmlformats.org/drawingml/2006/main">
               <a:ext uri="{FF2B5EF4-FFF2-40B4-BE49-F238E27FC236}">
-                <a16:creationId xmlns:a16="http://schemas.microsoft.com/office/drawing/2014/main" id="{8E500BF2-53B0-4F6C-89BC-31552B5C486A}"/>
+                <a16:creationId xmlns:a16="http://schemas.microsoft.com/office/drawing/2014/main" id="{D76CB86A-8D4D-4970-B727-29597451CB8F}"/>
               </a:ext>
             </a:extLst>
           </p:cNvPr>
@@ -11445,7 +11445,7 @@
           <p:cNvPr id="3" name="DEPO  /  Functional architecture">
             <a:extLst xmlns:a="http://schemas.openxmlformats.org/drawingml/2006/main">
               <a:ext uri="{FF2B5EF4-FFF2-40B4-BE49-F238E27FC236}">
-                <a16:creationId xmlns:a16="http://schemas.microsoft.com/office/drawing/2014/main" id="{752BB37E-A931-4388-AF27-A571715B4E8D}"/>
+                <a16:creationId xmlns:a16="http://schemas.microsoft.com/office/drawing/2014/main" id="{167F2D76-FFC0-4861-BDAD-B5385C657BBA}"/>
               </a:ext>
             </a:extLst>
           </p:cNvPr>
@@ -11502,7 +11502,7 @@
           <p:cNvPr id="4" name="02">
             <a:extLst xmlns:a="http://schemas.openxmlformats.org/drawingml/2006/main">
               <a:ext uri="{FF2B5EF4-FFF2-40B4-BE49-F238E27FC236}">
-                <a16:creationId xmlns:a16="http://schemas.microsoft.com/office/drawing/2014/main" id="{FF90BA9A-68C3-4112-8303-DE65E577B8D7}"/>
+                <a16:creationId xmlns:a16="http://schemas.microsoft.com/office/drawing/2014/main" id="{2D39212A-5FCC-42AA-B8BC-855FF0BF67FB}"/>
               </a:ext>
             </a:extLst>
           </p:cNvPr>
@@ -11559,7 +11559,7 @@
           <p:cNvPr id="5" name="Capture">
             <a:extLst xmlns:a="http://schemas.openxmlformats.org/drawingml/2006/main">
               <a:ext uri="{FF2B5EF4-FFF2-40B4-BE49-F238E27FC236}">
-                <a16:creationId xmlns:a16="http://schemas.microsoft.com/office/drawing/2014/main" id="{77790F30-268A-4A17-8101-4EF3EE752AE9}"/>
+                <a16:creationId xmlns:a16="http://schemas.microsoft.com/office/drawing/2014/main" id="{F28247B4-1FA7-4F0E-9EA4-BB8655433C48}"/>
               </a:ext>
             </a:extLst>
           </p:cNvPr>
@@ -11646,7 +11646,7 @@
           <p:cNvPr id="6" name="Prepare">
             <a:extLst xmlns:a="http://schemas.openxmlformats.org/drawingml/2006/main">
               <a:ext uri="{FF2B5EF4-FFF2-40B4-BE49-F238E27FC236}">
-                <a16:creationId xmlns:a16="http://schemas.microsoft.com/office/drawing/2014/main" id="{601300D9-9039-415A-8BA1-84A2A2473FAE}"/>
+                <a16:creationId xmlns:a16="http://schemas.microsoft.com/office/drawing/2014/main" id="{4F06F2D9-675E-41AE-A00B-B92B446D8C7F}"/>
               </a:ext>
             </a:extLst>
           </p:cNvPr>
@@ -11733,7 +11733,7 @@
           <p:cNvPr id="7" name="Approve">
             <a:extLst xmlns:a="http://schemas.openxmlformats.org/drawingml/2006/main">
               <a:ext uri="{FF2B5EF4-FFF2-40B4-BE49-F238E27FC236}">
-                <a16:creationId xmlns:a16="http://schemas.microsoft.com/office/drawing/2014/main" id="{B3CEE6C7-AF0F-4C16-A5A4-3933643C351B}"/>
+                <a16:creationId xmlns:a16="http://schemas.microsoft.com/office/drawing/2014/main" id="{5B2C50AE-5F51-40C7-83FE-CA996D51A1CA}"/>
               </a:ext>
             </a:extLst>
           </p:cNvPr>
@@ -11820,7 +11820,7 @@
           <p:cNvPr id="8" name="Consume">
             <a:extLst xmlns:a="http://schemas.openxmlformats.org/drawingml/2006/main">
               <a:ext uri="{FF2B5EF4-FFF2-40B4-BE49-F238E27FC236}">
-                <a16:creationId xmlns:a16="http://schemas.microsoft.com/office/drawing/2014/main" id="{86016CF3-CB5D-4C4B-8C67-79C857CF2702}"/>
+                <a16:creationId xmlns:a16="http://schemas.microsoft.com/office/drawing/2014/main" id="{3F57DD4E-94EB-4FD0-8D32-62E5C024554C}"/>
               </a:ext>
             </a:extLst>
           </p:cNvPr>
@@ -11982,7 +11982,7 @@
           <p:cNvPr id="12" name="Input">
             <a:extLst xmlns:a="http://schemas.openxmlformats.org/drawingml/2006/main">
               <a:ext uri="{FF2B5EF4-FFF2-40B4-BE49-F238E27FC236}">
-                <a16:creationId xmlns:a16="http://schemas.microsoft.com/office/drawing/2014/main" id="{16665FE0-7A98-4ECA-BD46-2487B31CD918}"/>
+                <a16:creationId xmlns:a16="http://schemas.microsoft.com/office/drawing/2014/main" id="{44D4776D-C9F8-4AC6-B725-0B526C675BC9}"/>
               </a:ext>
             </a:extLst>
           </p:cNvPr>
@@ -12039,7 +12039,7 @@
           <p:cNvPr id="13" name="Source artifact, ontology release and intended engineering use case.">
             <a:extLst xmlns:a="http://schemas.openxmlformats.org/drawingml/2006/main">
               <a:ext uri="{FF2B5EF4-FFF2-40B4-BE49-F238E27FC236}">
-                <a16:creationId xmlns:a16="http://schemas.microsoft.com/office/drawing/2014/main" id="{71D7D259-5CAC-448B-8ECB-C62AC1674909}"/>
+                <a16:creationId xmlns:a16="http://schemas.microsoft.com/office/drawing/2014/main" id="{5828A37D-9D74-446C-81FF-4A74891D9C29}"/>
               </a:ext>
             </a:extLst>
           </p:cNvPr>
@@ -12096,7 +12096,7 @@
           <p:cNvPr id="14" name="Retained evidence">
             <a:extLst xmlns:a="http://schemas.openxmlformats.org/drawingml/2006/main">
               <a:ext uri="{FF2B5EF4-FFF2-40B4-BE49-F238E27FC236}">
-                <a16:creationId xmlns:a16="http://schemas.microsoft.com/office/drawing/2014/main" id="{56B80150-7385-4BB4-BCA7-6B480519A2AF}"/>
+                <a16:creationId xmlns:a16="http://schemas.microsoft.com/office/drawing/2014/main" id="{2ADCCA72-5030-40B3-B307-45A63825C8EC}"/>
               </a:ext>
             </a:extLst>
           </p:cNvPr>
@@ -12153,7 +12153,7 @@
           <p:cNvPr id="15" name="Source digest, job/run identity, review decision and publication recei">
             <a:extLst xmlns:a="http://schemas.openxmlformats.org/drawingml/2006/main">
               <a:ext uri="{FF2B5EF4-FFF2-40B4-BE49-F238E27FC236}">
-                <a16:creationId xmlns:a16="http://schemas.microsoft.com/office/drawing/2014/main" id="{C6246059-F042-410B-A935-75C834EEB13C}"/>
+                <a16:creationId xmlns:a16="http://schemas.microsoft.com/office/drawing/2014/main" id="{36D07DDF-2BAD-4578-8C92-1CD6BA312B7C}"/>
               </a:ext>
             </a:extLst>
           </p:cNvPr>
@@ -12208,7 +12208,7 @@
     </p:spTree>
     <p:extLst>
       <p:ext uri="{BB962C8B-B14F-4D97-AF65-F5344CB8AC3E}">
-        <p14:creationId xmlns:p14="http://schemas.microsoft.com/office/powerpoint/2010/main" val="1808088885"/>
+        <p14:creationId xmlns:p14="http://schemas.microsoft.com/office/powerpoint/2010/main" val="1691398884"/>
       </p:ext>
     </p:extLst>
   </p:cSld>
@@ -12239,7 +12239,7 @@
           <p:cNvPr id="7" name="Service inventory and installation references">
             <a:extLst xmlns:a="http://schemas.openxmlformats.org/drawingml/2006/main">
               <a:ext uri="{FF2B5EF4-FFF2-40B4-BE49-F238E27FC236}">
-                <a16:creationId xmlns:a16="http://schemas.microsoft.com/office/drawing/2014/main" id="{E70B66CD-3C35-4C64-B442-B89DCE4A0B65}"/>
+                <a16:creationId xmlns:a16="http://schemas.microsoft.com/office/drawing/2014/main" id="{82B6E1DE-0364-4A3D-BC7F-74C76F31519C}"/>
               </a:ext>
             </a:extLst>
           </p:cNvPr>
@@ -12296,7 +12296,7 @@
           <p:cNvPr id="2" name="Ports describe internal service defaults. The customer web server prov">
             <a:extLst xmlns:a="http://schemas.openxmlformats.org/drawingml/2006/main">
               <a:ext uri="{FF2B5EF4-FFF2-40B4-BE49-F238E27FC236}">
-                <a16:creationId xmlns:a16="http://schemas.microsoft.com/office/drawing/2014/main" id="{A3F35FF2-F7C1-4247-A5D6-7797F907ED46}"/>
+                <a16:creationId xmlns:a16="http://schemas.microsoft.com/office/drawing/2014/main" id="{0B07A97E-5D6B-4C21-83FC-1E6FB397D14C}"/>
               </a:ext>
             </a:extLst>
           </p:cNvPr>
@@ -12353,7 +12353,7 @@
           <p:cNvPr id="3" name="DEPO  /  Functional architecture">
             <a:extLst xmlns:a="http://schemas.openxmlformats.org/drawingml/2006/main">
               <a:ext uri="{FF2B5EF4-FFF2-40B4-BE49-F238E27FC236}">
-                <a16:creationId xmlns:a16="http://schemas.microsoft.com/office/drawing/2014/main" id="{57535EA2-5CEE-4045-90DB-D96933335C2E}"/>
+                <a16:creationId xmlns:a16="http://schemas.microsoft.com/office/drawing/2014/main" id="{FEAC2F63-720D-4AF4-9B1B-867524165802}"/>
               </a:ext>
             </a:extLst>
           </p:cNvPr>
@@ -12410,7 +12410,7 @@
           <p:cNvPr id="4" name="20">
             <a:extLst xmlns:a="http://schemas.openxmlformats.org/drawingml/2006/main">
               <a:ext uri="{FF2B5EF4-FFF2-40B4-BE49-F238E27FC236}">
-                <a16:creationId xmlns:a16="http://schemas.microsoft.com/office/drawing/2014/main" id="{62A6D51A-4B6F-437B-946D-B1A9C969C92F}"/>
+                <a16:creationId xmlns:a16="http://schemas.microsoft.com/office/drawing/2014/main" id="{BD06A8C1-52BE-4A2F-BF14-859B5A4518B3}"/>
               </a:ext>
             </a:extLst>
           </p:cNvPr>
@@ -13301,10 +13301,10 @@
       </p:graphicFrame>
       <p:sp>
         <p:nvSpPr>
-          <p:cNvPr id="6" name="Installation: infra/deployment/README.md&#10;Database columns: infra/postg">
+          <p:cNvPr id="6" name="Installation: INSTALLATION.md&#10;Database columns: infra/postgres/SCHEMA.">
             <a:extLst xmlns:a="http://schemas.openxmlformats.org/drawingml/2006/main">
               <a:ext uri="{FF2B5EF4-FFF2-40B4-BE49-F238E27FC236}">
-                <a16:creationId xmlns:a16="http://schemas.microsoft.com/office/drawing/2014/main" id="{14180248-7A64-4405-81C3-6AAEDAC94C92}"/>
+                <a16:creationId xmlns:a16="http://schemas.microsoft.com/office/drawing/2014/main" id="{385DC656-AC56-4853-9F25-B51571990BEC}"/>
               </a:ext>
             </a:extLst>
           </p:cNvPr>
@@ -13351,7 +13351,7 @@
                 <a:ea typeface="Arial"/>
                 <a:cs typeface="Arial"/>
               </a:rPr>
-              <a:t>Installation: infra/deployment/README.md</a:t>
+              <a:t>Installation: INSTALLATION.md</a:t>
             </a:r>
           </a:p>
           <a:p xmlns:a="http://schemas.openxmlformats.org/drawingml/2006/main">
@@ -13374,7 +13374,7 @@
                 <a:ea typeface="Arial"/>
                 <a:cs typeface="Arial"/>
               </a:rPr>
-              <a:t>Database columns: infra/postgres/SCHEMA.md   |   Neo4j: infra/neo4j/README.md   |   Spark: infra/spark/README.md</a:t>
+              <a:t>Database columns: infra/postgres/SCHEMA.md   |   Neo4j: INSTALLATION.md   |   Spark: INSTALLATION.md</a:t>
             </a:r>
           </a:p>
         </p:txBody>
@@ -13382,7 +13382,7 @@
     </p:spTree>
     <p:extLst>
       <p:ext uri="{BB962C8B-B14F-4D97-AF65-F5344CB8AC3E}">
-        <p14:creationId xmlns:p14="http://schemas.microsoft.com/office/powerpoint/2010/main" val="1339483594"/>
+        <p14:creationId xmlns:p14="http://schemas.microsoft.com/office/powerpoint/2010/main" val="630585979"/>
       </p:ext>
     </p:extLst>
   </p:cSld>
@@ -13413,7 +13413,7 @@
           <p:cNvPr id="15" name="Component responsibilities">
             <a:extLst xmlns:a="http://schemas.openxmlformats.org/drawingml/2006/main">
               <a:ext uri="{FF2B5EF4-FFF2-40B4-BE49-F238E27FC236}">
-                <a16:creationId xmlns:a16="http://schemas.microsoft.com/office/drawing/2014/main" id="{126F8812-73F1-46E6-BC07-1B97148F4079}"/>
+                <a16:creationId xmlns:a16="http://schemas.microsoft.com/office/drawing/2014/main" id="{935DA4A9-8AFB-4AFA-8B00-978D0495BD5C}"/>
               </a:ext>
             </a:extLst>
           </p:cNvPr>
@@ -13470,7 +13470,7 @@
           <p:cNvPr id="2" name="Logical work stages across ten APIs. Detailed call paths follow on the">
             <a:extLst xmlns:a="http://schemas.openxmlformats.org/drawingml/2006/main">
               <a:ext uri="{FF2B5EF4-FFF2-40B4-BE49-F238E27FC236}">
-                <a16:creationId xmlns:a16="http://schemas.microsoft.com/office/drawing/2014/main" id="{75D377F6-C6ED-4450-9B38-BD852545A6B9}"/>
+                <a16:creationId xmlns:a16="http://schemas.microsoft.com/office/drawing/2014/main" id="{29C20917-4AC5-463B-8E38-DDDE2A0AA880}"/>
               </a:ext>
             </a:extLst>
           </p:cNvPr>
@@ -13527,7 +13527,7 @@
           <p:cNvPr id="3" name="DEPO  /  Functional architecture">
             <a:extLst xmlns:a="http://schemas.openxmlformats.org/drawingml/2006/main">
               <a:ext uri="{FF2B5EF4-FFF2-40B4-BE49-F238E27FC236}">
-                <a16:creationId xmlns:a16="http://schemas.microsoft.com/office/drawing/2014/main" id="{40DF6F9E-867C-436F-9F46-06CDA609FEB4}"/>
+                <a16:creationId xmlns:a16="http://schemas.microsoft.com/office/drawing/2014/main" id="{7A2E4059-C776-4E67-9354-75EDCEAE0735}"/>
               </a:ext>
             </a:extLst>
           </p:cNvPr>
@@ -13584,7 +13584,7 @@
           <p:cNvPr id="4" name="03">
             <a:extLst xmlns:a="http://schemas.openxmlformats.org/drawingml/2006/main">
               <a:ext uri="{FF2B5EF4-FFF2-40B4-BE49-F238E27FC236}">
-                <a16:creationId xmlns:a16="http://schemas.microsoft.com/office/drawing/2014/main" id="{98F4178B-1A5B-42D5-9431-2A92AAE79110}"/>
+                <a16:creationId xmlns:a16="http://schemas.microsoft.com/office/drawing/2014/main" id="{BCAC46C6-2074-4387-9BD0-7C93837CC6F7}"/>
               </a:ext>
             </a:extLst>
           </p:cNvPr>
@@ -13641,7 +13641,7 @@
           <p:cNvPr id="5" name="Capture">
             <a:extLst xmlns:a="http://schemas.openxmlformats.org/drawingml/2006/main">
               <a:ext uri="{FF2B5EF4-FFF2-40B4-BE49-F238E27FC236}">
-                <a16:creationId xmlns:a16="http://schemas.microsoft.com/office/drawing/2014/main" id="{A69B028D-C220-45FD-8967-8C7DD3CF73C9}"/>
+                <a16:creationId xmlns:a16="http://schemas.microsoft.com/office/drawing/2014/main" id="{6BF7F208-E40F-402D-BAC3-B7E9404B3D4B}"/>
               </a:ext>
             </a:extLst>
           </p:cNvPr>
@@ -13730,7 +13730,7 @@
           <p:cNvPr id="6" name="Govern">
             <a:extLst xmlns:a="http://schemas.openxmlformats.org/drawingml/2006/main">
               <a:ext uri="{FF2B5EF4-FFF2-40B4-BE49-F238E27FC236}">
-                <a16:creationId xmlns:a16="http://schemas.microsoft.com/office/drawing/2014/main" id="{B952FFE7-10BD-4B82-86F8-CAB9BACF1A2F}"/>
+                <a16:creationId xmlns:a16="http://schemas.microsoft.com/office/drawing/2014/main" id="{F5D907F0-9055-4290-902E-E74DDF009AC2}"/>
               </a:ext>
             </a:extLst>
           </p:cNvPr>
@@ -13818,7 +13818,7 @@
           <p:cNvPr id="7" name="Execute">
             <a:extLst xmlns:a="http://schemas.openxmlformats.org/drawingml/2006/main">
               <a:ext uri="{FF2B5EF4-FFF2-40B4-BE49-F238E27FC236}">
-                <a16:creationId xmlns:a16="http://schemas.microsoft.com/office/drawing/2014/main" id="{05E7680F-24FC-4ACC-ACAA-A94B3E82E915}"/>
+                <a16:creationId xmlns:a16="http://schemas.microsoft.com/office/drawing/2014/main" id="{539FF53D-638D-4055-A382-64C44267D639}"/>
               </a:ext>
             </a:extLst>
           </p:cNvPr>
@@ -13906,7 +13906,7 @@
           <p:cNvPr id="8" name="Serve">
             <a:extLst xmlns:a="http://schemas.openxmlformats.org/drawingml/2006/main">
               <a:ext uri="{FF2B5EF4-FFF2-40B4-BE49-F238E27FC236}">
-                <a16:creationId xmlns:a16="http://schemas.microsoft.com/office/drawing/2014/main" id="{12E6B1B6-6E82-4568-BF79-45FACFB9183E}"/>
+                <a16:creationId xmlns:a16="http://schemas.microsoft.com/office/drawing/2014/main" id="{72BA970E-04FF-488D-B769-D235E6B165F7}"/>
               </a:ext>
             </a:extLst>
           </p:cNvPr>
@@ -14070,7 +14070,7 @@
           <p:cNvPr id="12" name="PostgreSQL">
             <a:extLst xmlns:a="http://schemas.openxmlformats.org/drawingml/2006/main">
               <a:ext uri="{FF2B5EF4-FFF2-40B4-BE49-F238E27FC236}">
-                <a16:creationId xmlns:a16="http://schemas.microsoft.com/office/drawing/2014/main" id="{D1285430-1BB4-455F-A683-BBCA41B31EB2}"/>
+                <a16:creationId xmlns:a16="http://schemas.microsoft.com/office/drawing/2014/main" id="{5BDAB4DB-86DB-44A9-A731-716065D0CDAD}"/>
               </a:ext>
             </a:extLst>
           </p:cNvPr>
@@ -14157,7 +14157,7 @@
           <p:cNvPr id="13" name="Artifact storage">
             <a:extLst xmlns:a="http://schemas.openxmlformats.org/drawingml/2006/main">
               <a:ext uri="{FF2B5EF4-FFF2-40B4-BE49-F238E27FC236}">
-                <a16:creationId xmlns:a16="http://schemas.microsoft.com/office/drawing/2014/main" id="{09D60EAF-7608-497F-B9CD-2F04450EF01D}"/>
+                <a16:creationId xmlns:a16="http://schemas.microsoft.com/office/drawing/2014/main" id="{1D5B2EB1-CA12-4418-A6E9-BE816BB7CD4E}"/>
               </a:ext>
             </a:extLst>
           </p:cNvPr>
@@ -14244,7 +14244,7 @@
           <p:cNvPr id="14" name="Neo4j">
             <a:extLst xmlns:a="http://schemas.openxmlformats.org/drawingml/2006/main">
               <a:ext uri="{FF2B5EF4-FFF2-40B4-BE49-F238E27FC236}">
-                <a16:creationId xmlns:a16="http://schemas.microsoft.com/office/drawing/2014/main" id="{EC235D29-735C-4670-92FE-103E5AF7DFCC}"/>
+                <a16:creationId xmlns:a16="http://schemas.microsoft.com/office/drawing/2014/main" id="{ADCE4D0B-505F-4E83-A234-CCB69F48878F}"/>
               </a:ext>
             </a:extLst>
           </p:cNvPr>
@@ -14329,7 +14329,7 @@
     </p:spTree>
     <p:extLst>
       <p:ext uri="{BB962C8B-B14F-4D97-AF65-F5344CB8AC3E}">
-        <p14:creationId xmlns:p14="http://schemas.microsoft.com/office/powerpoint/2010/main" val="707530037"/>
+        <p14:creationId xmlns:p14="http://schemas.microsoft.com/office/powerpoint/2010/main" val="629954823"/>
       </p:ext>
     </p:extLst>
   </p:cSld>
@@ -14360,7 +14360,7 @@
           <p:cNvPr id="18" name="Governed publication routes">
             <a:extLst xmlns:a="http://schemas.openxmlformats.org/drawingml/2006/main">
               <a:ext uri="{FF2B5EF4-FFF2-40B4-BE49-F238E27FC236}">
-                <a16:creationId xmlns:a16="http://schemas.microsoft.com/office/drawing/2014/main" id="{9065D6CD-110F-42C0-B3B6-61767F830CC2}"/>
+                <a16:creationId xmlns:a16="http://schemas.microsoft.com/office/drawing/2014/main" id="{0D7027BF-A486-4683-9055-32BFF805583F}"/>
               </a:ext>
             </a:extLst>
           </p:cNvPr>
@@ -14417,7 +14417,7 @@
           <p:cNvPr id="2" name="CEIM batches and Semantic Bridge mappings use distinct Graph Service c">
             <a:extLst xmlns:a="http://schemas.openxmlformats.org/drawingml/2006/main">
               <a:ext uri="{FF2B5EF4-FFF2-40B4-BE49-F238E27FC236}">
-                <a16:creationId xmlns:a16="http://schemas.microsoft.com/office/drawing/2014/main" id="{3756F2D0-A09A-4F7F-9BD4-1BEF9CDF9572}"/>
+                <a16:creationId xmlns:a16="http://schemas.microsoft.com/office/drawing/2014/main" id="{3BFE1FC9-784F-457A-B667-8BCB2399FF2E}"/>
               </a:ext>
             </a:extLst>
           </p:cNvPr>
@@ -14474,7 +14474,7 @@
           <p:cNvPr id="3" name="DEPO  /  Functional architecture">
             <a:extLst xmlns:a="http://schemas.openxmlformats.org/drawingml/2006/main">
               <a:ext uri="{FF2B5EF4-FFF2-40B4-BE49-F238E27FC236}">
-                <a16:creationId xmlns:a16="http://schemas.microsoft.com/office/drawing/2014/main" id="{B2090A32-9E1E-4035-B224-A3C6B89ED823}"/>
+                <a16:creationId xmlns:a16="http://schemas.microsoft.com/office/drawing/2014/main" id="{9ADE3E56-7AC5-4A12-BFA1-B5348E93AFE6}"/>
               </a:ext>
             </a:extLst>
           </p:cNvPr>
@@ -14531,7 +14531,7 @@
           <p:cNvPr id="4" name="04">
             <a:extLst xmlns:a="http://schemas.openxmlformats.org/drawingml/2006/main">
               <a:ext uri="{FF2B5EF4-FFF2-40B4-BE49-F238E27FC236}">
-                <a16:creationId xmlns:a16="http://schemas.microsoft.com/office/drawing/2014/main" id="{73356388-B34D-47DC-89BF-9F180549F240}"/>
+                <a16:creationId xmlns:a16="http://schemas.microsoft.com/office/drawing/2014/main" id="{E0FE14A8-A243-43EF-B070-A96C1CC9E3E1}"/>
               </a:ext>
             </a:extLst>
           </p:cNvPr>
@@ -14588,7 +14588,7 @@
           <p:cNvPr id="5" name="Semantic batch">
             <a:extLst xmlns:a="http://schemas.openxmlformats.org/drawingml/2006/main">
               <a:ext uri="{FF2B5EF4-FFF2-40B4-BE49-F238E27FC236}">
-                <a16:creationId xmlns:a16="http://schemas.microsoft.com/office/drawing/2014/main" id="{16D89CA1-9801-4E4B-B52B-756246E3E1CD}"/>
+                <a16:creationId xmlns:a16="http://schemas.microsoft.com/office/drawing/2014/main" id="{55173C22-3C51-4ED3-9162-A07F8F2C146B}"/>
               </a:ext>
             </a:extLst>
           </p:cNvPr>
@@ -14645,7 +14645,7 @@
           <p:cNvPr id="6" name="Accepted partition">
             <a:extLst xmlns:a="http://schemas.openxmlformats.org/drawingml/2006/main">
               <a:ext uri="{FF2B5EF4-FFF2-40B4-BE49-F238E27FC236}">
-                <a16:creationId xmlns:a16="http://schemas.microsoft.com/office/drawing/2014/main" id="{CD8A8FE8-2807-478E-8A7D-A0553932E19D}"/>
+                <a16:creationId xmlns:a16="http://schemas.microsoft.com/office/drawing/2014/main" id="{5E3B251E-C015-4B18-9973-858099EC4BA7}"/>
               </a:ext>
             </a:extLst>
           </p:cNvPr>
@@ -14732,7 +14732,7 @@
           <p:cNvPr id="7" name="CEIM approval">
             <a:extLst xmlns:a="http://schemas.openxmlformats.org/drawingml/2006/main">
               <a:ext uri="{FF2B5EF4-FFF2-40B4-BE49-F238E27FC236}">
-                <a16:creationId xmlns:a16="http://schemas.microsoft.com/office/drawing/2014/main" id="{3FE714F6-0336-47F7-A941-6E69D83B944D}"/>
+                <a16:creationId xmlns:a16="http://schemas.microsoft.com/office/drawing/2014/main" id="{6C5891E8-6457-444F-AFA6-106D4222D351}"/>
               </a:ext>
             </a:extLst>
           </p:cNvPr>
@@ -14819,7 +14819,7 @@
           <p:cNvPr id="8" name="Graph publication">
             <a:extLst xmlns:a="http://schemas.openxmlformats.org/drawingml/2006/main">
               <a:ext uri="{FF2B5EF4-FFF2-40B4-BE49-F238E27FC236}">
-                <a16:creationId xmlns:a16="http://schemas.microsoft.com/office/drawing/2014/main" id="{BED0E674-1415-4196-B7A8-E8BA2BD212D5}"/>
+                <a16:creationId xmlns:a16="http://schemas.microsoft.com/office/drawing/2014/main" id="{E3EF2C39-E21A-4178-A922-5B2EDC34BCFE}"/>
               </a:ext>
             </a:extLst>
           </p:cNvPr>
@@ -14956,7 +14956,7 @@
           <p:cNvPr id="11" name="Semantic Bridge">
             <a:extLst xmlns:a="http://schemas.openxmlformats.org/drawingml/2006/main">
               <a:ext uri="{FF2B5EF4-FFF2-40B4-BE49-F238E27FC236}">
-                <a16:creationId xmlns:a16="http://schemas.microsoft.com/office/drawing/2014/main" id="{B3E005F3-C166-4E2A-A719-F64721461B07}"/>
+                <a16:creationId xmlns:a16="http://schemas.microsoft.com/office/drawing/2014/main" id="{93023943-94C5-4E78-9743-080496DE0768}"/>
               </a:ext>
             </a:extLst>
           </p:cNvPr>
@@ -15013,7 +15013,7 @@
           <p:cNvPr id="12" name="Saved preview">
             <a:extLst xmlns:a="http://schemas.openxmlformats.org/drawingml/2006/main">
               <a:ext uri="{FF2B5EF4-FFF2-40B4-BE49-F238E27FC236}">
-                <a16:creationId xmlns:a16="http://schemas.microsoft.com/office/drawing/2014/main" id="{657108AD-23A2-488A-B732-3A460C796A25}"/>
+                <a16:creationId xmlns:a16="http://schemas.microsoft.com/office/drawing/2014/main" id="{F799516B-E101-400B-92B7-6808484DBDC7}"/>
               </a:ext>
             </a:extLst>
           </p:cNvPr>
@@ -15100,7 +15100,7 @@
           <p:cNvPr id="13" name="Agentic approval">
             <a:extLst xmlns:a="http://schemas.openxmlformats.org/drawingml/2006/main">
               <a:ext uri="{FF2B5EF4-FFF2-40B4-BE49-F238E27FC236}">
-                <a16:creationId xmlns:a16="http://schemas.microsoft.com/office/drawing/2014/main" id="{52BBF7CC-DAAB-4738-AE1C-7E0F87824E25}"/>
+                <a16:creationId xmlns:a16="http://schemas.microsoft.com/office/drawing/2014/main" id="{720E2EA4-52DE-4056-A4A7-AE28FE2A2537}"/>
               </a:ext>
             </a:extLst>
           </p:cNvPr>
@@ -15187,7 +15187,7 @@
           <p:cNvPr id="14" name="Graph Bridge API">
             <a:extLst xmlns:a="http://schemas.openxmlformats.org/drawingml/2006/main">
               <a:ext uri="{FF2B5EF4-FFF2-40B4-BE49-F238E27FC236}">
-                <a16:creationId xmlns:a16="http://schemas.microsoft.com/office/drawing/2014/main" id="{E8BC861D-EC20-433B-9E5C-E805E3E2AC67}"/>
+                <a16:creationId xmlns:a16="http://schemas.microsoft.com/office/drawing/2014/main" id="{5759665C-5557-4EA5-A4D6-6CEBDE7BD2BA}"/>
               </a:ext>
             </a:extLst>
           </p:cNvPr>
@@ -15324,7 +15324,7 @@
           <p:cNvPr id="17" name="The browser never receives the private Graph publication credential.">
             <a:extLst xmlns:a="http://schemas.openxmlformats.org/drawingml/2006/main">
               <a:ext uri="{FF2B5EF4-FFF2-40B4-BE49-F238E27FC236}">
-                <a16:creationId xmlns:a16="http://schemas.microsoft.com/office/drawing/2014/main" id="{B21568FC-3F98-486A-ADB7-376EEF11C589}"/>
+                <a16:creationId xmlns:a16="http://schemas.microsoft.com/office/drawing/2014/main" id="{C6D43487-FCF1-4386-8B1E-E63F7C1C4CA0}"/>
               </a:ext>
             </a:extLst>
           </p:cNvPr>
@@ -15379,7 +15379,7 @@
     </p:spTree>
     <p:extLst>
       <p:ext uri="{BB962C8B-B14F-4D97-AF65-F5344CB8AC3E}">
-        <p14:creationId xmlns:p14="http://schemas.microsoft.com/office/powerpoint/2010/main" val="1613428034"/>
+        <p14:creationId xmlns:p14="http://schemas.microsoft.com/office/powerpoint/2010/main" val="1550356793"/>
       </p:ext>
     </p:extLst>
   </p:cSld>
@@ -15410,7 +15410,7 @@
           <p:cNvPr id="18" name="Semantic Bridge review and recovery">
             <a:extLst xmlns:a="http://schemas.openxmlformats.org/drawingml/2006/main">
               <a:ext uri="{FF2B5EF4-FFF2-40B4-BE49-F238E27FC236}">
-                <a16:creationId xmlns:a16="http://schemas.microsoft.com/office/drawing/2014/main" id="{17F91537-7BFF-46F7-AC44-D4729CE7FE6E}"/>
+                <a16:creationId xmlns:a16="http://schemas.microsoft.com/office/drawing/2014/main" id="{8C68DFCF-5765-4CFB-92B6-F77BC9B62999}"/>
               </a:ext>
             </a:extLst>
           </p:cNvPr>
@@ -15467,7 +15467,7 @@
           <p:cNvPr id="2" name="A saved preview connects a selected import to a selected ontology.">
             <a:extLst xmlns:a="http://schemas.openxmlformats.org/drawingml/2006/main">
               <a:ext uri="{FF2B5EF4-FFF2-40B4-BE49-F238E27FC236}">
-                <a16:creationId xmlns:a16="http://schemas.microsoft.com/office/drawing/2014/main" id="{24ECADDD-FEAE-4E56-8B14-91A9C52118CF}"/>
+                <a16:creationId xmlns:a16="http://schemas.microsoft.com/office/drawing/2014/main" id="{F77F8162-56B1-4C73-8F57-69EB5901F259}"/>
               </a:ext>
             </a:extLst>
           </p:cNvPr>
@@ -15524,7 +15524,7 @@
           <p:cNvPr id="3" name="DEPO  /  Functional architecture">
             <a:extLst xmlns:a="http://schemas.openxmlformats.org/drawingml/2006/main">
               <a:ext uri="{FF2B5EF4-FFF2-40B4-BE49-F238E27FC236}">
-                <a16:creationId xmlns:a16="http://schemas.microsoft.com/office/drawing/2014/main" id="{87294871-CA73-4713-8220-CE9ED49BE69C}"/>
+                <a16:creationId xmlns:a16="http://schemas.microsoft.com/office/drawing/2014/main" id="{EAE8475A-A921-433D-8101-529C11F3C070}"/>
               </a:ext>
             </a:extLst>
           </p:cNvPr>
@@ -15581,7 +15581,7 @@
           <p:cNvPr id="4" name="05">
             <a:extLst xmlns:a="http://schemas.openxmlformats.org/drawingml/2006/main">
               <a:ext uri="{FF2B5EF4-FFF2-40B4-BE49-F238E27FC236}">
-                <a16:creationId xmlns:a16="http://schemas.microsoft.com/office/drawing/2014/main" id="{4AE32619-BA18-4424-BD1D-A4DE984ABEE9}"/>
+                <a16:creationId xmlns:a16="http://schemas.microsoft.com/office/drawing/2014/main" id="{796B1BC8-B8B1-48C8-8950-3FA5F23D2B18}"/>
               </a:ext>
             </a:extLst>
           </p:cNvPr>
@@ -15638,7 +15638,7 @@
           <p:cNvPr id="5" name="Preview">
             <a:extLst xmlns:a="http://schemas.openxmlformats.org/drawingml/2006/main">
               <a:ext uri="{FF2B5EF4-FFF2-40B4-BE49-F238E27FC236}">
-                <a16:creationId xmlns:a16="http://schemas.microsoft.com/office/drawing/2014/main" id="{2A2845D2-84BF-48A5-9127-A0FA0720A0EC}"/>
+                <a16:creationId xmlns:a16="http://schemas.microsoft.com/office/drawing/2014/main" id="{30E7DE05-355E-4851-9320-53E7286B655A}"/>
               </a:ext>
             </a:extLst>
           </p:cNvPr>
@@ -15725,7 +15725,7 @@
           <p:cNvPr id="6" name="Review">
             <a:extLst xmlns:a="http://schemas.openxmlformats.org/drawingml/2006/main">
               <a:ext uri="{FF2B5EF4-FFF2-40B4-BE49-F238E27FC236}">
-                <a16:creationId xmlns:a16="http://schemas.microsoft.com/office/drawing/2014/main" id="{116020F7-9893-4EA2-B8E2-787CAF0060BD}"/>
+                <a16:creationId xmlns:a16="http://schemas.microsoft.com/office/drawing/2014/main" id="{07214FCC-8DEA-47B1-B455-5641483D6C8B}"/>
               </a:ext>
             </a:extLst>
           </p:cNvPr>
@@ -15812,7 +15812,7 @@
           <p:cNvPr id="7" name="Approve">
             <a:extLst xmlns:a="http://schemas.openxmlformats.org/drawingml/2006/main">
               <a:ext uri="{FF2B5EF4-FFF2-40B4-BE49-F238E27FC236}">
-                <a16:creationId xmlns:a16="http://schemas.microsoft.com/office/drawing/2014/main" id="{497075E9-4EFA-48E4-86FB-80E789FDB89C}"/>
+                <a16:creationId xmlns:a16="http://schemas.microsoft.com/office/drawing/2014/main" id="{34C7DB99-25BC-4906-AD7D-8CE7B3BD91C6}"/>
               </a:ext>
             </a:extLst>
           </p:cNvPr>
@@ -15899,7 +15899,7 @@
           <p:cNvPr id="8" name="Publish">
             <a:extLst xmlns:a="http://schemas.openxmlformats.org/drawingml/2006/main">
               <a:ext uri="{FF2B5EF4-FFF2-40B4-BE49-F238E27FC236}">
-                <a16:creationId xmlns:a16="http://schemas.microsoft.com/office/drawing/2014/main" id="{FF0C890A-5699-41C8-9165-9864F4270D85}"/>
+                <a16:creationId xmlns:a16="http://schemas.microsoft.com/office/drawing/2014/main" id="{9364F71E-DAE6-4350-A64A-B44F0D424C14}"/>
               </a:ext>
             </a:extLst>
           </p:cNvPr>
@@ -16061,7 +16061,7 @@
           <p:cNvPr id="12" name="Changed source">
             <a:extLst xmlns:a="http://schemas.openxmlformats.org/drawingml/2006/main">
               <a:ext uri="{FF2B5EF4-FFF2-40B4-BE49-F238E27FC236}">
-                <a16:creationId xmlns:a16="http://schemas.microsoft.com/office/drawing/2014/main" id="{50D605D5-1688-4B48-A579-1EABA5848932}"/>
+                <a16:creationId xmlns:a16="http://schemas.microsoft.com/office/drawing/2014/main" id="{2A51CF85-FA0F-4C7F-B048-08ED499E6FC8}"/>
               </a:ext>
             </a:extLst>
           </p:cNvPr>
@@ -16118,7 +16118,7 @@
           <p:cNvPr id="13" name="A stale snapshot requires a new preview and review.">
             <a:extLst xmlns:a="http://schemas.openxmlformats.org/drawingml/2006/main">
               <a:ext uri="{FF2B5EF4-FFF2-40B4-BE49-F238E27FC236}">
-                <a16:creationId xmlns:a16="http://schemas.microsoft.com/office/drawing/2014/main" id="{F2B0E9EE-DF29-4ED9-BC88-BE2999925FFD}"/>
+                <a16:creationId xmlns:a16="http://schemas.microsoft.com/office/drawing/2014/main" id="{9BE9B9DC-FED0-4212-8F71-5FDC112D1A52}"/>
               </a:ext>
             </a:extLst>
           </p:cNvPr>
@@ -16175,7 +16175,7 @@
           <p:cNvPr id="14" name="Interrupted response">
             <a:extLst xmlns:a="http://schemas.openxmlformats.org/drawingml/2006/main">
               <a:ext uri="{FF2B5EF4-FFF2-40B4-BE49-F238E27FC236}">
-                <a16:creationId xmlns:a16="http://schemas.microsoft.com/office/drawing/2014/main" id="{3E74E45C-2462-447C-99E2-56017C2EE6B0}"/>
+                <a16:creationId xmlns:a16="http://schemas.microsoft.com/office/drawing/2014/main" id="{9191C3B7-E25F-40DD-993B-F5D5AF794467}"/>
               </a:ext>
             </a:extLst>
           </p:cNvPr>
@@ -16232,7 +16232,7 @@
           <p:cNvPr id="15" name="Retry the same selection. Reconcile the durable graph receipt.">
             <a:extLst xmlns:a="http://schemas.openxmlformats.org/drawingml/2006/main">
               <a:ext uri="{FF2B5EF4-FFF2-40B4-BE49-F238E27FC236}">
-                <a16:creationId xmlns:a16="http://schemas.microsoft.com/office/drawing/2014/main" id="{9A797908-DFC3-4C40-95BD-F899D4B62669}"/>
+                <a16:creationId xmlns:a16="http://schemas.microsoft.com/office/drawing/2014/main" id="{35388D10-C26B-48AC-A1A9-4286B36695B8}"/>
               </a:ext>
             </a:extLst>
           </p:cNvPr>
@@ -16289,7 +16289,7 @@
           <p:cNvPr id="16" name="UI evidence">
             <a:extLst xmlns:a="http://schemas.openxmlformats.org/drawingml/2006/main">
               <a:ext uri="{FF2B5EF4-FFF2-40B4-BE49-F238E27FC236}">
-                <a16:creationId xmlns:a16="http://schemas.microsoft.com/office/drawing/2014/main" id="{29C07D61-B106-4C24-9CAF-93322EA114F6}"/>
+                <a16:creationId xmlns:a16="http://schemas.microsoft.com/office/drawing/2014/main" id="{755A7002-4A1B-41D0-858A-E16CB4A3146F}"/>
               </a:ext>
             </a:extLst>
           </p:cNvPr>
@@ -16346,7 +16346,7 @@
           <p:cNvPr id="17" name="Load a saved preview, refresh status and download the job artifact.">
             <a:extLst xmlns:a="http://schemas.openxmlformats.org/drawingml/2006/main">
               <a:ext uri="{FF2B5EF4-FFF2-40B4-BE49-F238E27FC236}">
-                <a16:creationId xmlns:a16="http://schemas.microsoft.com/office/drawing/2014/main" id="{87B779D8-5A50-4719-A77D-4EF553A89392}"/>
+                <a16:creationId xmlns:a16="http://schemas.microsoft.com/office/drawing/2014/main" id="{629D8BB3-85DB-44D6-9DE7-8039755CD2C0}"/>
               </a:ext>
             </a:extLst>
           </p:cNvPr>
@@ -16401,7 +16401,7 @@
     </p:spTree>
     <p:extLst>
       <p:ext uri="{BB962C8B-B14F-4D97-AF65-F5344CB8AC3E}">
-        <p14:creationId xmlns:p14="http://schemas.microsoft.com/office/powerpoint/2010/main" val="730355650"/>
+        <p14:creationId xmlns:p14="http://schemas.microsoft.com/office/powerpoint/2010/main" val="61538804"/>
       </p:ext>
     </p:extLst>
   </p:cSld>
@@ -16432,7 +16432,7 @@
           <p:cNvPr id="16" name="Data-job execution and checkpoint control">
             <a:extLst xmlns:a="http://schemas.openxmlformats.org/drawingml/2006/main">
               <a:ext uri="{FF2B5EF4-FFF2-40B4-BE49-F238E27FC236}">
-                <a16:creationId xmlns:a16="http://schemas.microsoft.com/office/drawing/2014/main" id="{C27C8D10-FA91-4562-B32A-5018706A1C1D}"/>
+                <a16:creationId xmlns:a16="http://schemas.microsoft.com/office/drawing/2014/main" id="{0CE78E93-832E-4F95-8252-6816228A2775}"/>
               </a:ext>
             </a:extLst>
           </p:cNvPr>
@@ -16489,7 +16489,7 @@
           <p:cNvPr id="2" name="A successful compute run and a successful graph publication are separa">
             <a:extLst xmlns:a="http://schemas.openxmlformats.org/drawingml/2006/main">
               <a:ext uri="{FF2B5EF4-FFF2-40B4-BE49-F238E27FC236}">
-                <a16:creationId xmlns:a16="http://schemas.microsoft.com/office/drawing/2014/main" id="{0A8F8D01-AD70-427C-92F8-AD4358A763B4}"/>
+                <a16:creationId xmlns:a16="http://schemas.microsoft.com/office/drawing/2014/main" id="{CD04BC62-C3E4-4467-A5AF-85CCA45C969C}"/>
               </a:ext>
             </a:extLst>
           </p:cNvPr>
@@ -16546,7 +16546,7 @@
           <p:cNvPr id="3" name="DEPO  /  Functional architecture">
             <a:extLst xmlns:a="http://schemas.openxmlformats.org/drawingml/2006/main">
               <a:ext uri="{FF2B5EF4-FFF2-40B4-BE49-F238E27FC236}">
-                <a16:creationId xmlns:a16="http://schemas.microsoft.com/office/drawing/2014/main" id="{71B56509-D3AC-46A3-BE5B-A215447F6E20}"/>
+                <a16:creationId xmlns:a16="http://schemas.microsoft.com/office/drawing/2014/main" id="{889B2718-F949-4A01-B6F2-B6885E81FBDB}"/>
               </a:ext>
             </a:extLst>
           </p:cNvPr>
@@ -16603,7 +16603,7 @@
           <p:cNvPr id="4" name="06">
             <a:extLst xmlns:a="http://schemas.openxmlformats.org/drawingml/2006/main">
               <a:ext uri="{FF2B5EF4-FFF2-40B4-BE49-F238E27FC236}">
-                <a16:creationId xmlns:a16="http://schemas.microsoft.com/office/drawing/2014/main" id="{AC296FE4-48CD-42D1-9A18-73B8EBBDCDAD}"/>
+                <a16:creationId xmlns:a16="http://schemas.microsoft.com/office/drawing/2014/main" id="{B8F3888F-A3B5-4BA9-8864-917D0B1E26A9}"/>
               </a:ext>
             </a:extLst>
           </p:cNvPr>
@@ -16660,7 +16660,7 @@
           <p:cNvPr id="5" name="Job definition">
             <a:extLst xmlns:a="http://schemas.openxmlformats.org/drawingml/2006/main">
               <a:ext uri="{FF2B5EF4-FFF2-40B4-BE49-F238E27FC236}">
-                <a16:creationId xmlns:a16="http://schemas.microsoft.com/office/drawing/2014/main" id="{9E462AA9-974C-481A-A420-20DBDB70BB31}"/>
+                <a16:creationId xmlns:a16="http://schemas.microsoft.com/office/drawing/2014/main" id="{B5121DBF-A77D-4B64-AA83-BAE6B1D06A69}"/>
               </a:ext>
             </a:extLst>
           </p:cNvPr>
@@ -16747,7 +16747,7 @@
           <p:cNvPr id="6" name="Run">
             <a:extLst xmlns:a="http://schemas.openxmlformats.org/drawingml/2006/main">
               <a:ext uri="{FF2B5EF4-FFF2-40B4-BE49-F238E27FC236}">
-                <a16:creationId xmlns:a16="http://schemas.microsoft.com/office/drawing/2014/main" id="{BCDCE9F8-368B-45DB-93E6-D4FFBF431AD9}"/>
+                <a16:creationId xmlns:a16="http://schemas.microsoft.com/office/drawing/2014/main" id="{D8378A50-808E-4FD8-9167-6ACEF9763F1B}"/>
               </a:ext>
             </a:extLst>
           </p:cNvPr>
@@ -16834,7 +16834,7 @@
           <p:cNvPr id="7" name="Quality result">
             <a:extLst xmlns:a="http://schemas.openxmlformats.org/drawingml/2006/main">
               <a:ext uri="{FF2B5EF4-FFF2-40B4-BE49-F238E27FC236}">
-                <a16:creationId xmlns:a16="http://schemas.microsoft.com/office/drawing/2014/main" id="{233C7137-1B99-447A-82B0-5C93FBCACF37}"/>
+                <a16:creationId xmlns:a16="http://schemas.microsoft.com/office/drawing/2014/main" id="{AB3FFE28-D0F7-4090-BDC2-05756529DB6E}"/>
               </a:ext>
             </a:extLst>
           </p:cNvPr>
@@ -16921,7 +16921,7 @@
           <p:cNvPr id="8" name="Publication">
             <a:extLst xmlns:a="http://schemas.openxmlformats.org/drawingml/2006/main">
               <a:ext uri="{FF2B5EF4-FFF2-40B4-BE49-F238E27FC236}">
-                <a16:creationId xmlns:a16="http://schemas.microsoft.com/office/drawing/2014/main" id="{C0CB4EA6-99C1-44E5-A2B9-E24E022502B3}"/>
+                <a16:creationId xmlns:a16="http://schemas.microsoft.com/office/drawing/2014/main" id="{DA101E9A-6B58-4984-9371-B088476AFCB1}"/>
               </a:ext>
             </a:extLst>
           </p:cNvPr>
@@ -17083,7 +17083,7 @@
           <p:cNvPr id="12" name="Accepted output">
             <a:extLst xmlns:a="http://schemas.openxmlformats.org/drawingml/2006/main">
               <a:ext uri="{FF2B5EF4-FFF2-40B4-BE49-F238E27FC236}">
-                <a16:creationId xmlns:a16="http://schemas.microsoft.com/office/drawing/2014/main" id="{E435E73C-76C8-40FB-8AFD-C66F72A6EDC1}"/>
+                <a16:creationId xmlns:a16="http://schemas.microsoft.com/office/drawing/2014/main" id="{F1F9B67D-9D35-4262-9432-CFF92E1E3113}"/>
               </a:ext>
             </a:extLst>
           </p:cNvPr>
@@ -17170,7 +17170,7 @@
           <p:cNvPr id="13" name="Confirmed graph receipt">
             <a:extLst xmlns:a="http://schemas.openxmlformats.org/drawingml/2006/main">
               <a:ext uri="{FF2B5EF4-FFF2-40B4-BE49-F238E27FC236}">
-                <a16:creationId xmlns:a16="http://schemas.microsoft.com/office/drawing/2014/main" id="{51596705-77F1-4036-A245-C8D5FFA128A2}"/>
+                <a16:creationId xmlns:a16="http://schemas.microsoft.com/office/drawing/2014/main" id="{C170521F-50C4-4B93-9699-741A834E8815}"/>
               </a:ext>
             </a:extLst>
           </p:cNvPr>
@@ -17282,7 +17282,7 @@
           <p:cNvPr id="15" name="Failed quality or uncertain publication keeps the checkpoint pending f">
             <a:extLst xmlns:a="http://schemas.openxmlformats.org/drawingml/2006/main">
               <a:ext uri="{FF2B5EF4-FFF2-40B4-BE49-F238E27FC236}">
-                <a16:creationId xmlns:a16="http://schemas.microsoft.com/office/drawing/2014/main" id="{F2D01D8D-6A75-4FA6-8FD0-243789161792}"/>
+                <a16:creationId xmlns:a16="http://schemas.microsoft.com/office/drawing/2014/main" id="{EB95A594-6284-485F-B028-A90B19EABA75}"/>
               </a:ext>
             </a:extLst>
           </p:cNvPr>
@@ -17337,7 +17337,7 @@
     </p:spTree>
     <p:extLst>
       <p:ext uri="{BB962C8B-B14F-4D97-AF65-F5344CB8AC3E}">
-        <p14:creationId xmlns:p14="http://schemas.microsoft.com/office/powerpoint/2010/main" val="1957770877"/>
+        <p14:creationId xmlns:p14="http://schemas.microsoft.com/office/powerpoint/2010/main" val="115243954"/>
       </p:ext>
     </p:extLst>
   </p:cSld>
@@ -17368,7 +17368,7 @@
           <p:cNvPr id="7" name="Semantic and document job contracts">
             <a:extLst xmlns:a="http://schemas.openxmlformats.org/drawingml/2006/main">
               <a:ext uri="{FF2B5EF4-FFF2-40B4-BE49-F238E27FC236}">
-                <a16:creationId xmlns:a16="http://schemas.microsoft.com/office/drawing/2014/main" id="{53C82E91-0FFE-4A8F-A3CE-06451940F4D3}"/>
+                <a16:creationId xmlns:a16="http://schemas.microsoft.com/office/drawing/2014/main" id="{0B971D63-682E-415A-A787-1E069A18BECF}"/>
               </a:ext>
             </a:extLst>
           </p:cNvPr>
@@ -17425,7 +17425,7 @@
           <p:cNvPr id="2" name="Registered handlers define explicit input and output contracts.">
             <a:extLst xmlns:a="http://schemas.openxmlformats.org/drawingml/2006/main">
               <a:ext uri="{FF2B5EF4-FFF2-40B4-BE49-F238E27FC236}">
-                <a16:creationId xmlns:a16="http://schemas.microsoft.com/office/drawing/2014/main" id="{5A546287-244C-42B9-9E2B-4FE485662220}"/>
+                <a16:creationId xmlns:a16="http://schemas.microsoft.com/office/drawing/2014/main" id="{4C1D60CC-FAF3-4F9F-95B6-3D539D0288C9}"/>
               </a:ext>
             </a:extLst>
           </p:cNvPr>
@@ -17482,7 +17482,7 @@
           <p:cNvPr id="3" name="DEPO  /  Functional architecture">
             <a:extLst xmlns:a="http://schemas.openxmlformats.org/drawingml/2006/main">
               <a:ext uri="{FF2B5EF4-FFF2-40B4-BE49-F238E27FC236}">
-                <a16:creationId xmlns:a16="http://schemas.microsoft.com/office/drawing/2014/main" id="{764E139E-545B-4FD2-B59F-6752394297BE}"/>
+                <a16:creationId xmlns:a16="http://schemas.microsoft.com/office/drawing/2014/main" id="{D7CBB513-88C1-4481-B7FA-BEA503BE9020}"/>
               </a:ext>
             </a:extLst>
           </p:cNvPr>
@@ -17539,7 +17539,7 @@
           <p:cNvPr id="4" name="07">
             <a:extLst xmlns:a="http://schemas.openxmlformats.org/drawingml/2006/main">
               <a:ext uri="{FF2B5EF4-FFF2-40B4-BE49-F238E27FC236}">
-                <a16:creationId xmlns:a16="http://schemas.microsoft.com/office/drawing/2014/main" id="{7A73AC6D-38E5-4296-BCC9-8C8CB9A164B1}"/>
+                <a16:creationId xmlns:a16="http://schemas.microsoft.com/office/drawing/2014/main" id="{E68FEDF3-AE34-4171-A451-52172847A9FA}"/>
               </a:ext>
             </a:extLst>
           </p:cNvPr>
@@ -18063,7 +18063,7 @@
           <p:cNvPr id="6" name="Configured runs retain the input, quality report and output references">
             <a:extLst xmlns:a="http://schemas.openxmlformats.org/drawingml/2006/main">
               <a:ext uri="{FF2B5EF4-FFF2-40B4-BE49-F238E27FC236}">
-                <a16:creationId xmlns:a16="http://schemas.microsoft.com/office/drawing/2014/main" id="{98C6EAB9-CF3D-4BED-A0BE-22D25AC53808}"/>
+                <a16:creationId xmlns:a16="http://schemas.microsoft.com/office/drawing/2014/main" id="{C500EC49-2FDD-4DAD-989C-310CB89C4568}"/>
               </a:ext>
             </a:extLst>
           </p:cNvPr>
@@ -18118,7 +18118,7 @@
     </p:spTree>
     <p:extLst>
       <p:ext uri="{BB962C8B-B14F-4D97-AF65-F5344CB8AC3E}">
-        <p14:creationId xmlns:p14="http://schemas.microsoft.com/office/powerpoint/2010/main" val="1960533078"/>
+        <p14:creationId xmlns:p14="http://schemas.microsoft.com/office/powerpoint/2010/main" val="770472272"/>
       </p:ext>
     </p:extLst>
   </p:cSld>
@@ -18149,7 +18149,7 @@
           <p:cNvPr id="7" name="Quality, schema and RDF job contracts">
             <a:extLst xmlns:a="http://schemas.openxmlformats.org/drawingml/2006/main">
               <a:ext uri="{FF2B5EF4-FFF2-40B4-BE49-F238E27FC236}">
-                <a16:creationId xmlns:a16="http://schemas.microsoft.com/office/drawing/2014/main" id="{6E99D3EE-3E47-4373-955F-B438A56D4D21}"/>
+                <a16:creationId xmlns:a16="http://schemas.microsoft.com/office/drawing/2014/main" id="{D403EB12-0630-49D5-9BAF-2DD436BAACD0}"/>
               </a:ext>
             </a:extLst>
           </p:cNvPr>
@@ -18206,7 +18206,7 @@
           <p:cNvPr id="2" name="These outputs support analysis and preparation before a separate publi">
             <a:extLst xmlns:a="http://schemas.openxmlformats.org/drawingml/2006/main">
               <a:ext uri="{FF2B5EF4-FFF2-40B4-BE49-F238E27FC236}">
-                <a16:creationId xmlns:a16="http://schemas.microsoft.com/office/drawing/2014/main" id="{13C63117-D60C-4F14-9484-2CE72E197751}"/>
+                <a16:creationId xmlns:a16="http://schemas.microsoft.com/office/drawing/2014/main" id="{AA82F645-E759-49DA-9D77-6948A06F1617}"/>
               </a:ext>
             </a:extLst>
           </p:cNvPr>
@@ -18263,7 +18263,7 @@
           <p:cNvPr id="3" name="DEPO  /  Functional architecture">
             <a:extLst xmlns:a="http://schemas.openxmlformats.org/drawingml/2006/main">
               <a:ext uri="{FF2B5EF4-FFF2-40B4-BE49-F238E27FC236}">
-                <a16:creationId xmlns:a16="http://schemas.microsoft.com/office/drawing/2014/main" id="{D40C88F2-624F-43CA-B2B1-1E5D08F68B6C}"/>
+                <a16:creationId xmlns:a16="http://schemas.microsoft.com/office/drawing/2014/main" id="{FF4675AC-EDF7-4A1C-9938-2C5531B8699F}"/>
               </a:ext>
             </a:extLst>
           </p:cNvPr>
@@ -18320,7 +18320,7 @@
           <p:cNvPr id="4" name="08">
             <a:extLst xmlns:a="http://schemas.openxmlformats.org/drawingml/2006/main">
               <a:ext uri="{FF2B5EF4-FFF2-40B4-BE49-F238E27FC236}">
-                <a16:creationId xmlns:a16="http://schemas.microsoft.com/office/drawing/2014/main" id="{2510F5F4-9B26-49CE-A9D5-D3FFE8F38CE8}"/>
+                <a16:creationId xmlns:a16="http://schemas.microsoft.com/office/drawing/2014/main" id="{1CACFED5-6C64-4292-9FBE-7DBF85AD41E5}"/>
               </a:ext>
             </a:extLst>
           </p:cNvPr>
@@ -18844,7 +18844,7 @@
           <p:cNvPr id="6" name="RDF profiling and deduplication currently accept N-Triples artifacts.">
             <a:extLst xmlns:a="http://schemas.openxmlformats.org/drawingml/2006/main">
               <a:ext uri="{FF2B5EF4-FFF2-40B4-BE49-F238E27FC236}">
-                <a16:creationId xmlns:a16="http://schemas.microsoft.com/office/drawing/2014/main" id="{1A38F92A-2F68-4105-8DF7-803CE52D44FA}"/>
+                <a16:creationId xmlns:a16="http://schemas.microsoft.com/office/drawing/2014/main" id="{F2A3A672-A113-44DF-BEA4-44C637EC8B7E}"/>
               </a:ext>
             </a:extLst>
           </p:cNvPr>
@@ -18899,7 +18899,7 @@
     </p:spTree>
     <p:extLst>
       <p:ext uri="{BB962C8B-B14F-4D97-AF65-F5344CB8AC3E}">
-        <p14:creationId xmlns:p14="http://schemas.microsoft.com/office/powerpoint/2010/main" val="1589691068"/>
+        <p14:creationId xmlns:p14="http://schemas.microsoft.com/office/powerpoint/2010/main" val="822747444"/>
       </p:ext>
     </p:extLst>
   </p:cSld>
@@ -18930,7 +18930,7 @@
           <p:cNvPr id="18" name="Batch and event reconciliation">
             <a:extLst xmlns:a="http://schemas.openxmlformats.org/drawingml/2006/main">
               <a:ext uri="{FF2B5EF4-FFF2-40B4-BE49-F238E27FC236}">
-                <a16:creationId xmlns:a16="http://schemas.microsoft.com/office/drawing/2014/main" id="{E6CC4758-1FA4-47D9-8542-A90CE9969A2F}"/>
+                <a16:creationId xmlns:a16="http://schemas.microsoft.com/office/drawing/2014/main" id="{4AA09911-5041-42E7-8C36-8C6355082E2A}"/>
               </a:ext>
             </a:extLst>
           </p:cNvPr>
@@ -18987,7 +18987,7 @@
           <p:cNvPr id="2" name="Both paths retain evidence and use CEIM for semantic batch publication">
             <a:extLst xmlns:a="http://schemas.openxmlformats.org/drawingml/2006/main">
               <a:ext uri="{FF2B5EF4-FFF2-40B4-BE49-F238E27FC236}">
-                <a16:creationId xmlns:a16="http://schemas.microsoft.com/office/drawing/2014/main" id="{7872308E-5172-4169-891F-26F6E8EFEB04}"/>
+                <a16:creationId xmlns:a16="http://schemas.microsoft.com/office/drawing/2014/main" id="{A68C5C34-B806-42DB-AB55-E621B281C026}"/>
               </a:ext>
             </a:extLst>
           </p:cNvPr>
@@ -19044,7 +19044,7 @@
           <p:cNvPr id="3" name="DEPO  /  Functional architecture">
             <a:extLst xmlns:a="http://schemas.openxmlformats.org/drawingml/2006/main">
               <a:ext uri="{FF2B5EF4-FFF2-40B4-BE49-F238E27FC236}">
-                <a16:creationId xmlns:a16="http://schemas.microsoft.com/office/drawing/2014/main" id="{D6CACB5A-5660-44BC-988A-1FD62203399A}"/>
+                <a16:creationId xmlns:a16="http://schemas.microsoft.com/office/drawing/2014/main" id="{0071BAB0-6EBD-4A33-BAA2-BB2AF2350B93}"/>
               </a:ext>
             </a:extLst>
           </p:cNvPr>
@@ -19101,7 +19101,7 @@
           <p:cNvPr id="4" name="09">
             <a:extLst xmlns:a="http://schemas.openxmlformats.org/drawingml/2006/main">
               <a:ext uri="{FF2B5EF4-FFF2-40B4-BE49-F238E27FC236}">
-                <a16:creationId xmlns:a16="http://schemas.microsoft.com/office/drawing/2014/main" id="{3D0D837B-8EAF-4C23-9959-3D42DE6B41B3}"/>
+                <a16:creationId xmlns:a16="http://schemas.microsoft.com/office/drawing/2014/main" id="{B6EBAAE7-7DAD-4FD9-BE7D-E267C8369962}"/>
               </a:ext>
             </a:extLst>
           </p:cNvPr>
@@ -19158,7 +19158,7 @@
           <p:cNvPr id="5" name="Batch path">
             <a:extLst xmlns:a="http://schemas.openxmlformats.org/drawingml/2006/main">
               <a:ext uri="{FF2B5EF4-FFF2-40B4-BE49-F238E27FC236}">
-                <a16:creationId xmlns:a16="http://schemas.microsoft.com/office/drawing/2014/main" id="{86D8900F-D977-463C-8A03-1954FC8AEB97}"/>
+                <a16:creationId xmlns:a16="http://schemas.microsoft.com/office/drawing/2014/main" id="{86DD76F5-908C-4F4C-A363-B6B143DE1A37}"/>
               </a:ext>
             </a:extLst>
           </p:cNvPr>
@@ -19215,7 +19215,7 @@
           <p:cNvPr id="6" name="Retained artifact">
             <a:extLst xmlns:a="http://schemas.openxmlformats.org/drawingml/2006/main">
               <a:ext uri="{FF2B5EF4-FFF2-40B4-BE49-F238E27FC236}">
-                <a16:creationId xmlns:a16="http://schemas.microsoft.com/office/drawing/2014/main" id="{9E4312FD-C1DE-4E14-A7FD-E5010459E62E}"/>
+                <a16:creationId xmlns:a16="http://schemas.microsoft.com/office/drawing/2014/main" id="{B34BB0CE-0EBE-4C93-BDAA-D178BD9D0A4D}"/>
               </a:ext>
             </a:extLst>
           </p:cNvPr>
@@ -19302,7 +19302,7 @@
           <p:cNvPr id="7" name="Approved data job">
             <a:extLst xmlns:a="http://schemas.openxmlformats.org/drawingml/2006/main">
               <a:ext uri="{FF2B5EF4-FFF2-40B4-BE49-F238E27FC236}">
-                <a16:creationId xmlns:a16="http://schemas.microsoft.com/office/drawing/2014/main" id="{0CE6EC42-AF7F-4AA6-B5C4-44B51BF0AADE}"/>
+                <a16:creationId xmlns:a16="http://schemas.microsoft.com/office/drawing/2014/main" id="{DCE773CB-6702-4FCA-882D-0CFDD61C8F6B}"/>
               </a:ext>
             </a:extLst>
           </p:cNvPr>
@@ -19389,7 +19389,7 @@
           <p:cNvPr id="8" name="Accepted partition">
             <a:extLst xmlns:a="http://schemas.openxmlformats.org/drawingml/2006/main">
               <a:ext uri="{FF2B5EF4-FFF2-40B4-BE49-F238E27FC236}">
-                <a16:creationId xmlns:a16="http://schemas.microsoft.com/office/drawing/2014/main" id="{F98D78CD-90B5-456F-B3BA-D2C13E52BFA6}"/>
+                <a16:creationId xmlns:a16="http://schemas.microsoft.com/office/drawing/2014/main" id="{739F9A13-34A3-4358-A4AC-46A97016FA4B}"/>
               </a:ext>
             </a:extLst>
           </p:cNvPr>
@@ -19526,7 +19526,7 @@
           <p:cNvPr id="11" name="Event path">
             <a:extLst xmlns:a="http://schemas.openxmlformats.org/drawingml/2006/main">
               <a:ext uri="{FF2B5EF4-FFF2-40B4-BE49-F238E27FC236}">
-                <a16:creationId xmlns:a16="http://schemas.microsoft.com/office/drawing/2014/main" id="{B1FB512A-A496-46D8-82BA-6C3C032AC463}"/>
+                <a16:creationId xmlns:a16="http://schemas.microsoft.com/office/drawing/2014/main" id="{5B94B716-4576-484A-A27F-B2F56001F320}"/>
               </a:ext>
             </a:extLst>
           </p:cNvPr>
@@ -19583,7 +19583,7 @@
           <p:cNvPr id="12" name="Approved source">
             <a:extLst xmlns:a="http://schemas.openxmlformats.org/drawingml/2006/main">
               <a:ext uri="{FF2B5EF4-FFF2-40B4-BE49-F238E27FC236}">
-                <a16:creationId xmlns:a16="http://schemas.microsoft.com/office/drawing/2014/main" id="{48AC5E2D-D187-4DD8-80C8-F415B6D7DECA}"/>
+                <a16:creationId xmlns:a16="http://schemas.microsoft.com/office/drawing/2014/main" id="{AD1BE657-7015-4DF1-B4AD-32B41C2BE44F}"/>
               </a:ext>
             </a:extLst>
           </p:cNvPr>
@@ -19670,7 +19670,7 @@
           <p:cNvPr id="13" name="Reconciliation">
             <a:extLst xmlns:a="http://schemas.openxmlformats.org/drawingml/2006/main">
               <a:ext uri="{FF2B5EF4-FFF2-40B4-BE49-F238E27FC236}">
-                <a16:creationId xmlns:a16="http://schemas.microsoft.com/office/drawing/2014/main" id="{90201731-E8F5-4135-BF42-74AE2714A403}"/>
+                <a16:creationId xmlns:a16="http://schemas.microsoft.com/office/drawing/2014/main" id="{845A1993-3722-447B-8163-D87064543597}"/>
               </a:ext>
             </a:extLst>
           </p:cNvPr>
@@ -19757,7 +19757,7 @@
           <p:cNvPr id="14" name="Ready partition">
             <a:extLst xmlns:a="http://schemas.openxmlformats.org/drawingml/2006/main">
               <a:ext uri="{FF2B5EF4-FFF2-40B4-BE49-F238E27FC236}">
-                <a16:creationId xmlns:a16="http://schemas.microsoft.com/office/drawing/2014/main" id="{6CD65E69-2964-4B9F-8B2E-CD3B20EF32CD}"/>
+                <a16:creationId xmlns:a16="http://schemas.microsoft.com/office/drawing/2014/main" id="{E843CB73-8FAE-4355-9F05-95252438048C}"/>
               </a:ext>
             </a:extLst>
           </p:cNvPr>
@@ -19894,7 +19894,7 @@
           <p:cNvPr id="17" name="Customer CDC/message-bus adapters and throughput targets still need de">
             <a:extLst xmlns:a="http://schemas.openxmlformats.org/drawingml/2006/main">
               <a:ext uri="{FF2B5EF4-FFF2-40B4-BE49-F238E27FC236}">
-                <a16:creationId xmlns:a16="http://schemas.microsoft.com/office/drawing/2014/main" id="{AF38E168-B06F-4790-99EC-EDF9A1EBC441}"/>
+                <a16:creationId xmlns:a16="http://schemas.microsoft.com/office/drawing/2014/main" id="{886B26BB-1880-4799-8555-326D07B940B8}"/>
               </a:ext>
             </a:extLst>
           </p:cNvPr>
@@ -19949,7 +19949,7 @@
     </p:spTree>
     <p:extLst>
       <p:ext uri="{BB962C8B-B14F-4D97-AF65-F5344CB8AC3E}">
-        <p14:creationId xmlns:p14="http://schemas.microsoft.com/office/powerpoint/2010/main" val="248206665"/>
+        <p14:creationId xmlns:p14="http://schemas.microsoft.com/office/powerpoint/2010/main" val="855868255"/>
       </p:ext>
     </p:extLst>
   </p:cSld>

</xml_diff>